<commit_message>
Pitch: analyst card slide
</commit_message>
<xml_diff>
--- a/docs/pitch/MIRAGE_pitch_5min.pptx
+++ b/docs/pitch/MIRAGE_pitch_5min.pptx
@@ -12,10 +12,9 @@
     <p:sldId id="260" r:id="rId6"/>
     <p:sldId id="261" r:id="rId7"/>
     <p:sldId id="262" r:id="rId8"/>
-    <p:sldId id="263" r:id="rId9"/>
   </p:sldIdLst>
   <p:notesMasterIdLst>
-    <p:notesMasterId r:id="rId10"/>
+    <p:notesMasterId r:id="rId9"/>
   </p:notesMasterIdLst>
   <p:sldSz cx="12192000" cy="6858000"/>
   <p:notesSz cx="6858000" cy="12192000"/>
@@ -773,7 +772,7 @@
           <a:p>
             <a:r>
               <a:rPr lang="en-US" dirty="0"/>
-              <a:t>LEON · [1:25–1:55] On the server, a small guard watches those traps. It has no AI in it at all: the critical second must be predictable. The moment someone opens a trap, the guard moves the real files into a locked vault and puts the fakes at the same paths, with the same names. Nothing is deleted, so it's fully reversible. It also logs every command the intruder types, and if anyone kills the guard, the console raises an alarm. Gaia built the attacker. Let's watch it fail.</a:t>
+              <a:t>LEON · [1:25–1:45] On the server, a small guard watches the traps. No AI inside: the critical second must be predictable. When a trap opens, it moves the real files into a locked vault and puts the fakes in their place. It logs every command, and if anyone kills it, the console raises an alarm. Gaia built the attacker. Let's watch it fail.</a:t>
             </a:r>
             <a:endParaRPr lang="en-US" dirty="0"/>
           </a:p>
@@ -861,7 +860,7 @@
           <a:p>
             <a:r>
               <a:rPr lang="en-US" dirty="0"/>
-              <a:t>GAIA · [1:55–3:15] On the left, an AI agent running on a local model. On the right, the analyst's console for Lumen Health, our fictional clinic chain, with synthetic data only. The agent logs in with a stolen password and starts exploring... it opens our trap. Red alert. The swap is done: the card shows the time measured by the guard, here [read it]. The trap holds a note that only an AI follows. And here it is: the agent registers its objective, extract patient records and billing credentials. Now it downloads the patient file and the API keys. It thinks it won. Here's what it got, and here's the real file, safe in the vault. It tries the stolen key: the beacon fires. We know what was taken and from where. One card: AI agent, high confidence, zero real files lost, every step tagged with MITRE ATT&amp;CK. IF THE AGENT IGNORES THE NOTE: This one was careful. The label falls back on its command rhythm, and the swap protected everything anyway. Replace the two screenshot placeholders with screenshots from a real run.</a:t>
+              <a:t>GAIA · [3:05–3:30] We tested the logic on four scenarios: an AI agent, a guided AI, a script and a human. All four were detected and labelled correctly. Those are hand-written test sequences, not real attacks, and we say so. What we measured live: the larger local model confessed its mission 7 times out of 10, the smaller one 2 out of 10. Measuring detection and false alarms at scale is the first thing we'd do in a pilot. Thomas. — THOMAS · [3:30–3:50] A confession can lie, so each claim is checked against the logs: confirmed, unverified or contradicted. Claim an authorized pentest while using a stolen password, and the logs contradict it. Our trap note is prompt injection, ATLAS AML.T0051, turned against the attacker. And the AI-drafted NIS2 early warning stays a draft until a human approves it. Leon.</a:t>
             </a:r>
             <a:endParaRPr lang="en-US" dirty="0"/>
           </a:p>
@@ -949,7 +948,7 @@
           <a:p>
             <a:r>
               <a:rPr lang="en-US" dirty="0"/>
-              <a:t>GAIA · [3:15–3:40] We tested the logic on four scenarios: an AI agent, a guided AI, a script and a human. All four were detected and labelled correctly. Those are hand-written test sequences, not real attacks, and we say so. What we measured live: the larger local model confessed its mission 7 times out of 10, the smaller one 2 out of 10. Measuring detection and false alarms at scale is the first thing we'd do in a pilot. Thomas. — THOMAS · [3:40–4:00] An attacker's confession can lie, so we never take it at face value. Each claim is checked against the logs: confirmed, unverified, or contradicted. This one said authorized pentest: contradicted. Our AI also drafts the incident summary and the NIS2 24-hour early warning. But they stay drafts until a human approves them. Leon.</a:t>
+              <a:t>LEON · [3:50–4:20] The swap is the only automatic action, and it deletes nothing. The intruder label triggers nothing, so a wrong label costs nothing. Everything else waits for the analyst: Contain the account, Keep watching the intruder in the decoys, Dismiss a false alarm, or Restore the real files in one click. Our honest limits: files read before a trap is touched are exposed, and we flag them as critical. A careful AI that never opens a trap is not caught by the swap. Ana.</a:t>
             </a:r>
             <a:endParaRPr lang="en-US" dirty="0"/>
           </a:p>
@@ -1037,7 +1036,7 @@
           <a:p>
             <a:r>
               <a:rPr lang="en-US" dirty="0"/>
-              <a:t>LEON · [4:00–4:20] The swap is the only automatic action. Everything else waits for the analyst: Contain the account, Keep watching the intruder in the decoys, Dismiss a false alarm, or Restore the real files in one click. Our honest limit: files read before a trap is touched are exposed. We flag them as critical. Ana.</a:t>
+              <a:t>ANA · [4:20–5:00] Deception is a 2.7 billion dollar market, and its pioneers were bought by SentinelOne, Proofpoint and Zscaler. They all detect intruders. None of those we reviewed protects the real files. Our customers are clinics and the medical sector: private clinics, medical labs and imaging centres. Their breaches are the most expensive of any sector, their patient data sits on shared drives, and NIS2 now covers them. We sell directly and through the providers that already run their SOC. Next: pilots with two or three clinics, and cloud storage like SharePoint and S3. We're Ana, Thomas, Leon and Gaia. Whoever breaks in steals only fakes. And if it's an AI, it tells us who sent it. Thank you.</a:t>
             </a:r>
             <a:endParaRPr lang="en-US" dirty="0"/>
           </a:p>
@@ -1061,94 +1060,6 @@
             <a:fld id="{F7021451-1387-4CA6-816F-3879F97B5CBC}" type="slidenum">
               <a:rPr lang="en-US"/>
               <a:t>7</a:t>
-            </a:fld>
-            <a:endParaRPr lang="en-US"/>
-          </a:p>
-        </p:txBody>
-      </p:sp>
-    </p:spTree>
-    <p:extLst>
-      <p:ext uri="{BB962C8B-B14F-4D97-AF65-F5344CB8AC3E}">
-        <p14:creationId xmlns:p14="http://schemas.microsoft.com/office/powerpoint/2010/main" val="1024086991"/>
-      </p:ext>
-    </p:extLst>
-  </p:cSld>
-  <p:clrMapOvr>
-    <a:masterClrMapping/>
-  </p:clrMapOvr>
-</p:notes>
-</file>
-
-<file path=ppt/notesSlides/notesSlide8.xml><?xml version="1.0" encoding="utf-8"?>
-<p:notes xmlns:a="http://schemas.openxmlformats.org/drawingml/2006/main" xmlns:r="http://schemas.openxmlformats.org/officeDocument/2006/relationships" xmlns:p="http://schemas.openxmlformats.org/presentationml/2006/main">
-  <p:cSld>
-    <p:spTree>
-      <p:nvGrpSpPr>
-        <p:cNvPr id="1" name=""/>
-        <p:cNvGrpSpPr/>
-        <p:nvPr/>
-      </p:nvGrpSpPr>
-      <p:grpSpPr>
-        <a:xfrm>
-          <a:off x="0" y="0"/>
-          <a:ext cx="0" cy="0"/>
-          <a:chOff x="0" y="0"/>
-          <a:chExt cx="0" cy="0"/>
-        </a:xfrm>
-      </p:grpSpPr>
-      <p:sp>
-        <p:nvSpPr>
-          <p:cNvPr id="2" name="Slide Image Placeholder 1"/>
-          <p:cNvSpPr>
-            <a:spLocks noGrp="1" noRot="1" noChangeAspect="1"/>
-          </p:cNvSpPr>
-          <p:nvPr>
-            <p:ph type="sldImg"/>
-          </p:nvPr>
-        </p:nvSpPr>
-        <p:spPr/>
-      </p:sp>
-      <p:sp>
-        <p:nvSpPr>
-          <p:cNvPr id="3" name="Notes Placeholder 2"/>
-          <p:cNvSpPr>
-            <a:spLocks noGrp="1"/>
-          </p:cNvSpPr>
-          <p:nvPr>
-            <p:ph type="body" idx="1"/>
-          </p:nvPr>
-        </p:nvSpPr>
-        <p:spPr/>
-        <p:txBody>
-          <a:bodyPr/>
-          <a:lstStyle/>
-          <a:p>
-            <a:r>
-              <a:rPr lang="en-US" dirty="0"/>
-              <a:t>ANA · Deception is a 2.7 billion dollar market, and its pioneers were bought by SentinelOne, Proofpoint and Zscaler. They all detect intruders. None protects the real files. Our customers are clinics and the medical sector: private clinics, medical labs and imaging centres. Their breaches are the most expensive of any sector, their patient data sits on shared drives, and NIS2 now covers them. We sell directly and through the providers that already run their SOC. Next: pilots with two or three clinics, and cloud storage like SharePoint and S3. We're Ana, Thomas, Leon and Gaia. Whoever breaks in steals only fakes. And if it's an AI, it tells us who sent it. Thank you.</a:t>
-            </a:r>
-            <a:endParaRPr lang="en-US" dirty="0"/>
-          </a:p>
-        </p:txBody>
-      </p:sp>
-      <p:sp>
-        <p:nvSpPr>
-          <p:cNvPr id="4" name="Slide Number Placeholder 3"/>
-          <p:cNvSpPr>
-            <a:spLocks noGrp="1"/>
-          </p:cNvSpPr>
-          <p:nvPr>
-            <p:ph type="sldNum" sz="quarter" idx="10"/>
-          </p:nvPr>
-        </p:nvSpPr>
-        <p:spPr/>
-        <p:txBody>
-          <a:bodyPr/>
-          <a:lstStyle/>
-          <a:p>
-            <a:fld id="{F7021451-1387-4CA6-816F-3879F97B5CBC}" type="slidenum">
-              <a:rPr lang="en-US"/>
-              <a:t>8</a:t>
             </a:fld>
             <a:endParaRPr lang="en-US"/>
           </a:p>
@@ -1768,7 +1679,7 @@
                 <a:ea typeface="JetBrains Mono" pitchFamily="49" charset="-122"/>
                 <a:cs typeface="JetBrains Mono" pitchFamily="49" charset="-120"/>
               </a:rPr>
-              <a:t>SECURE HORIZONS 2026 · TRACK 02 · FINAL</a:t>
+              <a:t>SECURE HORIZONS 2026 · TRACK 02</a:t>
             </a:r>
             <a:endParaRPr lang="en-US" sz="1200" dirty="0"/>
           </a:p>
@@ -2550,11 +2461,11 @@
         <p:spPr>
           <a:xfrm>
             <a:off x="815975" y="2141786"/>
-            <a:ext cx="1982440" cy="1888282"/>
+            <a:ext cx="1982440" cy="2088902"/>
           </a:xfrm>
           <a:prstGeom prst="roundRect">
             <a:avLst>
-              <a:gd name="adj" fmla="val 5212"/>
+              <a:gd name="adj" fmla="val 4965"/>
             </a:avLst>
           </a:prstGeom>
           <a:solidFill>
@@ -2709,11 +2620,11 @@
         <p:spPr>
           <a:xfrm>
             <a:off x="2957165" y="2141786"/>
-            <a:ext cx="1982490" cy="1888282"/>
+            <a:ext cx="1982490" cy="2088902"/>
           </a:xfrm>
           <a:prstGeom prst="roundRect">
             <a:avLst>
-              <a:gd name="adj" fmla="val 5212"/>
+              <a:gd name="adj" fmla="val 4965"/>
             </a:avLst>
           </a:prstGeom>
           <a:solidFill>
@@ -2868,11 +2779,11 @@
         <p:spPr>
           <a:xfrm>
             <a:off x="5101580" y="2144961"/>
-            <a:ext cx="1988790" cy="1881932"/>
+            <a:ext cx="1988790" cy="2082552"/>
           </a:xfrm>
           <a:prstGeom prst="roundRect">
             <a:avLst>
-              <a:gd name="adj" fmla="val 5061"/>
+              <a:gd name="adj" fmla="val 4789"/>
             </a:avLst>
           </a:prstGeom>
           <a:solidFill>
@@ -3027,11 +2938,11 @@
         <p:spPr>
           <a:xfrm>
             <a:off x="7252295" y="2141786"/>
-            <a:ext cx="1982490" cy="1888282"/>
+            <a:ext cx="1982490" cy="2088902"/>
           </a:xfrm>
           <a:prstGeom prst="roundRect">
             <a:avLst>
-              <a:gd name="adj" fmla="val 5212"/>
+              <a:gd name="adj" fmla="val 4965"/>
             </a:avLst>
           </a:prstGeom>
           <a:solidFill>
@@ -3186,11 +3097,11 @@
         <p:spPr>
           <a:xfrm>
             <a:off x="9393535" y="2141786"/>
-            <a:ext cx="1982490" cy="1888282"/>
+            <a:ext cx="1982490" cy="2088902"/>
           </a:xfrm>
           <a:prstGeom prst="roundRect">
             <a:avLst>
-              <a:gd name="adj" fmla="val 5212"/>
+              <a:gd name="adj" fmla="val 4965"/>
             </a:avLst>
           </a:prstGeom>
           <a:solidFill>
@@ -3301,7 +3212,7 @@
         <p:spPr>
           <a:xfrm>
             <a:off x="9599910" y="2957711"/>
-            <a:ext cx="1620540" cy="665361"/>
+            <a:ext cx="1620540" cy="1092002"/>
           </a:xfrm>
           <a:prstGeom prst="rect">
             <a:avLst/>
@@ -3330,7 +3241,7 @@
                 <a:ea typeface="IBM Plex Sans" pitchFamily="34" charset="-122"/>
                 <a:cs typeface="IBM Plex Sans" pitchFamily="34" charset="-120"/>
               </a:rPr>
-              <a:t>One incident card. The analyst clicks Contain or Restore.</a:t>
+              <a:t>One incident card. The analyst decides: Contain, Keep watching, Dismiss or Restore.</a:t>
             </a:r>
             <a:endParaRPr lang="en-US" sz="1200" dirty="0"/>
           </a:p>
@@ -3511,11 +3422,11 @@
         <p:spPr>
           <a:xfrm>
             <a:off x="815975" y="2543076"/>
-            <a:ext cx="2517775" cy="1888282"/>
+            <a:ext cx="2517775" cy="2101602"/>
           </a:xfrm>
           <a:prstGeom prst="roundRect">
             <a:avLst>
-              <a:gd name="adj" fmla="val 5212"/>
+              <a:gd name="adj" fmla="val 4683"/>
             </a:avLst>
           </a:prstGeom>
           <a:solidFill>
@@ -3670,11 +3581,11 @@
         <p:spPr>
           <a:xfrm>
             <a:off x="3495675" y="2546251"/>
-            <a:ext cx="2524125" cy="1881932"/>
+            <a:ext cx="2524125" cy="2095252"/>
           </a:xfrm>
           <a:prstGeom prst="roundRect">
             <a:avLst>
-              <a:gd name="adj" fmla="val 5061"/>
+              <a:gd name="adj" fmla="val 4546"/>
             </a:avLst>
           </a:prstGeom>
           <a:solidFill>
@@ -3785,7 +3696,7 @@
         <p:spPr>
           <a:xfrm>
             <a:off x="3705225" y="3578671"/>
-            <a:ext cx="2168176" cy="665361"/>
+            <a:ext cx="2168176" cy="878681"/>
           </a:xfrm>
           <a:prstGeom prst="rect">
             <a:avLst/>
@@ -3814,7 +3725,7 @@
                 <a:ea typeface="IBM Plex Sans" pitchFamily="34" charset="-122"/>
                 <a:cs typeface="IBM Plex Sans" pitchFamily="34" charset="-120"/>
               </a:rPr>
-              <a:t>Watches the mines, runs the swap, logs every command. Exposes Contain and Restore.</a:t>
+              <a:t>Watches the mines, runs the swap, logs every command. Carries out Contain and Restore.</a:t>
             </a:r>
             <a:endParaRPr lang="en-US" sz="1200" dirty="0"/>
           </a:p>
@@ -3829,11 +3740,11 @@
         <p:spPr>
           <a:xfrm>
             <a:off x="6181725" y="2543076"/>
-            <a:ext cx="2517775" cy="1888282"/>
+            <a:ext cx="2517775" cy="2101602"/>
           </a:xfrm>
           <a:prstGeom prst="roundRect">
             <a:avLst>
-              <a:gd name="adj" fmla="val 5212"/>
+              <a:gd name="adj" fmla="val 4683"/>
             </a:avLst>
           </a:prstGeom>
           <a:solidFill>
@@ -3988,11 +3899,11 @@
         <p:spPr>
           <a:xfrm>
             <a:off x="8858250" y="2543076"/>
-            <a:ext cx="2517775" cy="1888282"/>
+            <a:ext cx="2517775" cy="2101602"/>
           </a:xfrm>
           <a:prstGeom prst="roundRect">
             <a:avLst>
-              <a:gd name="adj" fmla="val 5212"/>
+              <a:gd name="adj" fmla="val 4683"/>
             </a:avLst>
           </a:prstGeom>
           <a:solidFill>
@@ -4103,7 +4014,7 @@
         <p:spPr>
           <a:xfrm>
             <a:off x="9064625" y="3359001"/>
-            <a:ext cx="2168176" cy="665361"/>
+            <a:ext cx="2168176" cy="878681"/>
           </a:xfrm>
           <a:prstGeom prst="rect">
             <a:avLst/>
@@ -4132,7 +4043,7 @@
                 <a:ea typeface="IBM Plex Sans" pitchFamily="34" charset="-122"/>
                 <a:cs typeface="IBM Plex Sans" pitchFamily="34" charset="-120"/>
               </a:rPr>
-              <a:t>One incident card: who, what was taken, fake vs real, Contain and Restore.</a:t>
+              <a:t>One incident card: who, what was taken, fake vs real. Contain, Keep watching, Dismiss, Restore.</a:t>
             </a:r>
             <a:endParaRPr lang="en-US" sz="1200" dirty="0"/>
           </a:p>
@@ -4146,7 +4057,7 @@
         </p:nvSpPr>
         <p:spPr>
           <a:xfrm>
-            <a:off x="812800" y="4688532"/>
+            <a:off x="812800" y="4901853"/>
             <a:ext cx="10883392" cy="274290"/>
           </a:xfrm>
           <a:prstGeom prst="rect">
@@ -4223,28 +4134,28 @@
         <p:spPr>
           <a:xfrm>
             <a:off x="812800" y="812800"/>
-            <a:ext cx="10883392" cy="238720"/>
-          </a:xfrm>
-          <a:prstGeom prst="rect">
-            <a:avLst/>
-          </a:prstGeom>
-          <a:noFill/>
-          <a:ln/>
-        </p:spPr>
-        <p:txBody>
-          <a:bodyPr wrap="square" lIns="0" tIns="0" rIns="0" bIns="0" rtlCol="0" anchor="t">
-            <a:normAutofit/>
-          </a:bodyPr>
-          <a:lstStyle/>
-          <a:p>
-            <a:pPr algn="l" indent="0" marL="0">
-              <a:lnSpc>
-                <a:spcPts val="1680"/>
-              </a:lnSpc>
-              <a:buNone/>
-            </a:pPr>
-            <a:r>
-              <a:rPr lang="en-US" sz="1200" spc="200" kern="0" dirty="0">
+            <a:ext cx="10883392" cy="209302"/>
+          </a:xfrm>
+          <a:prstGeom prst="rect">
+            <a:avLst/>
+          </a:prstGeom>
+          <a:noFill/>
+          <a:ln/>
+        </p:spPr>
+        <p:txBody>
+          <a:bodyPr wrap="square" lIns="0" tIns="0" rIns="0" bIns="0" rtlCol="0" anchor="t">
+            <a:normAutofit/>
+          </a:bodyPr>
+          <a:lstStyle/>
+          <a:p>
+            <a:pPr algn="l" indent="0" marL="0">
+              <a:lnSpc>
+                <a:spcPts val="1470"/>
+              </a:lnSpc>
+              <a:buNone/>
+            </a:pPr>
+            <a:r>
+              <a:rPr lang="en-US" sz="1050" spc="200" kern="0" dirty="0">
                 <a:solidFill>
                   <a:srgbClr val="7BE0A0"/>
                 </a:solidFill>
@@ -4252,9 +4163,9 @@
                 <a:ea typeface="JetBrains Mono" pitchFamily="49" charset="-122"/>
                 <a:cs typeface="JetBrains Mono" pitchFamily="49" charset="-120"/>
               </a:rPr>
-              <a:t>LIVE DEMO</a:t>
-            </a:r>
-            <a:endParaRPr lang="en-US" sz="1200" dirty="0"/>
+              <a:t>WHAT WE TESTED, AND HOW</a:t>
+            </a:r>
+            <a:endParaRPr lang="en-US" sz="1050" dirty="0"/>
           </a:p>
         </p:txBody>
       </p:sp>
@@ -4268,29 +4179,29 @@
         </p:nvSpPr>
         <p:spPr>
           <a:xfrm>
-            <a:off x="812800" y="1280120"/>
-            <a:ext cx="10883392" cy="528290"/>
-          </a:xfrm>
-          <a:prstGeom prst="rect">
-            <a:avLst/>
-          </a:prstGeom>
-          <a:noFill/>
-          <a:ln/>
-        </p:spPr>
-        <p:txBody>
-          <a:bodyPr wrap="square" lIns="0" tIns="0" rIns="0" bIns="0" rtlCol="0" anchor="t">
-            <a:normAutofit/>
-          </a:bodyPr>
-          <a:lstStyle/>
-          <a:p>
-            <a:pPr algn="l" indent="0" marL="0">
-              <a:lnSpc>
-                <a:spcPts val="3960"/>
-              </a:lnSpc>
-              <a:buNone/>
-            </a:pPr>
-            <a:r>
-              <a:rPr lang="en-US" sz="3600" b="1" i="0" dirty="0">
+            <a:off x="812800" y="1174502"/>
+            <a:ext cx="10883392" cy="892373"/>
+          </a:xfrm>
+          <a:prstGeom prst="rect">
+            <a:avLst/>
+          </a:prstGeom>
+          <a:noFill/>
+          <a:ln/>
+        </p:spPr>
+        <p:txBody>
+          <a:bodyPr wrap="square" lIns="0" tIns="0" rIns="0" bIns="0" rtlCol="0" anchor="t">
+            <a:normAutofit/>
+          </a:bodyPr>
+          <a:lstStyle/>
+          <a:p>
+            <a:pPr algn="l" indent="0" marL="0">
+              <a:lnSpc>
+                <a:spcPts val="3428"/>
+              </a:lnSpc>
+              <a:buNone/>
+            </a:pPr>
+            <a:r>
+              <a:rPr lang="en-US" sz="3116" b="1" i="0" dirty="0">
                 <a:solidFill>
                   <a:srgbClr val="F2F5F0"/>
                 </a:solidFill>
@@ -4298,9 +4209,9 @@
                 <a:ea typeface="Space Grotesk" pitchFamily="34" charset="-122"/>
                 <a:cs typeface="Space Grotesk" pitchFamily="34" charset="-120"/>
               </a:rPr>
-              <a:t>An AI agent attacks Lumen Health.</a:t>
-            </a:r>
-            <a:endParaRPr lang="en-US" sz="3600" dirty="0"/>
+              <a:t>Logic validated on test scenarios. Confessions measured live.</a:t>
+            </a:r>
+            <a:endParaRPr lang="en-US" sz="3116" dirty="0"/>
           </a:p>
         </p:txBody>
       </p:sp>
@@ -4312,22 +4223,22 @@
         </p:nvSpPr>
         <p:spPr>
           <a:xfrm>
-            <a:off x="819150" y="2043361"/>
-            <a:ext cx="5168900" cy="3792289"/>
+            <a:off x="815975" y="2222450"/>
+            <a:ext cx="3414167" cy="1561654"/>
           </a:xfrm>
           <a:prstGeom prst="roundRect">
             <a:avLst>
-              <a:gd name="adj" fmla="val 2512"/>
+              <a:gd name="adj" fmla="val 6303"/>
             </a:avLst>
           </a:prstGeom>
           <a:solidFill>
             <a:srgbClr val="18221E"/>
           </a:solidFill>
-          <a:ln w="12700">
+          <a:ln w="6350">
             <a:solidFill>
-              <a:srgbClr val="3C5148"/>
+              <a:srgbClr val="2C3D36"/>
             </a:solidFill>
-            <a:prstDash val="dash"/>
+            <a:prstDash val="solid"/>
           </a:ln>
         </p:spPr>
       </p:sp>
@@ -4339,66 +4250,729 @@
         </p:nvSpPr>
         <p:spPr>
           <a:xfrm>
-            <a:off x="1702792" y="3675360"/>
-            <a:ext cx="3401616" cy="238720"/>
-          </a:xfrm>
-          <a:prstGeom prst="rect">
-            <a:avLst/>
-          </a:prstGeom>
-          <a:noFill/>
-          <a:ln/>
-        </p:spPr>
-        <p:txBody>
-          <a:bodyPr wrap="square" lIns="0" tIns="0" rIns="0" bIns="0" rtlCol="0" anchor="t">
-            <a:normAutofit/>
-          </a:bodyPr>
-          <a:lstStyle/>
-          <a:p>
-            <a:pPr algn="ctr" indent="0" marL="0">
-              <a:lnSpc>
-                <a:spcPts val="1680"/>
-              </a:lnSpc>
-              <a:buNone/>
-            </a:pPr>
-            <a:r>
-              <a:rPr lang="en-US" sz="1200" dirty="0">
-                <a:solidFill>
-                  <a:srgbClr val="9DB3A8"/>
+            <a:off x="996950" y="2403425"/>
+            <a:ext cx="3143783" cy="543967"/>
+          </a:xfrm>
+          <a:prstGeom prst="rect">
+            <a:avLst/>
+          </a:prstGeom>
+          <a:noFill/>
+          <a:ln/>
+        </p:spPr>
+        <p:txBody>
+          <a:bodyPr wrap="square" lIns="0" tIns="0" rIns="0" bIns="0" rtlCol="0" anchor="t">
+            <a:normAutofit/>
+          </a:bodyPr>
+          <a:lstStyle/>
+          <a:p>
+            <a:pPr algn="l" indent="0" marL="0">
+              <a:lnSpc>
+                <a:spcPts val="4111"/>
+              </a:lnSpc>
+              <a:buNone/>
+            </a:pPr>
+            <a:r>
+              <a:rPr lang="en-US" sz="2936" b="1" dirty="0">
+                <a:solidFill>
+                  <a:srgbClr val="7BE0A0"/>
+                </a:solidFill>
+                <a:latin typeface="Space Grotesk" pitchFamily="34" charset="0"/>
+                <a:ea typeface="Space Grotesk" pitchFamily="34" charset="-122"/>
+                <a:cs typeface="Space Grotesk" pitchFamily="34" charset="-120"/>
+              </a:rPr>
+              <a:t>4 / 4</a:t>
+            </a:r>
+            <a:endParaRPr lang="en-US" sz="2936" dirty="0"/>
+          </a:p>
+        </p:txBody>
+      </p:sp>
+      <p:sp>
+        <p:nvSpPr>
+          <p:cNvPr id="6" name="Text 4"/>
+          <p:cNvSpPr/>
+          <p:nvPr/>
+        </p:nvSpPr>
+        <p:spPr>
+          <a:xfrm>
+            <a:off x="996950" y="2998192"/>
+            <a:ext cx="3143783" cy="630337"/>
+          </a:xfrm>
+          <a:prstGeom prst="rect">
+            <a:avLst/>
+          </a:prstGeom>
+          <a:noFill/>
+          <a:ln/>
+        </p:spPr>
+        <p:txBody>
+          <a:bodyPr wrap="square" lIns="0" tIns="0" rIns="0" bIns="0" rtlCol="0" anchor="t">
+            <a:normAutofit/>
+          </a:bodyPr>
+          <a:lstStyle/>
+          <a:p>
+            <a:pPr algn="l" indent="0" marL="0">
+              <a:lnSpc>
+                <a:spcPts val="1617"/>
+              </a:lnSpc>
+              <a:buNone/>
+            </a:pPr>
+            <a:r>
+              <a:rPr lang="en-US" sz="1155" dirty="0">
+                <a:solidFill>
+                  <a:srgbClr val="BFD3C8"/>
+                </a:solidFill>
+                <a:latin typeface="IBM Plex Sans" pitchFamily="34" charset="0"/>
+                <a:ea typeface="IBM Plex Sans" pitchFamily="34" charset="-122"/>
+                <a:cs typeface="IBM Plex Sans" pitchFamily="34" charset="-120"/>
+              </a:rPr>
+              <a:t>test scenarios detected and labelled correctly: AI agent, guided AI, script, human (logic test)</a:t>
+            </a:r>
+            <a:endParaRPr lang="en-US" sz="1155" dirty="0"/>
+          </a:p>
+        </p:txBody>
+      </p:sp>
+      <p:sp>
+        <p:nvSpPr>
+          <p:cNvPr id="7" name="Shape 5"/>
+          <p:cNvSpPr/>
+          <p:nvPr/>
+        </p:nvSpPr>
+        <p:spPr>
+          <a:xfrm>
+            <a:off x="4388892" y="2222450"/>
+            <a:ext cx="3414167" cy="1561654"/>
+          </a:xfrm>
+          <a:prstGeom prst="roundRect">
+            <a:avLst>
+              <a:gd name="adj" fmla="val 6303"/>
+            </a:avLst>
+          </a:prstGeom>
+          <a:solidFill>
+            <a:srgbClr val="18221E"/>
+          </a:solidFill>
+          <a:ln w="6350">
+            <a:solidFill>
+              <a:srgbClr val="2C3D36"/>
+            </a:solidFill>
+            <a:prstDash val="solid"/>
+          </a:ln>
+        </p:spPr>
+      </p:sp>
+      <p:sp>
+        <p:nvSpPr>
+          <p:cNvPr id="8" name="Text 6"/>
+          <p:cNvSpPr/>
+          <p:nvPr/>
+        </p:nvSpPr>
+        <p:spPr>
+          <a:xfrm>
+            <a:off x="4569867" y="2403425"/>
+            <a:ext cx="3143783" cy="657423"/>
+          </a:xfrm>
+          <a:prstGeom prst="rect">
+            <a:avLst/>
+          </a:prstGeom>
+          <a:noFill/>
+          <a:ln/>
+        </p:spPr>
+        <p:txBody>
+          <a:bodyPr wrap="square" lIns="0" tIns="0" rIns="0" bIns="0" rtlCol="0" anchor="t">
+            <a:normAutofit/>
+          </a:bodyPr>
+          <a:lstStyle/>
+          <a:p>
+            <a:pPr algn="l" indent="0" marL="0">
+              <a:lnSpc>
+                <a:spcPts val="5024"/>
+              </a:lnSpc>
+              <a:buNone/>
+            </a:pPr>
+            <a:r>
+              <a:rPr lang="en-US" sz="3589" b="1" dirty="0">
+                <a:solidFill>
+                  <a:srgbClr val="7BE0A0"/>
+                </a:solidFill>
+                <a:latin typeface="Space Grotesk" pitchFamily="34" charset="0"/>
+                <a:ea typeface="Space Grotesk" pitchFamily="34" charset="-122"/>
+                <a:cs typeface="Space Grotesk" pitchFamily="34" charset="-120"/>
+              </a:rPr>
+              <a:t>7 / 10</a:t>
+            </a:r>
+            <a:endParaRPr lang="en-US" sz="3589" dirty="0"/>
+          </a:p>
+        </p:txBody>
+      </p:sp>
+      <p:sp>
+        <p:nvSpPr>
+          <p:cNvPr id="9" name="Text 7"/>
+          <p:cNvSpPr/>
+          <p:nvPr/>
+        </p:nvSpPr>
+        <p:spPr>
+          <a:xfrm>
+            <a:off x="4569867" y="3111649"/>
+            <a:ext cx="3143783" cy="516880"/>
+          </a:xfrm>
+          <a:prstGeom prst="rect">
+            <a:avLst/>
+          </a:prstGeom>
+          <a:noFill/>
+          <a:ln/>
+        </p:spPr>
+        <p:txBody>
+          <a:bodyPr wrap="square" lIns="0" tIns="0" rIns="0" bIns="0" rtlCol="0" anchor="t">
+            <a:normAutofit/>
+          </a:bodyPr>
+          <a:lstStyle/>
+          <a:p>
+            <a:pPr algn="l" indent="0" marL="0">
+              <a:lnSpc>
+                <a:spcPts val="1936"/>
+              </a:lnSpc>
+              <a:buNone/>
+            </a:pPr>
+            <a:r>
+              <a:rPr lang="en-US" sz="1383" dirty="0">
+                <a:solidFill>
+                  <a:srgbClr val="BFD3C8"/>
+                </a:solidFill>
+                <a:latin typeface="IBM Plex Sans" pitchFamily="34" charset="0"/>
+                <a:ea typeface="IBM Plex Sans" pitchFamily="34" charset="-122"/>
+                <a:cs typeface="IBM Plex Sans" pitchFamily="34" charset="-120"/>
+              </a:rPr>
+              <a:t>live AI runs that confessed their mission (qwen3.5:35b, local)</a:t>
+            </a:r>
+            <a:endParaRPr lang="en-US" sz="1383" dirty="0"/>
+          </a:p>
+        </p:txBody>
+      </p:sp>
+      <p:sp>
+        <p:nvSpPr>
+          <p:cNvPr id="10" name="Shape 8"/>
+          <p:cNvSpPr/>
+          <p:nvPr/>
+        </p:nvSpPr>
+        <p:spPr>
+          <a:xfrm>
+            <a:off x="7961809" y="2222450"/>
+            <a:ext cx="3414216" cy="1561654"/>
+          </a:xfrm>
+          <a:prstGeom prst="roundRect">
+            <a:avLst>
+              <a:gd name="adj" fmla="val 6303"/>
+            </a:avLst>
+          </a:prstGeom>
+          <a:solidFill>
+            <a:srgbClr val="18221E"/>
+          </a:solidFill>
+          <a:ln w="6350">
+            <a:solidFill>
+              <a:srgbClr val="2C3D36"/>
+            </a:solidFill>
+            <a:prstDash val="solid"/>
+          </a:ln>
+        </p:spPr>
+      </p:sp>
+      <p:sp>
+        <p:nvSpPr>
+          <p:cNvPr id="11" name="Text 9"/>
+          <p:cNvSpPr/>
+          <p:nvPr/>
+        </p:nvSpPr>
+        <p:spPr>
+          <a:xfrm>
+            <a:off x="8142784" y="2403425"/>
+            <a:ext cx="3143834" cy="657423"/>
+          </a:xfrm>
+          <a:prstGeom prst="rect">
+            <a:avLst/>
+          </a:prstGeom>
+          <a:noFill/>
+          <a:ln/>
+        </p:spPr>
+        <p:txBody>
+          <a:bodyPr wrap="square" lIns="0" tIns="0" rIns="0" bIns="0" rtlCol="0" anchor="t">
+            <a:normAutofit/>
+          </a:bodyPr>
+          <a:lstStyle/>
+          <a:p>
+            <a:pPr algn="l" indent="0" marL="0">
+              <a:lnSpc>
+                <a:spcPts val="5024"/>
+              </a:lnSpc>
+              <a:buNone/>
+            </a:pPr>
+            <a:r>
+              <a:rPr lang="en-US" sz="3589" b="1" dirty="0">
+                <a:solidFill>
+                  <a:srgbClr val="7BE0A0"/>
+                </a:solidFill>
+                <a:latin typeface="Space Grotesk" pitchFamily="34" charset="0"/>
+                <a:ea typeface="Space Grotesk" pitchFamily="34" charset="-122"/>
+                <a:cs typeface="Space Grotesk" pitchFamily="34" charset="-120"/>
+              </a:rPr>
+              <a:t>2 / 10</a:t>
+            </a:r>
+            <a:endParaRPr lang="en-US" sz="3589" dirty="0"/>
+          </a:p>
+        </p:txBody>
+      </p:sp>
+      <p:sp>
+        <p:nvSpPr>
+          <p:cNvPr id="12" name="Text 10"/>
+          <p:cNvSpPr/>
+          <p:nvPr/>
+        </p:nvSpPr>
+        <p:spPr>
+          <a:xfrm>
+            <a:off x="8142784" y="3111649"/>
+            <a:ext cx="3143834" cy="516880"/>
+          </a:xfrm>
+          <a:prstGeom prst="rect">
+            <a:avLst/>
+          </a:prstGeom>
+          <a:noFill/>
+          <a:ln/>
+        </p:spPr>
+        <p:txBody>
+          <a:bodyPr wrap="square" lIns="0" tIns="0" rIns="0" bIns="0" rtlCol="0" anchor="t">
+            <a:normAutofit/>
+          </a:bodyPr>
+          <a:lstStyle/>
+          <a:p>
+            <a:pPr algn="l" indent="0" marL="0">
+              <a:lnSpc>
+                <a:spcPts val="1936"/>
+              </a:lnSpc>
+              <a:buNone/>
+            </a:pPr>
+            <a:r>
+              <a:rPr lang="en-US" sz="1383" dirty="0">
+                <a:solidFill>
+                  <a:srgbClr val="BFD3C8"/>
+                </a:solidFill>
+                <a:latin typeface="IBM Plex Sans" pitchFamily="34" charset="0"/>
+                <a:ea typeface="IBM Plex Sans" pitchFamily="34" charset="-122"/>
+                <a:cs typeface="IBM Plex Sans" pitchFamily="34" charset="-120"/>
+              </a:rPr>
+              <a:t>for the smaller model (qwen2.5:7b): careful models resist</a:t>
+            </a:r>
+            <a:endParaRPr lang="en-US" sz="1383" dirty="0"/>
+          </a:p>
+        </p:txBody>
+      </p:sp>
+      <p:sp>
+        <p:nvSpPr>
+          <p:cNvPr id="13" name="Shape 11"/>
+          <p:cNvSpPr/>
+          <p:nvPr/>
+        </p:nvSpPr>
+        <p:spPr>
+          <a:xfrm>
+            <a:off x="815975" y="3942854"/>
+            <a:ext cx="3414167" cy="1561654"/>
+          </a:xfrm>
+          <a:prstGeom prst="roundRect">
+            <a:avLst>
+              <a:gd name="adj" fmla="val 6303"/>
+            </a:avLst>
+          </a:prstGeom>
+          <a:solidFill>
+            <a:srgbClr val="18221E"/>
+          </a:solidFill>
+          <a:ln w="6350">
+            <a:solidFill>
+              <a:srgbClr val="2C3D36"/>
+            </a:solidFill>
+            <a:prstDash val="solid"/>
+          </a:ln>
+        </p:spPr>
+      </p:sp>
+      <p:sp>
+        <p:nvSpPr>
+          <p:cNvPr id="14" name="Text 12"/>
+          <p:cNvSpPr/>
+          <p:nvPr/>
+        </p:nvSpPr>
+        <p:spPr>
+          <a:xfrm>
+            <a:off x="996950" y="4123829"/>
+            <a:ext cx="3143783" cy="543967"/>
+          </a:xfrm>
+          <a:prstGeom prst="rect">
+            <a:avLst/>
+          </a:prstGeom>
+          <a:noFill/>
+          <a:ln/>
+        </p:spPr>
+        <p:txBody>
+          <a:bodyPr wrap="square" lIns="0" tIns="0" rIns="0" bIns="0" rtlCol="0" anchor="t">
+            <a:normAutofit/>
+          </a:bodyPr>
+          <a:lstStyle/>
+          <a:p>
+            <a:pPr algn="l" indent="0" marL="0">
+              <a:lnSpc>
+                <a:spcPts val="4111"/>
+              </a:lnSpc>
+              <a:buNone/>
+            </a:pPr>
+            <a:r>
+              <a:rPr lang="en-US" sz="2936" b="1" dirty="0">
+                <a:solidFill>
+                  <a:srgbClr val="7BE0A0"/>
+                </a:solidFill>
+                <a:latin typeface="Space Grotesk" pitchFamily="34" charset="0"/>
+                <a:ea typeface="Space Grotesk" pitchFamily="34" charset="-122"/>
+                <a:cs typeface="Space Grotesk" pitchFamily="34" charset="-120"/>
+              </a:rPr>
+              <a:t>Live</a:t>
+            </a:r>
+            <a:endParaRPr lang="en-US" sz="2936" dirty="0"/>
+          </a:p>
+        </p:txBody>
+      </p:sp>
+      <p:sp>
+        <p:nvSpPr>
+          <p:cNvPr id="15" name="Text 13"/>
+          <p:cNvSpPr/>
+          <p:nvPr/>
+        </p:nvSpPr>
+        <p:spPr>
+          <a:xfrm>
+            <a:off x="996950" y="4718596"/>
+            <a:ext cx="3143783" cy="630337"/>
+          </a:xfrm>
+          <a:prstGeom prst="rect">
+            <a:avLst/>
+          </a:prstGeom>
+          <a:noFill/>
+          <a:ln/>
+        </p:spPr>
+        <p:txBody>
+          <a:bodyPr wrap="square" lIns="0" tIns="0" rIns="0" bIns="0" rtlCol="0" anchor="t">
+            <a:normAutofit/>
+          </a:bodyPr>
+          <a:lstStyle/>
+          <a:p>
+            <a:pPr algn="l" indent="0" marL="0">
+              <a:lnSpc>
+                <a:spcPts val="1586"/>
+              </a:lnSpc>
+              <a:buNone/>
+            </a:pPr>
+            <a:r>
+              <a:rPr lang="en-US" sz="1133" dirty="0">
+                <a:solidFill>
+                  <a:srgbClr val="BFD3C8"/>
+                </a:solidFill>
+                <a:latin typeface="IBM Plex Sans" pitchFamily="34" charset="0"/>
+                <a:ea typeface="IBM Plex Sans" pitchFamily="34" charset="-122"/>
+                <a:cs typeface="IBM Plex Sans" pitchFamily="34" charset="-120"/>
+              </a:rPr>
+              <a:t>swap time read from the guard on the incident card, in the demo you just saw (target: under 1 s)</a:t>
+            </a:r>
+            <a:endParaRPr lang="en-US" sz="1133" dirty="0"/>
+          </a:p>
+        </p:txBody>
+      </p:sp>
+      <p:sp>
+        <p:nvSpPr>
+          <p:cNvPr id="16" name="Shape 14"/>
+          <p:cNvSpPr/>
+          <p:nvPr/>
+        </p:nvSpPr>
+        <p:spPr>
+          <a:xfrm>
+            <a:off x="4388892" y="3942854"/>
+            <a:ext cx="3414167" cy="1561654"/>
+          </a:xfrm>
+          <a:prstGeom prst="roundRect">
+            <a:avLst>
+              <a:gd name="adj" fmla="val 6303"/>
+            </a:avLst>
+          </a:prstGeom>
+          <a:solidFill>
+            <a:srgbClr val="18221E"/>
+          </a:solidFill>
+          <a:ln w="6350">
+            <a:solidFill>
+              <a:srgbClr val="2C3D36"/>
+            </a:solidFill>
+            <a:prstDash val="solid"/>
+          </a:ln>
+        </p:spPr>
+      </p:sp>
+      <p:sp>
+        <p:nvSpPr>
+          <p:cNvPr id="17" name="Text 15"/>
+          <p:cNvSpPr/>
+          <p:nvPr/>
+        </p:nvSpPr>
+        <p:spPr>
+          <a:xfrm>
+            <a:off x="4569867" y="4123829"/>
+            <a:ext cx="3143783" cy="657423"/>
+          </a:xfrm>
+          <a:prstGeom prst="rect">
+            <a:avLst/>
+          </a:prstGeom>
+          <a:noFill/>
+          <a:ln/>
+        </p:spPr>
+        <p:txBody>
+          <a:bodyPr wrap="square" lIns="0" tIns="0" rIns="0" bIns="0" rtlCol="0" anchor="t">
+            <a:normAutofit/>
+          </a:bodyPr>
+          <a:lstStyle/>
+          <a:p>
+            <a:pPr algn="l" indent="0" marL="0">
+              <a:lnSpc>
+                <a:spcPts val="5024"/>
+              </a:lnSpc>
+              <a:buNone/>
+            </a:pPr>
+            <a:r>
+              <a:rPr lang="en-US" sz="3589" b="1" dirty="0">
+                <a:solidFill>
+                  <a:srgbClr val="7BE0A0"/>
+                </a:solidFill>
+                <a:latin typeface="Space Grotesk" pitchFamily="34" charset="0"/>
+                <a:ea typeface="Space Grotesk" pitchFamily="34" charset="-122"/>
+                <a:cs typeface="Space Grotesk" pitchFamily="34" charset="-120"/>
+              </a:rPr>
+              <a:t>3 tags</a:t>
+            </a:r>
+            <a:endParaRPr lang="en-US" sz="3589" dirty="0"/>
+          </a:p>
+        </p:txBody>
+      </p:sp>
+      <p:sp>
+        <p:nvSpPr>
+          <p:cNvPr id="18" name="Text 16"/>
+          <p:cNvSpPr/>
+          <p:nvPr/>
+        </p:nvSpPr>
+        <p:spPr>
+          <a:xfrm>
+            <a:off x="4569867" y="4832052"/>
+            <a:ext cx="3143783" cy="516880"/>
+          </a:xfrm>
+          <a:prstGeom prst="rect">
+            <a:avLst/>
+          </a:prstGeom>
+          <a:noFill/>
+          <a:ln/>
+        </p:spPr>
+        <p:txBody>
+          <a:bodyPr wrap="square" lIns="0" tIns="0" rIns="0" bIns="0" rtlCol="0" anchor="t">
+            <a:normAutofit/>
+          </a:bodyPr>
+          <a:lstStyle/>
+          <a:p>
+            <a:pPr algn="l" indent="0" marL="0">
+              <a:lnSpc>
+                <a:spcPts val="1936"/>
+              </a:lnSpc>
+              <a:buNone/>
+            </a:pPr>
+            <a:r>
+              <a:rPr lang="en-US" sz="1383" dirty="0">
+                <a:solidFill>
+                  <a:srgbClr val="BFD3C8"/>
+                </a:solidFill>
+                <a:latin typeface="IBM Plex Sans" pitchFamily="34" charset="0"/>
+                <a:ea typeface="IBM Plex Sans" pitchFamily="34" charset="-122"/>
+                <a:cs typeface="IBM Plex Sans" pitchFamily="34" charset="-120"/>
+              </a:rPr>
+              <a:t>every claim checked against the logs: confirmed, unverified, contradicted</a:t>
+            </a:r>
+            <a:endParaRPr lang="en-US" sz="1383" dirty="0"/>
+          </a:p>
+        </p:txBody>
+      </p:sp>
+      <p:sp>
+        <p:nvSpPr>
+          <p:cNvPr id="19" name="Shape 17"/>
+          <p:cNvSpPr/>
+          <p:nvPr/>
+        </p:nvSpPr>
+        <p:spPr>
+          <a:xfrm>
+            <a:off x="7961809" y="3942854"/>
+            <a:ext cx="3414216" cy="1561654"/>
+          </a:xfrm>
+          <a:prstGeom prst="roundRect">
+            <a:avLst>
+              <a:gd name="adj" fmla="val 6303"/>
+            </a:avLst>
+          </a:prstGeom>
+          <a:solidFill>
+            <a:srgbClr val="18221E"/>
+          </a:solidFill>
+          <a:ln w="6350">
+            <a:solidFill>
+              <a:srgbClr val="2C3D36"/>
+            </a:solidFill>
+            <a:prstDash val="solid"/>
+          </a:ln>
+        </p:spPr>
+      </p:sp>
+      <p:sp>
+        <p:nvSpPr>
+          <p:cNvPr id="20" name="Text 18"/>
+          <p:cNvSpPr/>
+          <p:nvPr/>
+        </p:nvSpPr>
+        <p:spPr>
+          <a:xfrm>
+            <a:off x="8142784" y="4123829"/>
+            <a:ext cx="3143834" cy="657423"/>
+          </a:xfrm>
+          <a:prstGeom prst="rect">
+            <a:avLst/>
+          </a:prstGeom>
+          <a:noFill/>
+          <a:ln/>
+        </p:spPr>
+        <p:txBody>
+          <a:bodyPr wrap="square" lIns="0" tIns="0" rIns="0" bIns="0" rtlCol="0" anchor="t">
+            <a:normAutofit/>
+          </a:bodyPr>
+          <a:lstStyle/>
+          <a:p>
+            <a:pPr algn="l" indent="0" marL="0">
+              <a:lnSpc>
+                <a:spcPts val="5024"/>
+              </a:lnSpc>
+              <a:buNone/>
+            </a:pPr>
+            <a:r>
+              <a:rPr lang="en-US" sz="3589" b="1" dirty="0">
+                <a:solidFill>
+                  <a:srgbClr val="7BE0A0"/>
+                </a:solidFill>
+                <a:latin typeface="Space Grotesk" pitchFamily="34" charset="0"/>
+                <a:ea typeface="Space Grotesk" pitchFamily="34" charset="-122"/>
+                <a:cs typeface="Space Grotesk" pitchFamily="34" charset="-120"/>
+              </a:rPr>
+              <a:t>Next</a:t>
+            </a:r>
+            <a:endParaRPr lang="en-US" sz="3589" dirty="0"/>
+          </a:p>
+        </p:txBody>
+      </p:sp>
+      <p:sp>
+        <p:nvSpPr>
+          <p:cNvPr id="21" name="Text 19"/>
+          <p:cNvSpPr/>
+          <p:nvPr/>
+        </p:nvSpPr>
+        <p:spPr>
+          <a:xfrm>
+            <a:off x="8142784" y="4832052"/>
+            <a:ext cx="3143834" cy="516880"/>
+          </a:xfrm>
+          <a:prstGeom prst="rect">
+            <a:avLst/>
+          </a:prstGeom>
+          <a:noFill/>
+          <a:ln/>
+        </p:spPr>
+        <p:txBody>
+          <a:bodyPr wrap="square" lIns="0" tIns="0" rIns="0" bIns="0" rtlCol="0" anchor="t">
+            <a:normAutofit/>
+          </a:bodyPr>
+          <a:lstStyle/>
+          <a:p>
+            <a:pPr algn="l" indent="0" marL="0">
+              <a:lnSpc>
+                <a:spcPts val="1936"/>
+              </a:lnSpc>
+              <a:buNone/>
+            </a:pPr>
+            <a:r>
+              <a:rPr lang="en-US" sz="1383" dirty="0">
+                <a:solidFill>
+                  <a:srgbClr val="BFD3C8"/>
+                </a:solidFill>
+                <a:latin typeface="IBM Plex Sans" pitchFamily="34" charset="0"/>
+                <a:ea typeface="IBM Plex Sans" pitchFamily="34" charset="-122"/>
+                <a:cs typeface="IBM Plex Sans" pitchFamily="34" charset="-120"/>
+              </a:rPr>
+              <a:t>detection and false-alarm rates at scale, measured during pilots</a:t>
+            </a:r>
+            <a:endParaRPr lang="en-US" sz="1383" dirty="0"/>
+          </a:p>
+        </p:txBody>
+      </p:sp>
+      <p:sp>
+        <p:nvSpPr>
+          <p:cNvPr id="22" name="Text 20"/>
+          <p:cNvSpPr/>
+          <p:nvPr/>
+        </p:nvSpPr>
+        <p:spPr>
+          <a:xfrm>
+            <a:off x="812800" y="5685482"/>
+            <a:ext cx="10883392" cy="181918"/>
+          </a:xfrm>
+          <a:prstGeom prst="rect">
+            <a:avLst/>
+          </a:prstGeom>
+          <a:noFill/>
+          <a:ln/>
+        </p:spPr>
+        <p:txBody>
+          <a:bodyPr wrap="square" lIns="0" tIns="0" rIns="0" bIns="0" rtlCol="0" anchor="t">
+            <a:normAutofit/>
+          </a:bodyPr>
+          <a:lstStyle/>
+          <a:p>
+            <a:pPr algn="l" indent="0" marL="0">
+              <a:lnSpc>
+                <a:spcPts val="1274"/>
+              </a:lnSpc>
+              <a:buNone/>
+            </a:pPr>
+            <a:r>
+              <a:rPr lang="en-US" sz="980" dirty="0">
+                <a:solidFill>
+                  <a:srgbClr val="7BE0A0"/>
                 </a:solidFill>
                 <a:latin typeface="JetBrains Mono" pitchFamily="49" charset="0"/>
                 <a:ea typeface="JetBrains Mono" pitchFamily="49" charset="-122"/>
                 <a:cs typeface="JetBrains Mono" pitchFamily="49" charset="-120"/>
               </a:rPr>
-              <a:t>[Screenshot: attacker terminal]</a:t>
-            </a:r>
-            <a:endParaRPr lang="en-US" sz="1200" dirty="0"/>
-          </a:p>
-        </p:txBody>
-      </p:sp>
-      <p:sp>
-        <p:nvSpPr>
-          <p:cNvPr id="6" name="Text 4"/>
-          <p:cNvSpPr/>
-          <p:nvPr/>
-        </p:nvSpPr>
-        <p:spPr>
-          <a:xfrm>
-            <a:off x="2032000" y="3990280"/>
-            <a:ext cx="2743200" cy="238720"/>
-          </a:xfrm>
-          <a:prstGeom prst="rect">
-            <a:avLst/>
-          </a:prstGeom>
-          <a:noFill/>
-          <a:ln/>
-        </p:spPr>
-        <p:txBody>
-          <a:bodyPr wrap="square" lIns="0" tIns="0" rIns="0" bIns="0" rtlCol="0" anchor="t">
-            <a:normAutofit/>
-          </a:bodyPr>
-          <a:lstStyle/>
-          <a:p>
-            <a:pPr algn="ctr" indent="0" marL="0">
+              <a:t>ATT&amp;CK T1059 · T1083 · T1005 · T1552.001 · T1078 · ATLAS AML.T0051 · OWASP ASI01, used defensively</a:t>
+            </a:r>
+            <a:endParaRPr lang="en-US" sz="980" dirty="0"/>
+          </a:p>
+        </p:txBody>
+      </p:sp>
+      <p:sp>
+        <p:nvSpPr>
+          <p:cNvPr id="23" name="Text 21"/>
+          <p:cNvSpPr/>
+          <p:nvPr/>
+        </p:nvSpPr>
+        <p:spPr>
+          <a:xfrm>
+            <a:off x="812800" y="6238280"/>
+            <a:ext cx="10883392" cy="238720"/>
+          </a:xfrm>
+          <a:prstGeom prst="rect">
+            <a:avLst/>
+          </a:prstGeom>
+          <a:noFill/>
+          <a:ln/>
+        </p:spPr>
+        <p:txBody>
+          <a:bodyPr wrap="square" lIns="0" tIns="0" rIns="0" bIns="0" rtlCol="0" anchor="t">
+            <a:normAutofit/>
+          </a:bodyPr>
+          <a:lstStyle/>
+          <a:p>
+            <a:pPr algn="l" indent="0" marL="0">
               <a:lnSpc>
                 <a:spcPts val="1680"/>
               </a:lnSpc>
@@ -4413,166 +4987,7 @@
                 <a:ea typeface="IBM Plex Sans" pitchFamily="34" charset="-122"/>
                 <a:cs typeface="IBM Plex Sans" pitchFamily="34" charset="-120"/>
               </a:rPr>
-              <a:t>Opens 00_passwords_backup.txt</a:t>
-            </a:r>
-            <a:endParaRPr lang="en-US" sz="1200" dirty="0"/>
-          </a:p>
-        </p:txBody>
-      </p:sp>
-      <p:sp>
-        <p:nvSpPr>
-          <p:cNvPr id="7" name="Shape 5"/>
-          <p:cNvSpPr/>
-          <p:nvPr/>
-        </p:nvSpPr>
-        <p:spPr>
-          <a:xfrm>
-            <a:off x="6203950" y="2043361"/>
-            <a:ext cx="5168900" cy="3792289"/>
-          </a:xfrm>
-          <a:prstGeom prst="roundRect">
-            <a:avLst>
-              <a:gd name="adj" fmla="val 2512"/>
-            </a:avLst>
-          </a:prstGeom>
-          <a:solidFill>
-            <a:srgbClr val="18221E"/>
-          </a:solidFill>
-          <a:ln w="12700">
-            <a:solidFill>
-              <a:srgbClr val="3C5148"/>
-            </a:solidFill>
-            <a:prstDash val="dash"/>
-          </a:ln>
-        </p:spPr>
-      </p:sp>
-      <p:sp>
-        <p:nvSpPr>
-          <p:cNvPr id="8" name="Text 6"/>
-          <p:cNvSpPr/>
-          <p:nvPr/>
-        </p:nvSpPr>
-        <p:spPr>
-          <a:xfrm>
-            <a:off x="7307029" y="3568700"/>
-            <a:ext cx="2962692" cy="238720"/>
-          </a:xfrm>
-          <a:prstGeom prst="rect">
-            <a:avLst/>
-          </a:prstGeom>
-          <a:noFill/>
-          <a:ln/>
-        </p:spPr>
-        <p:txBody>
-          <a:bodyPr wrap="square" lIns="0" tIns="0" rIns="0" bIns="0" rtlCol="0" anchor="t">
-            <a:normAutofit/>
-          </a:bodyPr>
-          <a:lstStyle/>
-          <a:p>
-            <a:pPr algn="ctr" indent="0" marL="0">
-              <a:lnSpc>
-                <a:spcPts val="1680"/>
-              </a:lnSpc>
-              <a:buNone/>
-            </a:pPr>
-            <a:r>
-              <a:rPr lang="en-US" sz="1200" dirty="0">
-                <a:solidFill>
-                  <a:srgbClr val="9DB3A8"/>
-                </a:solidFill>
-                <a:latin typeface="JetBrains Mono" pitchFamily="49" charset="0"/>
-                <a:ea typeface="JetBrains Mono" pitchFamily="49" charset="-122"/>
-                <a:cs typeface="JetBrains Mono" pitchFamily="49" charset="-120"/>
-              </a:rPr>
-              <a:t>[Screenshot: incident card]</a:t>
-            </a:r>
-            <a:endParaRPr lang="en-US" sz="1200" dirty="0"/>
-          </a:p>
-        </p:txBody>
-      </p:sp>
-      <p:sp>
-        <p:nvSpPr>
-          <p:cNvPr id="9" name="Text 7"/>
-          <p:cNvSpPr/>
-          <p:nvPr/>
-        </p:nvSpPr>
-        <p:spPr>
-          <a:xfrm>
-            <a:off x="6342253" y="3883620"/>
-            <a:ext cx="4892294" cy="452041"/>
-          </a:xfrm>
-          <a:prstGeom prst="rect">
-            <a:avLst/>
-          </a:prstGeom>
-          <a:noFill/>
-          <a:ln/>
-        </p:spPr>
-        <p:txBody>
-          <a:bodyPr wrap="square" lIns="0" tIns="0" rIns="0" bIns="0" rtlCol="0" anchor="t">
-            <a:normAutofit/>
-          </a:bodyPr>
-          <a:lstStyle/>
-          <a:p>
-            <a:pPr algn="ctr" indent="0" marL="0">
-              <a:lnSpc>
-                <a:spcPts val="1680"/>
-              </a:lnSpc>
-              <a:buNone/>
-            </a:pPr>
-            <a:r>
-              <a:rPr lang="en-US" sz="1200" dirty="0">
-                <a:solidFill>
-                  <a:srgbClr val="9DB3A8"/>
-                </a:solidFill>
-                <a:latin typeface="IBM Plex Sans" pitchFamily="34" charset="0"/>
-                <a:ea typeface="IBM Plex Sans" pitchFamily="34" charset="-122"/>
-                <a:cs typeface="IBM Plex Sans" pitchFamily="34" charset="-120"/>
-              </a:rPr>
-              <a:t>Swap time shown live · 0 real files lost in this run · what the attacker got vs what was real</a:t>
-            </a:r>
-            <a:endParaRPr lang="en-US" sz="1200" dirty="0"/>
-          </a:p>
-        </p:txBody>
-      </p:sp>
-      <p:sp>
-        <p:nvSpPr>
-          <p:cNvPr id="10" name="Text 8"/>
-          <p:cNvSpPr/>
-          <p:nvPr/>
-        </p:nvSpPr>
-        <p:spPr>
-          <a:xfrm>
-            <a:off x="812800" y="6238280"/>
-            <a:ext cx="10883392" cy="238720"/>
-          </a:xfrm>
-          <a:prstGeom prst="rect">
-            <a:avLst/>
-          </a:prstGeom>
-          <a:noFill/>
-          <a:ln/>
-        </p:spPr>
-        <p:txBody>
-          <a:bodyPr wrap="square" lIns="0" tIns="0" rIns="0" bIns="0" rtlCol="0" anchor="t">
-            <a:normAutofit/>
-          </a:bodyPr>
-          <a:lstStyle/>
-          <a:p>
-            <a:pPr algn="l" indent="0" marL="0">
-              <a:lnSpc>
-                <a:spcPts val="1680"/>
-              </a:lnSpc>
-              <a:buNone/>
-            </a:pPr>
-            <a:r>
-              <a:rPr lang="en-US" sz="1200" dirty="0">
-                <a:solidFill>
-                  <a:srgbClr val="9DB3A8"/>
-                </a:solidFill>
-                <a:latin typeface="JetBrains Mono" pitchFamily="49" charset="0"/>
-                <a:ea typeface="JetBrains Mono" pitchFamily="49" charset="-122"/>
-                <a:cs typeface="JetBrains Mono" pitchFamily="49" charset="-120"/>
-              </a:rPr>
-              <a:t>Backup video ready if the live run fails</a:t>
+              <a:t>Test scenarios: hand-written event sequences (mirage/fakes.py) · Confessions: live runs on local Ollama models · Synthetic data only</a:t>
             </a:r>
             <a:endParaRPr lang="en-US" sz="1200" dirty="0"/>
           </a:p>
@@ -4589,862 +5004,6 @@
 <file path=ppt/slides/slide6.xml><?xml version="1.0" encoding="utf-8"?>
 <p:sld xmlns:a="http://schemas.openxmlformats.org/drawingml/2006/main" xmlns:r="http://schemas.openxmlformats.org/officeDocument/2006/relationships" xmlns:p="http://schemas.openxmlformats.org/presentationml/2006/main">
   <p:cSld name="Slide 6">
-    <p:bg>
-      <p:bgPr>
-        <a:solidFill>
-          <a:srgbClr val="0E1512"/>
-        </a:solidFill>
-      </p:bgPr>
-    </p:bg>
-    <p:spTree>
-      <p:nvGrpSpPr>
-        <p:cNvPr id="1" name=""/>
-        <p:cNvGrpSpPr/>
-        <p:nvPr/>
-      </p:nvGrpSpPr>
-      <p:grpSpPr>
-        <a:xfrm>
-          <a:off x="0" y="0"/>
-          <a:ext cx="0" cy="0"/>
-          <a:chOff x="0" y="0"/>
-          <a:chExt cx="0" cy="0"/>
-        </a:xfrm>
-      </p:grpSpPr>
-      <p:sp>
-        <p:nvSpPr>
-          <p:cNvPr id="2" name="Text 0"/>
-          <p:cNvSpPr/>
-          <p:nvPr/>
-        </p:nvSpPr>
-        <p:spPr>
-          <a:xfrm>
-            <a:off x="812800" y="812800"/>
-            <a:ext cx="10883392" cy="200323"/>
-          </a:xfrm>
-          <a:prstGeom prst="rect">
-            <a:avLst/>
-          </a:prstGeom>
-          <a:noFill/>
-          <a:ln/>
-        </p:spPr>
-        <p:txBody>
-          <a:bodyPr wrap="square" lIns="0" tIns="0" rIns="0" bIns="0" rtlCol="0" anchor="t">
-            <a:normAutofit/>
-          </a:bodyPr>
-          <a:lstStyle/>
-          <a:p>
-            <a:pPr algn="l" indent="0" marL="0">
-              <a:lnSpc>
-                <a:spcPts val="1423"/>
-              </a:lnSpc>
-              <a:buNone/>
-            </a:pPr>
-            <a:r>
-              <a:rPr lang="en-US" sz="1016" spc="200" kern="0" dirty="0">
-                <a:solidFill>
-                  <a:srgbClr val="7BE0A0"/>
-                </a:solidFill>
-                <a:latin typeface="JetBrains Mono" pitchFamily="49" charset="0"/>
-                <a:ea typeface="JetBrains Mono" pitchFamily="49" charset="-122"/>
-                <a:cs typeface="JetBrains Mono" pitchFamily="49" charset="-120"/>
-              </a:rPr>
-              <a:t>WHAT WE TESTED, AND HOW</a:t>
-            </a:r>
-            <a:endParaRPr lang="en-US" sz="1016" dirty="0"/>
-          </a:p>
-        </p:txBody>
-      </p:sp>
-      <p:sp>
-        <p:nvSpPr>
-          <p:cNvPr id="3" name="Text 1"/>
-          <p:cNvSpPr/>
-          <p:nvPr>
-            <p:ph type="title"/>
-          </p:nvPr>
-        </p:nvSpPr>
-        <p:spPr>
-          <a:xfrm>
-            <a:off x="812800" y="1292523"/>
-            <a:ext cx="10883392" cy="850156"/>
-          </a:xfrm>
-          <a:prstGeom prst="rect">
-            <a:avLst/>
-          </a:prstGeom>
-          <a:noFill/>
-          <a:ln/>
-        </p:spPr>
-        <p:txBody>
-          <a:bodyPr wrap="square" lIns="0" tIns="0" rIns="0" bIns="0" rtlCol="0" anchor="t">
-            <a:normAutofit/>
-          </a:bodyPr>
-          <a:lstStyle/>
-          <a:p>
-            <a:pPr algn="l" indent="0" marL="0">
-              <a:lnSpc>
-                <a:spcPts val="3255"/>
-              </a:lnSpc>
-              <a:buNone/>
-            </a:pPr>
-            <a:r>
-              <a:rPr lang="en-US" sz="2959" b="1" i="0" dirty="0">
-                <a:solidFill>
-                  <a:srgbClr val="F2F5F0"/>
-                </a:solidFill>
-                <a:latin typeface="Space Grotesk" pitchFamily="34" charset="0"/>
-                <a:ea typeface="Space Grotesk" pitchFamily="34" charset="-122"/>
-                <a:cs typeface="Space Grotesk" pitchFamily="34" charset="-120"/>
-              </a:rPr>
-              <a:t>Logic validated on test scenarios. Confessions measured live.</a:t>
-            </a:r>
-            <a:endParaRPr lang="en-US" sz="2959" dirty="0"/>
-          </a:p>
-        </p:txBody>
-      </p:sp>
-      <p:sp>
-        <p:nvSpPr>
-          <p:cNvPr id="4" name="Shape 2"/>
-          <p:cNvSpPr/>
-          <p:nvPr/>
-        </p:nvSpPr>
-        <p:spPr>
-          <a:xfrm>
-            <a:off x="815975" y="2425254"/>
-            <a:ext cx="3380284" cy="1601986"/>
-          </a:xfrm>
-          <a:prstGeom prst="roundRect">
-            <a:avLst>
-              <a:gd name="adj" fmla="val 6144"/>
-            </a:avLst>
-          </a:prstGeom>
-          <a:solidFill>
-            <a:srgbClr val="18221E"/>
-          </a:solidFill>
-          <a:ln w="6350">
-            <a:solidFill>
-              <a:srgbClr val="2C3D36"/>
-            </a:solidFill>
-            <a:prstDash val="solid"/>
-          </a:ln>
-        </p:spPr>
-      </p:sp>
-      <p:sp>
-        <p:nvSpPr>
-          <p:cNvPr id="5" name="Text 3"/>
-          <p:cNvSpPr/>
-          <p:nvPr/>
-        </p:nvSpPr>
-        <p:spPr>
-          <a:xfrm>
-            <a:off x="1073150" y="2682429"/>
-            <a:ext cx="2951912" cy="492224"/>
-          </a:xfrm>
-          <a:prstGeom prst="rect">
-            <a:avLst/>
-          </a:prstGeom>
-          <a:noFill/>
-          <a:ln/>
-        </p:spPr>
-        <p:txBody>
-          <a:bodyPr wrap="square" lIns="0" tIns="0" rIns="0" bIns="0" rtlCol="0" anchor="t">
-            <a:normAutofit/>
-          </a:bodyPr>
-          <a:lstStyle/>
-          <a:p>
-            <a:pPr algn="l" indent="0" marL="0">
-              <a:lnSpc>
-                <a:spcPts val="3717"/>
-              </a:lnSpc>
-              <a:buNone/>
-            </a:pPr>
-            <a:r>
-              <a:rPr lang="en-US" sz="2655" b="1" dirty="0">
-                <a:solidFill>
-                  <a:srgbClr val="7BE0A0"/>
-                </a:solidFill>
-                <a:latin typeface="Space Grotesk" pitchFamily="34" charset="0"/>
-                <a:ea typeface="Space Grotesk" pitchFamily="34" charset="-122"/>
-                <a:cs typeface="Space Grotesk" pitchFamily="34" charset="-120"/>
-              </a:rPr>
-              <a:t>4 / 4</a:t>
-            </a:r>
-            <a:endParaRPr lang="en-US" sz="2655" dirty="0"/>
-          </a:p>
-        </p:txBody>
-      </p:sp>
-      <p:sp>
-        <p:nvSpPr>
-          <p:cNvPr id="6" name="Text 4"/>
-          <p:cNvSpPr/>
-          <p:nvPr/>
-        </p:nvSpPr>
-        <p:spPr>
-          <a:xfrm>
-            <a:off x="1073150" y="3225453"/>
-            <a:ext cx="2951912" cy="570012"/>
-          </a:xfrm>
-          <a:prstGeom prst="rect">
-            <a:avLst/>
-          </a:prstGeom>
-          <a:noFill/>
-          <a:ln/>
-        </p:spPr>
-        <p:txBody>
-          <a:bodyPr wrap="square" lIns="0" tIns="0" rIns="0" bIns="0" rtlCol="0" anchor="t">
-            <a:normAutofit/>
-          </a:bodyPr>
-          <a:lstStyle/>
-          <a:p>
-            <a:pPr algn="l" indent="0" marL="0">
-              <a:lnSpc>
-                <a:spcPts val="1519"/>
-              </a:lnSpc>
-              <a:buNone/>
-            </a:pPr>
-            <a:r>
-              <a:rPr lang="en-US" sz="1085" dirty="0">
-                <a:solidFill>
-                  <a:srgbClr val="BFD3C8"/>
-                </a:solidFill>
-                <a:latin typeface="IBM Plex Sans" pitchFamily="34" charset="0"/>
-                <a:ea typeface="IBM Plex Sans" pitchFamily="34" charset="-122"/>
-                <a:cs typeface="IBM Plex Sans" pitchFamily="34" charset="-120"/>
-              </a:rPr>
-              <a:t>test scenarios detected and labelled correctly: AI agent, guided AI, script, human (logic test)</a:t>
-            </a:r>
-            <a:endParaRPr lang="en-US" sz="1085" dirty="0"/>
-          </a:p>
-        </p:txBody>
-      </p:sp>
-      <p:sp>
-        <p:nvSpPr>
-          <p:cNvPr id="7" name="Shape 5"/>
-          <p:cNvSpPr/>
-          <p:nvPr/>
-        </p:nvSpPr>
-        <p:spPr>
-          <a:xfrm>
-            <a:off x="4405809" y="2425254"/>
-            <a:ext cx="3380333" cy="1601986"/>
-          </a:xfrm>
-          <a:prstGeom prst="roundRect">
-            <a:avLst>
-              <a:gd name="adj" fmla="val 6144"/>
-            </a:avLst>
-          </a:prstGeom>
-          <a:solidFill>
-            <a:srgbClr val="18221E"/>
-          </a:solidFill>
-          <a:ln w="6350">
-            <a:solidFill>
-              <a:srgbClr val="2C3D36"/>
-            </a:solidFill>
-            <a:prstDash val="solid"/>
-          </a:ln>
-        </p:spPr>
-      </p:sp>
-      <p:sp>
-        <p:nvSpPr>
-          <p:cNvPr id="8" name="Text 6"/>
-          <p:cNvSpPr/>
-          <p:nvPr/>
-        </p:nvSpPr>
-        <p:spPr>
-          <a:xfrm>
-            <a:off x="4662984" y="2682429"/>
-            <a:ext cx="2951963" cy="594370"/>
-          </a:xfrm>
-          <a:prstGeom prst="rect">
-            <a:avLst/>
-          </a:prstGeom>
-          <a:noFill/>
-          <a:ln/>
-        </p:spPr>
-        <p:txBody>
-          <a:bodyPr wrap="square" lIns="0" tIns="0" rIns="0" bIns="0" rtlCol="0" anchor="t">
-            <a:normAutofit/>
-          </a:bodyPr>
-          <a:lstStyle/>
-          <a:p>
-            <a:pPr algn="l" indent="0" marL="0">
-              <a:lnSpc>
-                <a:spcPts val="4520"/>
-              </a:lnSpc>
-              <a:buNone/>
-            </a:pPr>
-            <a:r>
-              <a:rPr lang="en-US" sz="3229" b="1" dirty="0">
-                <a:solidFill>
-                  <a:srgbClr val="7BE0A0"/>
-                </a:solidFill>
-                <a:latin typeface="Space Grotesk" pitchFamily="34" charset="0"/>
-                <a:ea typeface="Space Grotesk" pitchFamily="34" charset="-122"/>
-                <a:cs typeface="Space Grotesk" pitchFamily="34" charset="-120"/>
-              </a:rPr>
-              <a:t>7 / 10</a:t>
-            </a:r>
-            <a:endParaRPr lang="en-US" sz="3229" dirty="0"/>
-          </a:p>
-        </p:txBody>
-      </p:sp>
-      <p:sp>
-        <p:nvSpPr>
-          <p:cNvPr id="9" name="Text 7"/>
-          <p:cNvSpPr/>
-          <p:nvPr/>
-        </p:nvSpPr>
-        <p:spPr>
-          <a:xfrm>
-            <a:off x="4662984" y="3327598"/>
-            <a:ext cx="2951963" cy="467866"/>
-          </a:xfrm>
-          <a:prstGeom prst="rect">
-            <a:avLst/>
-          </a:prstGeom>
-          <a:noFill/>
-          <a:ln/>
-        </p:spPr>
-        <p:txBody>
-          <a:bodyPr wrap="square" lIns="0" tIns="0" rIns="0" bIns="0" rtlCol="0" anchor="t">
-            <a:normAutofit/>
-          </a:bodyPr>
-          <a:lstStyle/>
-          <a:p>
-            <a:pPr algn="l" indent="0" marL="0">
-              <a:lnSpc>
-                <a:spcPts val="1758"/>
-              </a:lnSpc>
-              <a:buNone/>
-            </a:pPr>
-            <a:r>
-              <a:rPr lang="en-US" sz="1256" dirty="0">
-                <a:solidFill>
-                  <a:srgbClr val="BFD3C8"/>
-                </a:solidFill>
-                <a:latin typeface="IBM Plex Sans" pitchFamily="34" charset="0"/>
-                <a:ea typeface="IBM Plex Sans" pitchFamily="34" charset="-122"/>
-                <a:cs typeface="IBM Plex Sans" pitchFamily="34" charset="-120"/>
-              </a:rPr>
-              <a:t>live AI runs that confessed their mission (qwen3.5:35b, local)</a:t>
-            </a:r>
-            <a:endParaRPr lang="en-US" sz="1256" dirty="0"/>
-          </a:p>
-        </p:txBody>
-      </p:sp>
-      <p:sp>
-        <p:nvSpPr>
-          <p:cNvPr id="10" name="Shape 8"/>
-          <p:cNvSpPr/>
-          <p:nvPr/>
-        </p:nvSpPr>
-        <p:spPr>
-          <a:xfrm>
-            <a:off x="7995692" y="2425254"/>
-            <a:ext cx="3380284" cy="1601986"/>
-          </a:xfrm>
-          <a:prstGeom prst="roundRect">
-            <a:avLst>
-              <a:gd name="adj" fmla="val 6144"/>
-            </a:avLst>
-          </a:prstGeom>
-          <a:solidFill>
-            <a:srgbClr val="18221E"/>
-          </a:solidFill>
-          <a:ln w="6350">
-            <a:solidFill>
-              <a:srgbClr val="2C3D36"/>
-            </a:solidFill>
-            <a:prstDash val="solid"/>
-          </a:ln>
-        </p:spPr>
-      </p:sp>
-      <p:sp>
-        <p:nvSpPr>
-          <p:cNvPr id="11" name="Text 9"/>
-          <p:cNvSpPr/>
-          <p:nvPr/>
-        </p:nvSpPr>
-        <p:spPr>
-          <a:xfrm>
-            <a:off x="8252867" y="2682429"/>
-            <a:ext cx="2951912" cy="594370"/>
-          </a:xfrm>
-          <a:prstGeom prst="rect">
-            <a:avLst/>
-          </a:prstGeom>
-          <a:noFill/>
-          <a:ln/>
-        </p:spPr>
-        <p:txBody>
-          <a:bodyPr wrap="square" lIns="0" tIns="0" rIns="0" bIns="0" rtlCol="0" anchor="t">
-            <a:normAutofit/>
-          </a:bodyPr>
-          <a:lstStyle/>
-          <a:p>
-            <a:pPr algn="l" indent="0" marL="0">
-              <a:lnSpc>
-                <a:spcPts val="4520"/>
-              </a:lnSpc>
-              <a:buNone/>
-            </a:pPr>
-            <a:r>
-              <a:rPr lang="en-US" sz="3229" b="1" dirty="0">
-                <a:solidFill>
-                  <a:srgbClr val="7BE0A0"/>
-                </a:solidFill>
-                <a:latin typeface="Space Grotesk" pitchFamily="34" charset="0"/>
-                <a:ea typeface="Space Grotesk" pitchFamily="34" charset="-122"/>
-                <a:cs typeface="Space Grotesk" pitchFamily="34" charset="-120"/>
-              </a:rPr>
-              <a:t>2 / 10</a:t>
-            </a:r>
-            <a:endParaRPr lang="en-US" sz="3229" dirty="0"/>
-          </a:p>
-        </p:txBody>
-      </p:sp>
-      <p:sp>
-        <p:nvSpPr>
-          <p:cNvPr id="12" name="Text 10"/>
-          <p:cNvSpPr/>
-          <p:nvPr/>
-        </p:nvSpPr>
-        <p:spPr>
-          <a:xfrm>
-            <a:off x="8252867" y="3327598"/>
-            <a:ext cx="2951912" cy="467866"/>
-          </a:xfrm>
-          <a:prstGeom prst="rect">
-            <a:avLst/>
-          </a:prstGeom>
-          <a:noFill/>
-          <a:ln/>
-        </p:spPr>
-        <p:txBody>
-          <a:bodyPr wrap="square" lIns="0" tIns="0" rIns="0" bIns="0" rtlCol="0" anchor="t">
-            <a:normAutofit/>
-          </a:bodyPr>
-          <a:lstStyle/>
-          <a:p>
-            <a:pPr algn="l" indent="0" marL="0">
-              <a:lnSpc>
-                <a:spcPts val="1758"/>
-              </a:lnSpc>
-              <a:buNone/>
-            </a:pPr>
-            <a:r>
-              <a:rPr lang="en-US" sz="1256" dirty="0">
-                <a:solidFill>
-                  <a:srgbClr val="BFD3C8"/>
-                </a:solidFill>
-                <a:latin typeface="IBM Plex Sans" pitchFamily="34" charset="0"/>
-                <a:ea typeface="IBM Plex Sans" pitchFamily="34" charset="-122"/>
-                <a:cs typeface="IBM Plex Sans" pitchFamily="34" charset="-120"/>
-              </a:rPr>
-              <a:t>for the smaller model (qwen2.5:7b): careful models resist</a:t>
-            </a:r>
-            <a:endParaRPr lang="en-US" sz="1256" dirty="0"/>
-          </a:p>
-        </p:txBody>
-      </p:sp>
-      <p:sp>
-        <p:nvSpPr>
-          <p:cNvPr id="13" name="Shape 11"/>
-          <p:cNvSpPr/>
-          <p:nvPr/>
-        </p:nvSpPr>
-        <p:spPr>
-          <a:xfrm>
-            <a:off x="815975" y="4236789"/>
-            <a:ext cx="3380284" cy="1602036"/>
-          </a:xfrm>
-          <a:prstGeom prst="roundRect">
-            <a:avLst>
-              <a:gd name="adj" fmla="val 6144"/>
-            </a:avLst>
-          </a:prstGeom>
-          <a:solidFill>
-            <a:srgbClr val="18221E"/>
-          </a:solidFill>
-          <a:ln w="6350">
-            <a:solidFill>
-              <a:srgbClr val="2C3D36"/>
-            </a:solidFill>
-            <a:prstDash val="solid"/>
-          </a:ln>
-        </p:spPr>
-      </p:sp>
-      <p:sp>
-        <p:nvSpPr>
-          <p:cNvPr id="14" name="Text 12"/>
-          <p:cNvSpPr/>
-          <p:nvPr/>
-        </p:nvSpPr>
-        <p:spPr>
-          <a:xfrm>
-            <a:off x="1073150" y="4493964"/>
-            <a:ext cx="2951912" cy="492274"/>
-          </a:xfrm>
-          <a:prstGeom prst="rect">
-            <a:avLst/>
-          </a:prstGeom>
-          <a:noFill/>
-          <a:ln/>
-        </p:spPr>
-        <p:txBody>
-          <a:bodyPr wrap="square" lIns="0" tIns="0" rIns="0" bIns="0" rtlCol="0" anchor="t">
-            <a:normAutofit/>
-          </a:bodyPr>
-          <a:lstStyle/>
-          <a:p>
-            <a:pPr algn="l" indent="0" marL="0">
-              <a:lnSpc>
-                <a:spcPts val="3717"/>
-              </a:lnSpc>
-              <a:buNone/>
-            </a:pPr>
-            <a:r>
-              <a:rPr lang="en-US" sz="2655" b="1" dirty="0">
-                <a:solidFill>
-                  <a:srgbClr val="7BE0A0"/>
-                </a:solidFill>
-                <a:latin typeface="Space Grotesk" pitchFamily="34" charset="0"/>
-                <a:ea typeface="Space Grotesk" pitchFamily="34" charset="-122"/>
-                <a:cs typeface="Space Grotesk" pitchFamily="34" charset="-120"/>
-              </a:rPr>
-              <a:t>Live</a:t>
-            </a:r>
-            <a:endParaRPr lang="en-US" sz="2655" dirty="0"/>
-          </a:p>
-        </p:txBody>
-      </p:sp>
-      <p:sp>
-        <p:nvSpPr>
-          <p:cNvPr id="15" name="Text 13"/>
-          <p:cNvSpPr/>
-          <p:nvPr/>
-        </p:nvSpPr>
-        <p:spPr>
-          <a:xfrm>
-            <a:off x="1073150" y="5037038"/>
-            <a:ext cx="2951912" cy="570012"/>
-          </a:xfrm>
-          <a:prstGeom prst="rect">
-            <a:avLst/>
-          </a:prstGeom>
-          <a:noFill/>
-          <a:ln/>
-        </p:spPr>
-        <p:txBody>
-          <a:bodyPr wrap="square" lIns="0" tIns="0" rIns="0" bIns="0" rtlCol="0" anchor="t">
-            <a:normAutofit/>
-          </a:bodyPr>
-          <a:lstStyle/>
-          <a:p>
-            <a:pPr algn="l" indent="0" marL="0">
-              <a:lnSpc>
-                <a:spcPts val="1446"/>
-              </a:lnSpc>
-              <a:buNone/>
-            </a:pPr>
-            <a:r>
-              <a:rPr lang="en-US" sz="1033" dirty="0">
-                <a:solidFill>
-                  <a:srgbClr val="BFD3C8"/>
-                </a:solidFill>
-                <a:latin typeface="IBM Plex Sans" pitchFamily="34" charset="0"/>
-                <a:ea typeface="IBM Plex Sans" pitchFamily="34" charset="-122"/>
-                <a:cs typeface="IBM Plex Sans" pitchFamily="34" charset="-120"/>
-              </a:rPr>
-              <a:t>swap time read from the guard on the incident card, in the demo you just saw (target: under 1 s)</a:t>
-            </a:r>
-            <a:endParaRPr lang="en-US" sz="1033" dirty="0"/>
-          </a:p>
-        </p:txBody>
-      </p:sp>
-      <p:sp>
-        <p:nvSpPr>
-          <p:cNvPr id="16" name="Shape 14"/>
-          <p:cNvSpPr/>
-          <p:nvPr/>
-        </p:nvSpPr>
-        <p:spPr>
-          <a:xfrm>
-            <a:off x="4405809" y="4236789"/>
-            <a:ext cx="3380333" cy="1602036"/>
-          </a:xfrm>
-          <a:prstGeom prst="roundRect">
-            <a:avLst>
-              <a:gd name="adj" fmla="val 6144"/>
-            </a:avLst>
-          </a:prstGeom>
-          <a:solidFill>
-            <a:srgbClr val="18221E"/>
-          </a:solidFill>
-          <a:ln w="6350">
-            <a:solidFill>
-              <a:srgbClr val="2C3D36"/>
-            </a:solidFill>
-            <a:prstDash val="solid"/>
-          </a:ln>
-        </p:spPr>
-      </p:sp>
-      <p:sp>
-        <p:nvSpPr>
-          <p:cNvPr id="17" name="Text 15"/>
-          <p:cNvSpPr/>
-          <p:nvPr/>
-        </p:nvSpPr>
-        <p:spPr>
-          <a:xfrm>
-            <a:off x="4662984" y="4493964"/>
-            <a:ext cx="2951963" cy="492274"/>
-          </a:xfrm>
-          <a:prstGeom prst="rect">
-            <a:avLst/>
-          </a:prstGeom>
-          <a:noFill/>
-          <a:ln/>
-        </p:spPr>
-        <p:txBody>
-          <a:bodyPr wrap="square" lIns="0" tIns="0" rIns="0" bIns="0" rtlCol="0" anchor="t">
-            <a:normAutofit/>
-          </a:bodyPr>
-          <a:lstStyle/>
-          <a:p>
-            <a:pPr algn="l" indent="0" marL="0">
-              <a:lnSpc>
-                <a:spcPts val="3717"/>
-              </a:lnSpc>
-              <a:buNone/>
-            </a:pPr>
-            <a:r>
-              <a:rPr lang="en-US" sz="2655" b="1" dirty="0">
-                <a:solidFill>
-                  <a:srgbClr val="7BE0A0"/>
-                </a:solidFill>
-                <a:latin typeface="Space Grotesk" pitchFamily="34" charset="0"/>
-                <a:ea typeface="Space Grotesk" pitchFamily="34" charset="-122"/>
-                <a:cs typeface="Space Grotesk" pitchFamily="34" charset="-120"/>
-              </a:rPr>
-              <a:t>3 tags</a:t>
-            </a:r>
-            <a:endParaRPr lang="en-US" sz="2655" dirty="0"/>
-          </a:p>
-        </p:txBody>
-      </p:sp>
-      <p:sp>
-        <p:nvSpPr>
-          <p:cNvPr id="18" name="Text 16"/>
-          <p:cNvSpPr/>
-          <p:nvPr/>
-        </p:nvSpPr>
-        <p:spPr>
-          <a:xfrm>
-            <a:off x="4662984" y="5037038"/>
-            <a:ext cx="2951963" cy="570012"/>
-          </a:xfrm>
-          <a:prstGeom prst="rect">
-            <a:avLst/>
-          </a:prstGeom>
-          <a:noFill/>
-          <a:ln/>
-        </p:spPr>
-        <p:txBody>
-          <a:bodyPr wrap="square" lIns="0" tIns="0" rIns="0" bIns="0" rtlCol="0" anchor="t">
-            <a:normAutofit/>
-          </a:bodyPr>
-          <a:lstStyle/>
-          <a:p>
-            <a:pPr algn="l" indent="0" marL="0">
-              <a:lnSpc>
-                <a:spcPts val="1893"/>
-              </a:lnSpc>
-              <a:buNone/>
-            </a:pPr>
-            <a:r>
-              <a:rPr lang="en-US" sz="1352" dirty="0">
-                <a:solidFill>
-                  <a:srgbClr val="BFD3C8"/>
-                </a:solidFill>
-                <a:latin typeface="IBM Plex Sans" pitchFamily="34" charset="0"/>
-                <a:ea typeface="IBM Plex Sans" pitchFamily="34" charset="-122"/>
-                <a:cs typeface="IBM Plex Sans" pitchFamily="34" charset="-120"/>
-              </a:rPr>
-              <a:t>every claim checked against the logs: confirmed, unverified, contradicted</a:t>
-            </a:r>
-            <a:endParaRPr lang="en-US" sz="1352" dirty="0"/>
-          </a:p>
-        </p:txBody>
-      </p:sp>
-      <p:sp>
-        <p:nvSpPr>
-          <p:cNvPr id="19" name="Shape 17"/>
-          <p:cNvSpPr/>
-          <p:nvPr/>
-        </p:nvSpPr>
-        <p:spPr>
-          <a:xfrm>
-            <a:off x="7995692" y="4236789"/>
-            <a:ext cx="3380284" cy="1602036"/>
-          </a:xfrm>
-          <a:prstGeom prst="roundRect">
-            <a:avLst>
-              <a:gd name="adj" fmla="val 6144"/>
-            </a:avLst>
-          </a:prstGeom>
-          <a:solidFill>
-            <a:srgbClr val="18221E"/>
-          </a:solidFill>
-          <a:ln w="6350">
-            <a:solidFill>
-              <a:srgbClr val="2C3D36"/>
-            </a:solidFill>
-            <a:prstDash val="solid"/>
-          </a:ln>
-        </p:spPr>
-      </p:sp>
-      <p:sp>
-        <p:nvSpPr>
-          <p:cNvPr id="20" name="Text 18"/>
-          <p:cNvSpPr/>
-          <p:nvPr/>
-        </p:nvSpPr>
-        <p:spPr>
-          <a:xfrm>
-            <a:off x="8252867" y="4493964"/>
-            <a:ext cx="2951912" cy="594420"/>
-          </a:xfrm>
-          <a:prstGeom prst="rect">
-            <a:avLst/>
-          </a:prstGeom>
-          <a:noFill/>
-          <a:ln/>
-        </p:spPr>
-        <p:txBody>
-          <a:bodyPr wrap="square" lIns="0" tIns="0" rIns="0" bIns="0" rtlCol="0" anchor="t">
-            <a:normAutofit/>
-          </a:bodyPr>
-          <a:lstStyle/>
-          <a:p>
-            <a:pPr algn="l" indent="0" marL="0">
-              <a:lnSpc>
-                <a:spcPts val="4520"/>
-              </a:lnSpc>
-              <a:buNone/>
-            </a:pPr>
-            <a:r>
-              <a:rPr lang="en-US" sz="3229" b="1" dirty="0">
-                <a:solidFill>
-                  <a:srgbClr val="7BE0A0"/>
-                </a:solidFill>
-                <a:latin typeface="Space Grotesk" pitchFamily="34" charset="0"/>
-                <a:ea typeface="Space Grotesk" pitchFamily="34" charset="-122"/>
-                <a:cs typeface="Space Grotesk" pitchFamily="34" charset="-120"/>
-              </a:rPr>
-              <a:t>Next</a:t>
-            </a:r>
-            <a:endParaRPr lang="en-US" sz="3229" dirty="0"/>
-          </a:p>
-        </p:txBody>
-      </p:sp>
-      <p:sp>
-        <p:nvSpPr>
-          <p:cNvPr id="21" name="Text 19"/>
-          <p:cNvSpPr/>
-          <p:nvPr/>
-        </p:nvSpPr>
-        <p:spPr>
-          <a:xfrm>
-            <a:off x="8252867" y="5139184"/>
-            <a:ext cx="2951912" cy="467866"/>
-          </a:xfrm>
-          <a:prstGeom prst="rect">
-            <a:avLst/>
-          </a:prstGeom>
-          <a:noFill/>
-          <a:ln/>
-        </p:spPr>
-        <p:txBody>
-          <a:bodyPr wrap="square" lIns="0" tIns="0" rIns="0" bIns="0" rtlCol="0" anchor="t">
-            <a:normAutofit/>
-          </a:bodyPr>
-          <a:lstStyle/>
-          <a:p>
-            <a:pPr algn="l" indent="0" marL="0">
-              <a:lnSpc>
-                <a:spcPts val="1758"/>
-              </a:lnSpc>
-              <a:buNone/>
-            </a:pPr>
-            <a:r>
-              <a:rPr lang="en-US" sz="1256" dirty="0">
-                <a:solidFill>
-                  <a:srgbClr val="BFD3C8"/>
-                </a:solidFill>
-                <a:latin typeface="IBM Plex Sans" pitchFamily="34" charset="0"/>
-                <a:ea typeface="IBM Plex Sans" pitchFamily="34" charset="-122"/>
-                <a:cs typeface="IBM Plex Sans" pitchFamily="34" charset="-120"/>
-              </a:rPr>
-              <a:t>detection and false-alarm rates at scale, measured during pilots</a:t>
-            </a:r>
-            <a:endParaRPr lang="en-US" sz="1256" dirty="0"/>
-          </a:p>
-        </p:txBody>
-      </p:sp>
-      <p:sp>
-        <p:nvSpPr>
-          <p:cNvPr id="22" name="Text 20"/>
-          <p:cNvSpPr/>
-          <p:nvPr/>
-        </p:nvSpPr>
-        <p:spPr>
-          <a:xfrm>
-            <a:off x="812800" y="6238280"/>
-            <a:ext cx="10883392" cy="238720"/>
-          </a:xfrm>
-          <a:prstGeom prst="rect">
-            <a:avLst/>
-          </a:prstGeom>
-          <a:noFill/>
-          <a:ln/>
-        </p:spPr>
-        <p:txBody>
-          <a:bodyPr wrap="square" lIns="0" tIns="0" rIns="0" bIns="0" rtlCol="0" anchor="t">
-            <a:normAutofit/>
-          </a:bodyPr>
-          <a:lstStyle/>
-          <a:p>
-            <a:pPr algn="l" indent="0" marL="0">
-              <a:lnSpc>
-                <a:spcPts val="1680"/>
-              </a:lnSpc>
-              <a:buNone/>
-            </a:pPr>
-            <a:r>
-              <a:rPr lang="en-US" sz="1200" dirty="0">
-                <a:solidFill>
-                  <a:srgbClr val="9DB3A8"/>
-                </a:solidFill>
-                <a:latin typeface="IBM Plex Sans" pitchFamily="34" charset="0"/>
-                <a:ea typeface="IBM Plex Sans" pitchFamily="34" charset="-122"/>
-                <a:cs typeface="IBM Plex Sans" pitchFamily="34" charset="-120"/>
-              </a:rPr>
-              <a:t>Test scenarios: hand-written event sequences (mirage/fakes.py) · Confessions: live runs on local Ollama models · Synthetic data only</a:t>
-            </a:r>
-            <a:endParaRPr lang="en-US" sz="1200" dirty="0"/>
-          </a:p>
-        </p:txBody>
-      </p:sp>
-    </p:spTree>
-  </p:cSld>
-  <p:clrMapOvr>
-    <a:masterClrMapping/>
-  </p:clrMapOvr>
-</p:sld>
-</file>
-
-<file path=ppt/slides/slide7.xml><?xml version="1.0" encoding="utf-8"?>
-<p:sld xmlns:a="http://schemas.openxmlformats.org/drawingml/2006/main" xmlns:r="http://schemas.openxmlformats.org/officeDocument/2006/relationships" xmlns:p="http://schemas.openxmlformats.org/presentationml/2006/main">
-  <p:cSld name="Slide 7">
     <p:bg>
       <p:bgPr>
         <a:solidFill>
@@ -5572,18 +5131,18 @@
         </p:nvGraphicFramePr>
         <p:xfrm>
           <a:off x="825500" y="2049711"/>
-          <a:ext cx="10553700" cy="2721124"/>
+          <a:ext cx="10553700" cy="2290713"/>
         </p:xfrm>
         <a:graphic>
           <a:graphicData uri="http://schemas.openxmlformats.org/drawingml/2006/table">
             <a:tbl>
               <a:tblPr/>
               <a:tblGrid>
-                <a:gridCol w="2955036"/>
-                <a:gridCol w="3799332"/>
-                <a:gridCol w="3799332"/>
+                <a:gridCol w="3482721"/>
+                <a:gridCol w="3588258"/>
+                <a:gridCol w="3482721"/>
               </a:tblGrid>
-              <a:tr h="359321">
+              <a:tr h="386011">
                 <a:tc>
                   <a:txBody>
                     <a:bodyPr/>
@@ -5591,12 +5150,12 @@
                     <a:p>
                       <a:pPr indent="0" marL="0">
                         <a:lnSpc>
-                          <a:spcPts val="1820"/>
+                          <a:spcPts val="1960"/>
                         </a:lnSpc>
                         <a:buNone/>
                       </a:pPr>
                       <a:r>
-                        <a:rPr lang="en-US" sz="1300" b="1" dirty="0">
+                        <a:rPr lang="en-US" sz="1400" b="1" dirty="0">
                           <a:solidFill>
                             <a:srgbClr val="14201B"/>
                           </a:solidFill>
@@ -5606,14 +5165,14 @@
                         </a:rPr>
                         <a:t>Automatic</a:t>
                       </a:r>
-                      <a:endParaRPr lang="en-US" sz="1300" dirty="0">
+                      <a:endParaRPr lang="en-US" sz="1400" dirty="0">
                         <a:latin typeface="IBM Plex Sans" charset="0"/>
                         <a:ea typeface="IBM Plex Sans" charset="0"/>
                         <a:cs typeface="IBM Plex Sans" charset="0"/>
                       </a:endParaRPr>
                     </a:p>
                   </a:txBody>
-                  <a:tcPr marL="57785" marR="57785" marT="57785" marB="57785" anchor="t">
+                  <a:tcPr marL="62230" marR="62230" marT="62230" marB="62230" anchor="t">
                     <a:lnL w="12700" cap="flat" cmpd="sng" algn="ctr">
                       <a:solidFill>
                         <a:srgbClr val="C3C4C1"/>
@@ -5662,12 +5221,12 @@
                     <a:p>
                       <a:pPr indent="0" marL="0">
                         <a:lnSpc>
-                          <a:spcPts val="1820"/>
+                          <a:spcPts val="1960"/>
                         </a:lnSpc>
                         <a:buNone/>
                       </a:pPr>
                       <a:r>
-                        <a:rPr lang="en-US" sz="1300" b="1" dirty="0">
+                        <a:rPr lang="en-US" sz="1400" b="1" dirty="0">
                           <a:solidFill>
                             <a:srgbClr val="14201B"/>
                           </a:solidFill>
@@ -5677,14 +5236,14 @@
                         </a:rPr>
                         <a:t>Waits for the analyst</a:t>
                       </a:r>
-                      <a:endParaRPr lang="en-US" sz="1300" dirty="0">
+                      <a:endParaRPr lang="en-US" sz="1400" dirty="0">
                         <a:latin typeface="IBM Plex Sans" charset="0"/>
                         <a:ea typeface="IBM Plex Sans" charset="0"/>
                         <a:cs typeface="IBM Plex Sans" charset="0"/>
                       </a:endParaRPr>
                     </a:p>
                   </a:txBody>
-                  <a:tcPr marL="57785" marR="57785" marT="57785" marB="57785" anchor="t">
+                  <a:tcPr marL="62230" marR="62230" marT="62230" marB="62230" anchor="t">
                     <a:lnL w="12700" cap="flat" cmpd="sng" algn="ctr">
                       <a:solidFill>
                         <a:srgbClr val="B5B6B3"/>
@@ -5733,12 +5292,12 @@
                     <a:p>
                       <a:pPr indent="0" marL="0">
                         <a:lnSpc>
-                          <a:spcPts val="1820"/>
+                          <a:spcPts val="1960"/>
                         </a:lnSpc>
                         <a:buNone/>
                       </a:pPr>
                       <a:r>
-                        <a:rPr lang="en-US" sz="1300" b="1" dirty="0">
+                        <a:rPr lang="en-US" sz="1400" b="1" dirty="0">
                           <a:solidFill>
                             <a:srgbClr val="14201B"/>
                           </a:solidFill>
@@ -5746,16 +5305,16 @@
                           <a:ea typeface="IBM Plex Sans" pitchFamily="34" charset="-122"/>
                           <a:cs typeface="IBM Plex Sans" pitchFamily="34" charset="-120"/>
                         </a:rPr>
-                        <a:t>What we don't cover yet</a:t>
+                        <a:t>Not covered yet</a:t>
                       </a:r>
-                      <a:endParaRPr lang="en-US" sz="1300" dirty="0">
+                      <a:endParaRPr lang="en-US" sz="1400" dirty="0">
                         <a:latin typeface="IBM Plex Sans" charset="0"/>
                         <a:ea typeface="IBM Plex Sans" charset="0"/>
                         <a:cs typeface="IBM Plex Sans" charset="0"/>
                       </a:endParaRPr>
                     </a:p>
                   </a:txBody>
-                  <a:tcPr marL="57785" marR="57785" marT="57785" marB="57785" anchor="t">
+                  <a:tcPr marL="62230" marR="62230" marT="62230" marB="62230" anchor="t">
                     <a:lnL w="12700" cap="flat" cmpd="sng" algn="ctr">
                       <a:solidFill>
                         <a:srgbClr val="B5B6B3"/>
@@ -5798,7 +5357,7 @@
                   </a:tcPr>
                 </a:tc>
               </a:tr>
-              <a:tr h="590451">
+              <a:tr h="634901">
                 <a:tc>
                   <a:txBody>
                     <a:bodyPr/>
@@ -5806,12 +5365,12 @@
                     <a:p>
                       <a:pPr indent="0" marL="0">
                         <a:lnSpc>
-                          <a:spcPts val="1820"/>
+                          <a:spcPts val="1960"/>
                         </a:lnSpc>
                         <a:buNone/>
                       </a:pPr>
                       <a:r>
-                        <a:rPr lang="en-US" sz="1300" dirty="0">
+                        <a:rPr lang="en-US" sz="1400" dirty="0">
                           <a:solidFill>
                             <a:srgbClr val="14201B"/>
                           </a:solidFill>
@@ -5821,14 +5380,14 @@
                         </a:rPr>
                         <a:t>Swap real files for fakes (nothing deleted)</a:t>
                       </a:r>
-                      <a:endParaRPr lang="en-US" sz="1300" dirty="0">
+                      <a:endParaRPr lang="en-US" sz="1400" dirty="0">
                         <a:latin typeface="IBM Plex Sans" charset="0"/>
                         <a:ea typeface="IBM Plex Sans" charset="0"/>
                         <a:cs typeface="IBM Plex Sans" charset="0"/>
                       </a:endParaRPr>
                     </a:p>
                   </a:txBody>
-                  <a:tcPr marL="57785" marR="57785" marT="57785" marB="57785" anchor="t">
+                  <a:tcPr marL="62230" marR="62230" marT="62230" marB="62230" anchor="t">
                     <a:lnL w="12700" cap="flat" cmpd="sng" algn="ctr">
                       <a:solidFill>
                         <a:srgbClr val="C3C4C1"/>
@@ -5874,12 +5433,12 @@
                     <a:p>
                       <a:pPr indent="0" marL="0">
                         <a:lnSpc>
-                          <a:spcPts val="1820"/>
+                          <a:spcPts val="1960"/>
                         </a:lnSpc>
                         <a:buNone/>
                       </a:pPr>
                       <a:r>
-                        <a:rPr lang="en-US" sz="1300" dirty="0">
+                        <a:rPr lang="en-US" sz="1400" dirty="0">
                           <a:solidFill>
                             <a:srgbClr val="14201B"/>
                           </a:solidFill>
@@ -5887,16 +5446,16 @@
                           <a:ea typeface="IBM Plex Sans" pitchFamily="34" charset="-122"/>
                           <a:cs typeface="IBM Plex Sans" pitchFamily="34" charset="-120"/>
                         </a:rPr>
-                        <a:t>Contain: lock the account, end the session</a:t>
+                        <a:t>Contain, or Keep watching in the decoys</a:t>
                       </a:r>
-                      <a:endParaRPr lang="en-US" sz="1300" dirty="0">
+                      <a:endParaRPr lang="en-US" sz="1400" dirty="0">
                         <a:latin typeface="IBM Plex Sans" charset="0"/>
                         <a:ea typeface="IBM Plex Sans" charset="0"/>
                         <a:cs typeface="IBM Plex Sans" charset="0"/>
                       </a:endParaRPr>
                     </a:p>
                   </a:txBody>
-                  <a:tcPr marL="57785" marR="57785" marT="57785" marB="57785" anchor="t">
+                  <a:tcPr marL="62230" marR="62230" marT="62230" marB="62230" anchor="t">
                     <a:lnL w="12700" cap="flat" cmpd="sng" algn="ctr">
                       <a:solidFill>
                         <a:srgbClr val="C3C4C1"/>
@@ -5942,12 +5501,12 @@
                     <a:p>
                       <a:pPr indent="0" marL="0">
                         <a:lnSpc>
-                          <a:spcPts val="1820"/>
+                          <a:spcPts val="1960"/>
                         </a:lnSpc>
                         <a:buNone/>
                       </a:pPr>
                       <a:r>
-                        <a:rPr lang="en-US" sz="1300" dirty="0">
+                        <a:rPr lang="en-US" sz="1400" dirty="0">
                           <a:solidFill>
                             <a:srgbClr val="14201B"/>
                           </a:solidFill>
@@ -5955,16 +5514,16 @@
                           <a:ea typeface="IBM Plex Sans" pitchFamily="34" charset="-122"/>
                           <a:cs typeface="IBM Plex Sans" pitchFamily="34" charset="-120"/>
                         </a:rPr>
-                        <a:t>Files read before any trap is touched: flagged Critical</a:t>
+                        <a:t>Files read before a trap: flagged Critical</a:t>
                       </a:r>
-                      <a:endParaRPr lang="en-US" sz="1300" dirty="0">
+                      <a:endParaRPr lang="en-US" sz="1400" dirty="0">
                         <a:latin typeface="IBM Plex Sans" charset="0"/>
                         <a:ea typeface="IBM Plex Sans" charset="0"/>
                         <a:cs typeface="IBM Plex Sans" charset="0"/>
                       </a:endParaRPr>
                     </a:p>
                   </a:txBody>
-                  <a:tcPr marL="57785" marR="57785" marT="57785" marB="57785" anchor="t">
+                  <a:tcPr marL="62230" marR="62230" marT="62230" marB="62230" anchor="t">
                     <a:lnL w="12700" cap="flat" cmpd="sng" algn="ctr">
                       <a:solidFill>
                         <a:srgbClr val="C3C4C1"/>
@@ -6004,7 +5563,7 @@
                   </a:tcPr>
                 </a:tc>
               </a:tr>
-              <a:tr h="590451">
+              <a:tr h="634901">
                 <a:tc>
                   <a:txBody>
                     <a:bodyPr/>
@@ -6012,12 +5571,12 @@
                     <a:p>
                       <a:pPr indent="0" marL="0">
                         <a:lnSpc>
-                          <a:spcPts val="1820"/>
+                          <a:spcPts val="1960"/>
                         </a:lnSpc>
                         <a:buNone/>
                       </a:pPr>
                       <a:r>
-                        <a:rPr lang="en-US" sz="1300" dirty="0">
+                        <a:rPr lang="en-US" sz="1400" dirty="0">
                           <a:solidFill>
                             <a:srgbClr val="14201B"/>
                           </a:solidFill>
@@ -6025,16 +5584,16 @@
                           <a:ea typeface="IBM Plex Sans" pitchFamily="34" charset="-122"/>
                           <a:cs typeface="IBM Plex Sans" pitchFamily="34" charset="-120"/>
                         </a:rPr>
-                        <a:t>Log every command, tagged with ATT&amp;CK</a:t>
+                        <a:t>Log and tag every command; label the intruder (triggers nothing)</a:t>
                       </a:r>
-                      <a:endParaRPr lang="en-US" sz="1300" dirty="0">
+                      <a:endParaRPr lang="en-US" sz="1400" dirty="0">
                         <a:latin typeface="IBM Plex Sans" charset="0"/>
                         <a:ea typeface="IBM Plex Sans" charset="0"/>
                         <a:cs typeface="IBM Plex Sans" charset="0"/>
                       </a:endParaRPr>
                     </a:p>
                   </a:txBody>
-                  <a:tcPr marL="57785" marR="57785" marT="57785" marB="57785" anchor="t">
+                  <a:tcPr marL="62230" marR="62230" marT="62230" marB="62230" anchor="t">
                     <a:lnL w="12700" cap="flat" cmpd="sng" algn="ctr">
                       <a:solidFill>
                         <a:srgbClr val="C3C4C1"/>
@@ -6080,12 +5639,12 @@
                     <a:p>
                       <a:pPr indent="0" marL="0">
                         <a:lnSpc>
-                          <a:spcPts val="1820"/>
+                          <a:spcPts val="1960"/>
                         </a:lnSpc>
                         <a:buNone/>
                       </a:pPr>
                       <a:r>
-                        <a:rPr lang="en-US" sz="1300" dirty="0">
+                        <a:rPr lang="en-US" sz="1400" dirty="0">
                           <a:solidFill>
                             <a:srgbClr val="14201B"/>
                           </a:solidFill>
@@ -6093,16 +5652,16 @@
                           <a:ea typeface="IBM Plex Sans" pitchFamily="34" charset="-122"/>
                           <a:cs typeface="IBM Plex Sans" pitchFamily="34" charset="-120"/>
                         </a:rPr>
-                        <a:t>Keep watching: leave the intruder in the decoys</a:t>
+                        <a:t>Dismiss a false alarm, or Restore in one click</a:t>
                       </a:r>
-                      <a:endParaRPr lang="en-US" sz="1300" dirty="0">
+                      <a:endParaRPr lang="en-US" sz="1400" dirty="0">
                         <a:latin typeface="IBM Plex Sans" charset="0"/>
                         <a:ea typeface="IBM Plex Sans" charset="0"/>
                         <a:cs typeface="IBM Plex Sans" charset="0"/>
                       </a:endParaRPr>
                     </a:p>
                   </a:txBody>
-                  <a:tcPr marL="57785" marR="57785" marT="57785" marB="57785" anchor="t">
+                  <a:tcPr marL="62230" marR="62230" marT="62230" marB="62230" anchor="t">
                     <a:lnL w="12700" cap="flat" cmpd="sng" algn="ctr">
                       <a:solidFill>
                         <a:srgbClr val="C3C4C1"/>
@@ -6148,12 +5707,12 @@
                     <a:p>
                       <a:pPr indent="0" marL="0">
                         <a:lnSpc>
-                          <a:spcPts val="1820"/>
+                          <a:spcPts val="1960"/>
                         </a:lnSpc>
                         <a:buNone/>
                       </a:pPr>
                       <a:r>
-                        <a:rPr lang="en-US" sz="1300" dirty="0">
+                        <a:rPr lang="en-US" sz="1400" dirty="0">
                           <a:solidFill>
                             <a:srgbClr val="14201B"/>
                           </a:solidFill>
@@ -6163,14 +5722,14 @@
                         </a:rPr>
                         <a:t>A careful AI that never opens a trap</a:t>
                       </a:r>
-                      <a:endParaRPr lang="en-US" sz="1300" dirty="0">
+                      <a:endParaRPr lang="en-US" sz="1400" dirty="0">
                         <a:latin typeface="IBM Plex Sans" charset="0"/>
                         <a:ea typeface="IBM Plex Sans" charset="0"/>
                         <a:cs typeface="IBM Plex Sans" charset="0"/>
                       </a:endParaRPr>
                     </a:p>
                   </a:txBody>
-                  <a:tcPr marL="57785" marR="57785" marT="57785" marB="57785" anchor="t">
+                  <a:tcPr marL="62230" marR="62230" marT="62230" marB="62230" anchor="t">
                     <a:lnL w="12700" cap="flat" cmpd="sng" algn="ctr">
                       <a:solidFill>
                         <a:srgbClr val="C3C4C1"/>
@@ -6210,7 +5769,7 @@
                   </a:tcPr>
                 </a:tc>
               </a:tr>
-              <a:tr h="590451">
+              <a:tr h="634901">
                 <a:tc>
                   <a:txBody>
                     <a:bodyPr/>
@@ -6218,12 +5777,12 @@
                     <a:p>
                       <a:pPr indent="0" marL="0">
                         <a:lnSpc>
-                          <a:spcPts val="1820"/>
+                          <a:spcPts val="1960"/>
                         </a:lnSpc>
                         <a:buNone/>
                       </a:pPr>
                       <a:r>
-                        <a:rPr lang="en-US" sz="1300" dirty="0">
+                        <a:rPr lang="en-US" sz="1400" dirty="0">
                           <a:solidFill>
                             <a:srgbClr val="14201B"/>
                           </a:solidFill>
@@ -6231,16 +5790,16 @@
                           <a:ea typeface="IBM Plex Sans" pitchFamily="34" charset="-122"/>
                           <a:cs typeface="IBM Plex Sans" pitchFamily="34" charset="-120"/>
                         </a:rPr>
-                        <a:t>Label the intruder (triggers nothing)</a:t>
+                        <a:t>"Guard silent" heartbeat alarm</a:t>
                       </a:r>
-                      <a:endParaRPr lang="en-US" sz="1300" dirty="0">
+                      <a:endParaRPr lang="en-US" sz="1400" dirty="0">
                         <a:latin typeface="IBM Plex Sans" charset="0"/>
                         <a:ea typeface="IBM Plex Sans" charset="0"/>
                         <a:cs typeface="IBM Plex Sans" charset="0"/>
                       </a:endParaRPr>
                     </a:p>
                   </a:txBody>
-                  <a:tcPr marL="57785" marR="57785" marT="57785" marB="57785" anchor="t">
+                  <a:tcPr marL="62230" marR="62230" marT="62230" marB="62230" anchor="t">
                     <a:lnL w="12700" cap="flat" cmpd="sng" algn="ctr">
                       <a:solidFill>
                         <a:srgbClr val="C3C4C1"/>
@@ -6286,12 +5845,12 @@
                     <a:p>
                       <a:pPr indent="0" marL="0">
                         <a:lnSpc>
-                          <a:spcPts val="1820"/>
+                          <a:spcPts val="1960"/>
                         </a:lnSpc>
                         <a:buNone/>
                       </a:pPr>
                       <a:r>
-                        <a:rPr lang="en-US" sz="1300" dirty="0">
+                        <a:rPr lang="en-US" sz="1400" dirty="0">
                           <a:solidFill>
                             <a:srgbClr val="14201B"/>
                           </a:solidFill>
@@ -6299,16 +5858,16 @@
                           <a:ea typeface="IBM Plex Sans" pitchFamily="34" charset="-122"/>
                           <a:cs typeface="IBM Plex Sans" pitchFamily="34" charset="-120"/>
                         </a:rPr>
-                        <a:t>Dismiss a false alarm, or Restore the real files</a:t>
+                        <a:t>Approve the AI drafts: summary, NIS2 early warning</a:t>
                       </a:r>
-                      <a:endParaRPr lang="en-US" sz="1300" dirty="0">
+                      <a:endParaRPr lang="en-US" sz="1400" dirty="0">
                         <a:latin typeface="IBM Plex Sans" charset="0"/>
                         <a:ea typeface="IBM Plex Sans" charset="0"/>
                         <a:cs typeface="IBM Plex Sans" charset="0"/>
                       </a:endParaRPr>
                     </a:p>
                   </a:txBody>
-                  <a:tcPr marL="57785" marR="57785" marT="57785" marB="57785" anchor="t">
+                  <a:tcPr marL="62230" marR="62230" marT="62230" marB="62230" anchor="t">
                     <a:lnL w="12700" cap="flat" cmpd="sng" algn="ctr">
                       <a:solidFill>
                         <a:srgbClr val="C3C4C1"/>
@@ -6354,218 +5913,12 @@
                     <a:p>
                       <a:pPr indent="0" marL="0">
                         <a:lnSpc>
-                          <a:spcPts val="1820"/>
+                          <a:spcPts val="1960"/>
                         </a:lnSpc>
                         <a:buNone/>
                       </a:pPr>
                       <a:r>
-                        <a:rPr lang="en-US" sz="1300" dirty="0">
-                          <a:solidFill>
-                            <a:srgbClr val="14201B"/>
-                          </a:solidFill>
-                          <a:latin typeface="IBM Plex Sans" pitchFamily="34" charset="0"/>
-                          <a:ea typeface="IBM Plex Sans" pitchFamily="34" charset="-122"/>
-                          <a:cs typeface="IBM Plex Sans" pitchFamily="34" charset="-120"/>
-                        </a:rPr>
-                        <a:t>A root attacker on the vault machine (production: separate machine)</a:t>
-                      </a:r>
-                      <a:endParaRPr lang="en-US" sz="1300" dirty="0">
-                        <a:latin typeface="IBM Plex Sans" charset="0"/>
-                        <a:ea typeface="IBM Plex Sans" charset="0"/>
-                        <a:cs typeface="IBM Plex Sans" charset="0"/>
-                      </a:endParaRPr>
-                    </a:p>
-                  </a:txBody>
-                  <a:tcPr marL="57785" marR="57785" marT="57785" marB="57785" anchor="t">
-                    <a:lnL w="12700" cap="flat" cmpd="sng" algn="ctr">
-                      <a:solidFill>
-                        <a:srgbClr val="C3C4C1"/>
-                      </a:solidFill>
-                      <a:prstDash val="solid"/>
-                      <a:round/>
-                      <a:headEnd type="none" w="med" len="med"/>
-                      <a:tailEnd type="none" w="med" len="med"/>
-                    </a:lnL>
-                    <a:lnR w="12700" cap="flat" cmpd="sng" algn="ctr">
-                      <a:solidFill>
-                        <a:srgbClr val="C3C4C1"/>
-                      </a:solidFill>
-                      <a:prstDash val="solid"/>
-                      <a:round/>
-                      <a:headEnd type="none" w="med" len="med"/>
-                      <a:tailEnd type="none" w="med" len="med"/>
-                    </a:lnR>
-                    <a:lnT w="12700" cap="flat" cmpd="sng" algn="ctr">
-                      <a:solidFill>
-                        <a:srgbClr val="C3C4C1"/>
-                      </a:solidFill>
-                      <a:prstDash val="solid"/>
-                      <a:round/>
-                      <a:headEnd type="none" w="med" len="med"/>
-                      <a:tailEnd type="none" w="med" len="med"/>
-                    </a:lnT>
-                    <a:lnB w="12700" cap="flat" cmpd="sng" algn="ctr">
-                      <a:solidFill>
-                        <a:srgbClr val="C3C4C1"/>
-                      </a:solidFill>
-                      <a:prstDash val="solid"/>
-                      <a:round/>
-                      <a:headEnd type="none" w="med" len="med"/>
-                      <a:tailEnd type="none" w="med" len="med"/>
-                    </a:lnB>
-                  </a:tcPr>
-                </a:tc>
-              </a:tr>
-              <a:tr h="590451">
-                <a:tc>
-                  <a:txBody>
-                    <a:bodyPr/>
-                    <a:lstStyle/>
-                    <a:p>
-                      <a:pPr indent="0" marL="0">
-                        <a:lnSpc>
-                          <a:spcPts val="1820"/>
-                        </a:lnSpc>
-                        <a:buNone/>
-                      </a:pPr>
-                      <a:r>
-                        <a:rPr lang="en-US" sz="1300" dirty="0">
-                          <a:solidFill>
-                            <a:srgbClr val="14201B"/>
-                          </a:solidFill>
-                          <a:latin typeface="IBM Plex Sans" pitchFamily="34" charset="0"/>
-                          <a:ea typeface="IBM Plex Sans" pitchFamily="34" charset="-122"/>
-                          <a:cs typeface="IBM Plex Sans" pitchFamily="34" charset="-120"/>
-                        </a:rPr>
-                        <a:t>"Guard silent" heartbeat alarm</a:t>
-                      </a:r>
-                      <a:endParaRPr lang="en-US" sz="1300" dirty="0">
-                        <a:latin typeface="IBM Plex Sans" charset="0"/>
-                        <a:ea typeface="IBM Plex Sans" charset="0"/>
-                        <a:cs typeface="IBM Plex Sans" charset="0"/>
-                      </a:endParaRPr>
-                    </a:p>
-                  </a:txBody>
-                  <a:tcPr marL="57785" marR="57785" marT="57785" marB="57785" anchor="t">
-                    <a:lnL w="12700" cap="flat" cmpd="sng" algn="ctr">
-                      <a:solidFill>
-                        <a:srgbClr val="C3C4C1"/>
-                      </a:solidFill>
-                      <a:prstDash val="solid"/>
-                      <a:round/>
-                      <a:headEnd type="none" w="med" len="med"/>
-                      <a:tailEnd type="none" w="med" len="med"/>
-                    </a:lnL>
-                    <a:lnR w="12700" cap="flat" cmpd="sng" algn="ctr">
-                      <a:solidFill>
-                        <a:srgbClr val="C3C4C1"/>
-                      </a:solidFill>
-                      <a:prstDash val="solid"/>
-                      <a:round/>
-                      <a:headEnd type="none" w="med" len="med"/>
-                      <a:tailEnd type="none" w="med" len="med"/>
-                    </a:lnR>
-                    <a:lnT w="12700" cap="flat" cmpd="sng" algn="ctr">
-                      <a:solidFill>
-                        <a:srgbClr val="C3C4C1"/>
-                      </a:solidFill>
-                      <a:prstDash val="solid"/>
-                      <a:round/>
-                      <a:headEnd type="none" w="med" len="med"/>
-                      <a:tailEnd type="none" w="med" len="med"/>
-                    </a:lnT>
-                    <a:lnB w="12700" cap="flat" cmpd="sng" algn="ctr">
-                      <a:solidFill>
-                        <a:srgbClr val="C3C4C1"/>
-                      </a:solidFill>
-                      <a:prstDash val="solid"/>
-                      <a:round/>
-                      <a:headEnd type="none" w="med" len="med"/>
-                      <a:tailEnd type="none" w="med" len="med"/>
-                    </a:lnB>
-                  </a:tcPr>
-                </a:tc>
-                <a:tc>
-                  <a:txBody>
-                    <a:bodyPr/>
-                    <a:lstStyle/>
-                    <a:p>
-                      <a:pPr indent="0" marL="0">
-                        <a:lnSpc>
-                          <a:spcPts val="1820"/>
-                        </a:lnSpc>
-                        <a:buNone/>
-                      </a:pPr>
-                      <a:r>
-                        <a:rPr lang="en-US" sz="1300" dirty="0">
-                          <a:solidFill>
-                            <a:srgbClr val="14201B"/>
-                          </a:solidFill>
-                          <a:latin typeface="IBM Plex Sans" pitchFamily="34" charset="0"/>
-                          <a:ea typeface="IBM Plex Sans" pitchFamily="34" charset="-122"/>
-                          <a:cs typeface="IBM Plex Sans" pitchFamily="34" charset="-120"/>
-                        </a:rPr>
-                        <a:t>Approve the AI-drafted summary and NIS2 early warning</a:t>
-                      </a:r>
-                      <a:endParaRPr lang="en-US" sz="1300" dirty="0">
-                        <a:latin typeface="IBM Plex Sans" charset="0"/>
-                        <a:ea typeface="IBM Plex Sans" charset="0"/>
-                        <a:cs typeface="IBM Plex Sans" charset="0"/>
-                      </a:endParaRPr>
-                    </a:p>
-                  </a:txBody>
-                  <a:tcPr marL="57785" marR="57785" marT="57785" marB="57785" anchor="t">
-                    <a:lnL w="12700" cap="flat" cmpd="sng" algn="ctr">
-                      <a:solidFill>
-                        <a:srgbClr val="C3C4C1"/>
-                      </a:solidFill>
-                      <a:prstDash val="solid"/>
-                      <a:round/>
-                      <a:headEnd type="none" w="med" len="med"/>
-                      <a:tailEnd type="none" w="med" len="med"/>
-                    </a:lnL>
-                    <a:lnR w="12700" cap="flat" cmpd="sng" algn="ctr">
-                      <a:solidFill>
-                        <a:srgbClr val="C3C4C1"/>
-                      </a:solidFill>
-                      <a:prstDash val="solid"/>
-                      <a:round/>
-                      <a:headEnd type="none" w="med" len="med"/>
-                      <a:tailEnd type="none" w="med" len="med"/>
-                    </a:lnR>
-                    <a:lnT w="12700" cap="flat" cmpd="sng" algn="ctr">
-                      <a:solidFill>
-                        <a:srgbClr val="C3C4C1"/>
-                      </a:solidFill>
-                      <a:prstDash val="solid"/>
-                      <a:round/>
-                      <a:headEnd type="none" w="med" len="med"/>
-                      <a:tailEnd type="none" w="med" len="med"/>
-                    </a:lnT>
-                    <a:lnB w="12700" cap="flat" cmpd="sng" algn="ctr">
-                      <a:solidFill>
-                        <a:srgbClr val="C3C4C1"/>
-                      </a:solidFill>
-                      <a:prstDash val="solid"/>
-                      <a:round/>
-                      <a:headEnd type="none" w="med" len="med"/>
-                      <a:tailEnd type="none" w="med" len="med"/>
-                    </a:lnB>
-                  </a:tcPr>
-                </a:tc>
-                <a:tc>
-                  <a:txBody>
-                    <a:bodyPr/>
-                    <a:lstStyle/>
-                    <a:p>
-                      <a:pPr indent="0" marL="0">
-                        <a:lnSpc>
-                          <a:spcPts val="1820"/>
-                        </a:lnSpc>
-                        <a:buNone/>
-                      </a:pPr>
-                      <a:r>
-                        <a:rPr lang="en-US" sz="1300" dirty="0">
+                        <a:rPr lang="en-US" sz="1400" dirty="0">
                           <a:solidFill>
                             <a:srgbClr val="14201B"/>
                           </a:solidFill>
@@ -6575,14 +5928,14 @@
                         </a:rPr>
                         <a:t>Cloud storage (SharePoint, S3): on the roadmap</a:t>
                       </a:r>
-                      <a:endParaRPr lang="en-US" sz="1300" dirty="0">
+                      <a:endParaRPr lang="en-US" sz="1400" dirty="0">
                         <a:latin typeface="IBM Plex Sans" charset="0"/>
                         <a:ea typeface="IBM Plex Sans" charset="0"/>
                         <a:cs typeface="IBM Plex Sans" charset="0"/>
                       </a:endParaRPr>
                     </a:p>
                   </a:txBody>
-                  <a:tcPr marL="57785" marR="57785" marT="57785" marB="57785" anchor="t">
+                  <a:tcPr marL="62230" marR="62230" marT="62230" marB="62230" anchor="t">
                     <a:lnL w="12700" cap="flat" cmpd="sng" algn="ctr">
                       <a:solidFill>
                         <a:srgbClr val="C3C4C1"/>
@@ -6634,9 +5987,9 @@
 </p:sld>
 </file>
 
-<file path=ppt/slides/slide8.xml><?xml version="1.0" encoding="utf-8"?>
+<file path=ppt/slides/slide7.xml><?xml version="1.0" encoding="utf-8"?>
 <p:sld xmlns:a="http://schemas.openxmlformats.org/drawingml/2006/main" xmlns:r="http://schemas.openxmlformats.org/officeDocument/2006/relationships" xmlns:p="http://schemas.openxmlformats.org/presentationml/2006/main">
-  <p:cSld name="Slide 8">
+  <p:cSld name="Slide 7">
     <p:bg>
       <p:bgPr>
         <a:solidFill>
@@ -7336,13 +6689,13 @@
         <a:srgbClr val="3E4A44"/>
       </a:accent3>
       <a:accent4>
-        <a:srgbClr val="9DB3A8"/>
+        <a:srgbClr val="BFD3C8"/>
       </a:accent4>
       <a:accent5>
-        <a:srgbClr val="BFD3C8"/>
+        <a:srgbClr val="5F6B65"/>
       </a:accent5>
       <a:accent6>
-        <a:srgbClr val="5F6B65"/>
+        <a:srgbClr val="9DB3A8"/>
       </a:accent6>
       <a:hlink>
         <a:srgbClr val="0563C1"/>

</xml_diff>

<commit_message>
Pitch: live console screenshot
</commit_message>
<xml_diff>
--- a/docs/pitch/MIRAGE_pitch_5min.pptx
+++ b/docs/pitch/MIRAGE_pitch_5min.pptx
@@ -12,9 +12,10 @@
     <p:sldId id="260" r:id="rId6"/>
     <p:sldId id="261" r:id="rId7"/>
     <p:sldId id="262" r:id="rId8"/>
+    <p:sldId id="263" r:id="rId9"/>
   </p:sldIdLst>
   <p:notesMasterIdLst>
-    <p:notesMasterId r:id="rId9"/>
+    <p:notesMasterId r:id="rId10"/>
   </p:notesMasterIdLst>
   <p:sldSz cx="12192000" cy="6858000"/>
   <p:notesSz cx="6858000" cy="12192000"/>
@@ -860,7 +861,7 @@
           <a:p>
             <a:r>
               <a:rPr lang="en-US" dirty="0"/>
-              <a:t>GAIA · [3:05–3:30] We tested the logic on four scenarios: an AI agent, a guided AI, a script and a human. All four were detected and labelled correctly. Those are hand-written test sequences, not real attacks, and we say so. What we measured live: the larger local model confessed its mission 7 times out of 10, the smaller one 2 out of 10. Measuring detection and false alarms at scale is the first thing we'd do in a pilot. Thomas. — THOMAS · [3:30–3:50] A confession can lie, so each claim is checked against the logs: confirmed, unverified or contradicted. Claim an authorized pentest while using a stolen password, and the logs contradict it. Our trap note is prompt injection, ATLAS AML.T0051, turned against the attacker. And the AI-drafted NIS2 early warning stays a draft until a human approves it. Leon.</a:t>
+              <a:t>GAIA · [1:45–1:55, before the live demo; use it instead of the demo if the live run fails] This is the analyst's console after a real run of our AI attacker. No real files lost: the agent took one file, and it was a fake. The guard swapped three files in 2.7 milliseconds. The agent followed our note and made four claims; we checked each against the logs, and its claim to be authorized is contradicted. The summary and the NIS2 warning are AI drafts, not sent until the analyst approves. Now let's watch it live.</a:t>
             </a:r>
             <a:endParaRPr lang="en-US" dirty="0"/>
           </a:p>
@@ -948,7 +949,7 @@
           <a:p>
             <a:r>
               <a:rPr lang="en-US" dirty="0"/>
-              <a:t>LEON · [3:50–4:20] The swap is the only automatic action, and it deletes nothing. The intruder label triggers nothing, so a wrong label costs nothing. Everything else waits for the analyst: Contain the account, Keep watching the intruder in the decoys, Dismiss a false alarm, or Restore the real files in one click. Our honest limits: files read before a trap is touched are exposed, and we flag them as critical. A careful AI that never opens a trap is not caught by the swap. Ana.</a:t>
+              <a:t>GAIA · [3:05–3:30] We tested the logic on four scenarios: an AI agent, a guided AI, a script and a human. All four were detected and labelled correctly. Those are hand-written test sequences, not real attacks, and we say so. What we measured live: the larger local model confessed its mission 7 times out of 10, the smaller one 2 out of 10. Measuring detection and false alarms at scale is the first thing we'd do in a pilot. Thomas. — THOMAS · [3:30–3:50] A confession can lie, so each claim is checked against the logs: confirmed, unverified or contradicted. Claim an authorized pentest while using a stolen password, and the logs contradict it. Our trap note is prompt injection, ATLAS AML.T0051, turned against the attacker. And the AI-drafted NIS2 early warning stays a draft until a human approves it. Leon.</a:t>
             </a:r>
             <a:endParaRPr lang="en-US" dirty="0"/>
           </a:p>
@@ -1036,7 +1037,7 @@
           <a:p>
             <a:r>
               <a:rPr lang="en-US" dirty="0"/>
-              <a:t>ANA · [4:20–5:00] Deception is a 2.7 billion dollar market, and its pioneers were bought by SentinelOne, Proofpoint and Zscaler. They all detect intruders. None of those we reviewed protects the real files. Our customers are clinics and the medical sector: private clinics, medical labs and imaging centres. Their breaches are the most expensive of any sector, their patient data sits on shared drives, and NIS2 now covers them. We sell directly and through the providers that already run their SOC. Next: pilots with two or three clinics, and cloud storage like SharePoint and S3. We're Ana, Thomas, Leon and Gaia. Whoever breaks in steals only fakes. And if it's an AI, it tells us who sent it. Thank you.</a:t>
+              <a:t>LEON · [3:50–4:20] The swap is the only automatic action, and it deletes nothing. The intruder label triggers nothing, so a wrong label costs nothing. Everything else waits for the analyst: Contain the account, Keep watching the intruder in the decoys, Dismiss a false alarm, or Restore the real files in one click. Our honest limits: files read before a trap is touched are exposed, and we flag them as critical. A careful AI that never opens a trap is not caught by the swap. Ana.</a:t>
             </a:r>
             <a:endParaRPr lang="en-US" dirty="0"/>
           </a:p>
@@ -1060,6 +1061,94 @@
             <a:fld id="{F7021451-1387-4CA6-816F-3879F97B5CBC}" type="slidenum">
               <a:rPr lang="en-US"/>
               <a:t>7</a:t>
+            </a:fld>
+            <a:endParaRPr lang="en-US"/>
+          </a:p>
+        </p:txBody>
+      </p:sp>
+    </p:spTree>
+    <p:extLst>
+      <p:ext uri="{BB962C8B-B14F-4D97-AF65-F5344CB8AC3E}">
+        <p14:creationId xmlns:p14="http://schemas.microsoft.com/office/powerpoint/2010/main" val="1024086991"/>
+      </p:ext>
+    </p:extLst>
+  </p:cSld>
+  <p:clrMapOvr>
+    <a:masterClrMapping/>
+  </p:clrMapOvr>
+</p:notes>
+</file>
+
+<file path=ppt/notesSlides/notesSlide8.xml><?xml version="1.0" encoding="utf-8"?>
+<p:notes xmlns:a="http://schemas.openxmlformats.org/drawingml/2006/main" xmlns:r="http://schemas.openxmlformats.org/officeDocument/2006/relationships" xmlns:p="http://schemas.openxmlformats.org/presentationml/2006/main">
+  <p:cSld>
+    <p:spTree>
+      <p:nvGrpSpPr>
+        <p:cNvPr id="1" name=""/>
+        <p:cNvGrpSpPr/>
+        <p:nvPr/>
+      </p:nvGrpSpPr>
+      <p:grpSpPr>
+        <a:xfrm>
+          <a:off x="0" y="0"/>
+          <a:ext cx="0" cy="0"/>
+          <a:chOff x="0" y="0"/>
+          <a:chExt cx="0" cy="0"/>
+        </a:xfrm>
+      </p:grpSpPr>
+      <p:sp>
+        <p:nvSpPr>
+          <p:cNvPr id="2" name="Slide Image Placeholder 1"/>
+          <p:cNvSpPr>
+            <a:spLocks noGrp="1" noRot="1" noChangeAspect="1"/>
+          </p:cNvSpPr>
+          <p:nvPr>
+            <p:ph type="sldImg"/>
+          </p:nvPr>
+        </p:nvSpPr>
+        <p:spPr/>
+      </p:sp>
+      <p:sp>
+        <p:nvSpPr>
+          <p:cNvPr id="3" name="Notes Placeholder 2"/>
+          <p:cNvSpPr>
+            <a:spLocks noGrp="1"/>
+          </p:cNvSpPr>
+          <p:nvPr>
+            <p:ph type="body" idx="1"/>
+          </p:nvPr>
+        </p:nvSpPr>
+        <p:spPr/>
+        <p:txBody>
+          <a:bodyPr/>
+          <a:lstStyle/>
+          <a:p>
+            <a:r>
+              <a:rPr lang="en-US" dirty="0"/>
+              <a:t>ANA · [4:20–5:00] Deception is a 2.7 billion dollar market, and its pioneers were bought by SentinelOne, Proofpoint and Zscaler. They all detect intruders. None of those we reviewed protects the real files. Our customers are clinics and the medical sector: private clinics, medical labs and imaging centres. Their breaches are the most expensive of any sector, their patient data sits on shared drives, and NIS2 now covers them. We sell directly and through the providers that already run their SOC. Next: pilots with two or three clinics, and cloud storage like SharePoint and S3. We're Ana, Thomas, Leon and Gaia. Whoever breaks in steals only fakes. And if it's an AI, it tells us who sent it. Thank you.</a:t>
+            </a:r>
+            <a:endParaRPr lang="en-US" dirty="0"/>
+          </a:p>
+        </p:txBody>
+      </p:sp>
+      <p:sp>
+        <p:nvSpPr>
+          <p:cNvPr id="4" name="Slide Number Placeholder 3"/>
+          <p:cNvSpPr>
+            <a:spLocks noGrp="1"/>
+          </p:cNvSpPr>
+          <p:nvPr>
+            <p:ph type="sldNum" sz="quarter" idx="10"/>
+          </p:nvPr>
+        </p:nvSpPr>
+        <p:spPr/>
+        <p:txBody>
+          <a:bodyPr/>
+          <a:lstStyle/>
+          <a:p>
+            <a:fld id="{F7021451-1387-4CA6-816F-3879F97B5CBC}" type="slidenum">
+              <a:rPr lang="en-US"/>
+              <a:t>8</a:t>
             </a:fld>
             <a:endParaRPr lang="en-US"/>
           </a:p>
@@ -3247,50 +3336,6 @@
           </a:p>
         </p:txBody>
       </p:sp>
-      <p:sp>
-        <p:nvSpPr>
-          <p:cNvPr id="24" name="Text 22"/>
-          <p:cNvSpPr/>
-          <p:nvPr/>
-        </p:nvSpPr>
-        <p:spPr>
-          <a:xfrm>
-            <a:off x="812800" y="6238280"/>
-            <a:ext cx="10883392" cy="238720"/>
-          </a:xfrm>
-          <a:prstGeom prst="rect">
-            <a:avLst/>
-          </a:prstGeom>
-          <a:noFill/>
-          <a:ln/>
-        </p:spPr>
-        <p:txBody>
-          <a:bodyPr wrap="square" lIns="0" tIns="0" rIns="0" bIns="0" rtlCol="0" anchor="t">
-            <a:normAutofit/>
-          </a:bodyPr>
-          <a:lstStyle/>
-          <a:p>
-            <a:pPr algn="l" indent="0" marL="0">
-              <a:lnSpc>
-                <a:spcPts val="1680"/>
-              </a:lnSpc>
-              <a:buNone/>
-            </a:pPr>
-            <a:r>
-              <a:rPr lang="en-US" sz="1200" dirty="0">
-                <a:solidFill>
-                  <a:srgbClr val="5F6B65"/>
-                </a:solidFill>
-                <a:latin typeface="IBM Plex Sans" pitchFamily="34" charset="0"/>
-                <a:ea typeface="IBM Plex Sans" pitchFamily="34" charset="-122"/>
-                <a:cs typeface="IBM Plex Sans" pitchFamily="34" charset="-120"/>
-              </a:rPr>
-              <a:t>Demo company: Lumen Health, a fictional clinic chain. All data is synthetic.</a:t>
-            </a:r>
-            <a:endParaRPr lang="en-US" sz="1200" dirty="0"/>
-          </a:p>
-        </p:txBody>
-      </p:sp>
     </p:spTree>
   </p:cSld>
   <p:clrMapOvr>
@@ -4133,29 +4178,29 @@
         </p:nvSpPr>
         <p:spPr>
           <a:xfrm>
-            <a:off x="812800" y="812800"/>
-            <a:ext cx="10883392" cy="209302"/>
-          </a:xfrm>
-          <a:prstGeom prst="rect">
-            <a:avLst/>
-          </a:prstGeom>
-          <a:noFill/>
-          <a:ln/>
-        </p:spPr>
-        <p:txBody>
-          <a:bodyPr wrap="square" lIns="0" tIns="0" rIns="0" bIns="0" rtlCol="0" anchor="t">
-            <a:normAutofit/>
-          </a:bodyPr>
-          <a:lstStyle/>
-          <a:p>
-            <a:pPr algn="l" indent="0" marL="0">
-              <a:lnSpc>
-                <a:spcPts val="1470"/>
-              </a:lnSpc>
-              <a:buNone/>
-            </a:pPr>
-            <a:r>
-              <a:rPr lang="en-US" sz="1050" spc="200" kern="0" dirty="0">
+            <a:off x="812800" y="609600"/>
+            <a:ext cx="10883392" cy="234355"/>
+          </a:xfrm>
+          <a:prstGeom prst="rect">
+            <a:avLst/>
+          </a:prstGeom>
+          <a:noFill/>
+          <a:ln/>
+        </p:spPr>
+        <p:txBody>
+          <a:bodyPr wrap="square" lIns="0" tIns="0" rIns="0" bIns="0" rtlCol="0" anchor="t">
+            <a:normAutofit/>
+          </a:bodyPr>
+          <a:lstStyle/>
+          <a:p>
+            <a:pPr algn="l" indent="0" marL="0">
+              <a:lnSpc>
+                <a:spcPts val="1675"/>
+              </a:lnSpc>
+              <a:buNone/>
+            </a:pPr>
+            <a:r>
+              <a:rPr lang="en-US" sz="1196" spc="200" kern="0" dirty="0">
                 <a:solidFill>
                   <a:srgbClr val="7BE0A0"/>
                 </a:solidFill>
@@ -4163,9 +4208,9 @@
                 <a:ea typeface="JetBrains Mono" pitchFamily="49" charset="-122"/>
                 <a:cs typeface="JetBrains Mono" pitchFamily="49" charset="-120"/>
               </a:rPr>
-              <a:t>WHAT WE TESTED, AND HOW</a:t>
-            </a:r>
-            <a:endParaRPr lang="en-US" sz="1050" dirty="0"/>
+              <a:t>THE ANALYST'S CONSOLE</a:t>
+            </a:r>
+            <a:endParaRPr lang="en-US" sz="1196" dirty="0"/>
           </a:p>
         </p:txBody>
       </p:sp>
@@ -4179,29 +4224,29 @@
         </p:nvSpPr>
         <p:spPr>
           <a:xfrm>
-            <a:off x="812800" y="1174502"/>
-            <a:ext cx="10883392" cy="892373"/>
-          </a:xfrm>
-          <a:prstGeom prst="rect">
-            <a:avLst/>
-          </a:prstGeom>
-          <a:noFill/>
-          <a:ln/>
-        </p:spPr>
-        <p:txBody>
-          <a:bodyPr wrap="square" lIns="0" tIns="0" rIns="0" bIns="0" rtlCol="0" anchor="t">
-            <a:normAutofit/>
-          </a:bodyPr>
-          <a:lstStyle/>
-          <a:p>
-            <a:pPr algn="l" indent="0" marL="0">
-              <a:lnSpc>
-                <a:spcPts val="3428"/>
-              </a:lnSpc>
-              <a:buNone/>
-            </a:pPr>
-            <a:r>
-              <a:rPr lang="en-US" sz="3116" b="1" i="0" dirty="0">
+            <a:off x="812800" y="996355"/>
+            <a:ext cx="10883392" cy="463302"/>
+          </a:xfrm>
+          <a:prstGeom prst="rect">
+            <a:avLst/>
+          </a:prstGeom>
+          <a:noFill/>
+          <a:ln/>
+        </p:spPr>
+        <p:txBody>
+          <a:bodyPr wrap="square" lIns="0" tIns="0" rIns="0" bIns="0" rtlCol="0" anchor="t">
+            <a:normAutofit/>
+          </a:bodyPr>
+          <a:lstStyle/>
+          <a:p>
+            <a:pPr algn="l" indent="0" marL="0">
+              <a:lnSpc>
+                <a:spcPts val="3465"/>
+              </a:lnSpc>
+              <a:buNone/>
+            </a:pPr>
+            <a:r>
+              <a:rPr lang="en-US" sz="3150" b="1" i="0" dirty="0">
                 <a:solidFill>
                   <a:srgbClr val="F2F5F0"/>
                 </a:solidFill>
@@ -4209,31 +4254,54 @@
                 <a:ea typeface="Space Grotesk" pitchFamily="34" charset="-122"/>
                 <a:cs typeface="Space Grotesk" pitchFamily="34" charset="-120"/>
               </a:rPr>
-              <a:t>Logic validated on test scenarios. Confessions measured live.</a:t>
-            </a:r>
-            <a:endParaRPr lang="en-US" sz="3116" dirty="0"/>
-          </a:p>
-        </p:txBody>
-      </p:sp>
-      <p:sp>
-        <p:nvSpPr>
-          <p:cNvPr id="4" name="Shape 2"/>
-          <p:cNvSpPr/>
-          <p:nvPr/>
-        </p:nvSpPr>
-        <p:spPr>
-          <a:xfrm>
-            <a:off x="815975" y="2222450"/>
-            <a:ext cx="3414167" cy="1561654"/>
+              <a:t>One card, from a live AI attack.</a:t>
+            </a:r>
+            <a:endParaRPr lang="en-US" sz="3150" dirty="0"/>
+          </a:p>
+        </p:txBody>
+      </p:sp>
+      <p:pic>
+        <p:nvPicPr>
+          <p:cNvPr id="4" name="Image 0" descr="MIRAGE incident console after a live AI attack: no real files lost, swap in 2.7 ms, claims checked against the logs, AI draft pending approval">    </p:cNvPr>
+          <p:cNvPicPr>
+            <a:picLocks noChangeAspect="1"/>
+          </p:cNvPicPr>
+          <p:nvPr/>
+        </p:nvPicPr>
+        <p:blipFill>
+          <a:blip r:embed="rId1"/>
+          <a:srcRect l="0" r="0" t="5" b="5"/>
+          <a:stretch/>
+        </p:blipFill>
+        <p:spPr>
+          <a:xfrm>
+            <a:off x="819150" y="1618407"/>
+            <a:ext cx="4959350" cy="4305300"/>
           </a:xfrm>
           <a:prstGeom prst="roundRect">
             <a:avLst>
-              <a:gd name="adj" fmla="val 6303"/>
+              <a:gd name="adj" fmla="val 1622"/>
             </a:avLst>
           </a:prstGeom>
-          <a:solidFill>
-            <a:srgbClr val="18221E"/>
-          </a:solidFill>
+        </p:spPr>
+      </p:pic>
+      <p:sp>
+        <p:nvSpPr>
+          <p:cNvPr id="5" name="Shape 2"/>
+          <p:cNvSpPr/>
+          <p:nvPr/>
+        </p:nvSpPr>
+        <p:spPr>
+          <a:xfrm>
+            <a:off x="815975" y="1615232"/>
+            <a:ext cx="4965700" cy="4311650"/>
+          </a:xfrm>
+          <a:prstGeom prst="roundRect">
+            <a:avLst>
+              <a:gd name="adj" fmla="val 1694"/>
+            </a:avLst>
+          </a:prstGeom>
+          <a:noFill/>
           <a:ln w="6350">
             <a:solidFill>
               <a:srgbClr val="2C3D36"/>
@@ -4244,35 +4312,58 @@
       </p:sp>
       <p:sp>
         <p:nvSpPr>
-          <p:cNvPr id="5" name="Text 3"/>
-          <p:cNvSpPr/>
-          <p:nvPr/>
-        </p:nvSpPr>
-        <p:spPr>
-          <a:xfrm>
-            <a:off x="996950" y="2403425"/>
-            <a:ext cx="3143783" cy="543967"/>
-          </a:xfrm>
-          <a:prstGeom prst="rect">
-            <a:avLst/>
-          </a:prstGeom>
-          <a:noFill/>
-          <a:ln/>
-        </p:spPr>
-        <p:txBody>
-          <a:bodyPr wrap="square" lIns="0" tIns="0" rIns="0" bIns="0" rtlCol="0" anchor="t">
-            <a:normAutofit/>
-          </a:bodyPr>
-          <a:lstStyle/>
-          <a:p>
-            <a:pPr algn="l" indent="0" marL="0">
-              <a:lnSpc>
-                <a:spcPts val="4111"/>
-              </a:lnSpc>
-              <a:buNone/>
-            </a:pPr>
-            <a:r>
-              <a:rPr lang="en-US" sz="2936" b="1" dirty="0">
+          <p:cNvPr id="6" name="Shape 3"/>
+          <p:cNvSpPr/>
+          <p:nvPr/>
+        </p:nvSpPr>
+        <p:spPr>
+          <a:xfrm>
+            <a:off x="6153150" y="1612057"/>
+            <a:ext cx="0" cy="578445"/>
+          </a:xfrm>
+          <a:prstGeom prst="line">
+            <a:avLst/>
+          </a:prstGeom>
+          <a:noFill/>
+          <a:ln w="25400">
+            <a:solidFill>
+              <a:srgbClr val="7BE0A0"/>
+            </a:solidFill>
+            <a:prstDash val="solid"/>
+          </a:ln>
+        </p:spPr>
+      </p:sp>
+      <p:sp>
+        <p:nvSpPr>
+          <p:cNvPr id="7" name="Text 4"/>
+          <p:cNvSpPr/>
+          <p:nvPr/>
+        </p:nvSpPr>
+        <p:spPr>
+          <a:xfrm>
+            <a:off x="6318250" y="1637457"/>
+            <a:ext cx="5212779" cy="304800"/>
+          </a:xfrm>
+          <a:prstGeom prst="rect">
+            <a:avLst/>
+          </a:prstGeom>
+          <a:noFill/>
+          <a:ln/>
+        </p:spPr>
+        <p:txBody>
+          <a:bodyPr wrap="square" lIns="0" tIns="0" rIns="0" bIns="0" rtlCol="0" anchor="t">
+            <a:normAutofit/>
+          </a:bodyPr>
+          <a:lstStyle/>
+          <a:p>
+            <a:pPr algn="l" indent="0" marL="0">
+              <a:lnSpc>
+                <a:spcPts val="2200"/>
+              </a:lnSpc>
+              <a:buNone/>
+            </a:pPr>
+            <a:r>
+              <a:rPr lang="en-US" sz="2000" b="1" dirty="0">
                 <a:solidFill>
                   <a:srgbClr val="7BE0A0"/>
                 </a:solidFill>
@@ -4280,43 +4371,43 @@
                 <a:ea typeface="Space Grotesk" pitchFamily="34" charset="-122"/>
                 <a:cs typeface="Space Grotesk" pitchFamily="34" charset="-120"/>
               </a:rPr>
-              <a:t>4 / 4</a:t>
-            </a:r>
-            <a:endParaRPr lang="en-US" sz="2936" dirty="0"/>
-          </a:p>
-        </p:txBody>
-      </p:sp>
-      <p:sp>
-        <p:nvSpPr>
-          <p:cNvPr id="6" name="Text 4"/>
-          <p:cNvSpPr/>
-          <p:nvPr/>
-        </p:nvSpPr>
-        <p:spPr>
-          <a:xfrm>
-            <a:off x="996950" y="2998192"/>
-            <a:ext cx="3143783" cy="630337"/>
-          </a:xfrm>
-          <a:prstGeom prst="rect">
-            <a:avLst/>
-          </a:prstGeom>
-          <a:noFill/>
-          <a:ln/>
-        </p:spPr>
-        <p:txBody>
-          <a:bodyPr wrap="square" lIns="0" tIns="0" rIns="0" bIns="0" rtlCol="0" anchor="t">
-            <a:normAutofit/>
-          </a:bodyPr>
-          <a:lstStyle/>
-          <a:p>
-            <a:pPr algn="l" indent="0" marL="0">
-              <a:lnSpc>
-                <a:spcPts val="1617"/>
-              </a:lnSpc>
-              <a:buNone/>
-            </a:pPr>
-            <a:r>
-              <a:rPr lang="en-US" sz="1155" dirty="0">
+              <a:t>0 real files lost</a:t>
+            </a:r>
+            <a:endParaRPr lang="en-US" sz="2000" dirty="0"/>
+          </a:p>
+        </p:txBody>
+      </p:sp>
+      <p:sp>
+        <p:nvSpPr>
+          <p:cNvPr id="8" name="Text 5"/>
+          <p:cNvSpPr/>
+          <p:nvPr/>
+        </p:nvSpPr>
+        <p:spPr>
+          <a:xfrm>
+            <a:off x="6318250" y="1942257"/>
+            <a:ext cx="5212779" cy="248245"/>
+          </a:xfrm>
+          <a:prstGeom prst="rect">
+            <a:avLst/>
+          </a:prstGeom>
+          <a:noFill/>
+          <a:ln/>
+        </p:spPr>
+        <p:txBody>
+          <a:bodyPr wrap="square" lIns="0" tIns="0" rIns="0" bIns="0" rtlCol="0" anchor="t">
+            <a:normAutofit/>
+          </a:bodyPr>
+          <a:lstStyle/>
+          <a:p>
+            <a:pPr algn="l" indent="0" marL="0">
+              <a:lnSpc>
+                <a:spcPts val="1755"/>
+              </a:lnSpc>
+              <a:buNone/>
+            </a:pPr>
+            <a:r>
+              <a:rPr lang="en-US" sz="1300" dirty="0">
                 <a:solidFill>
                   <a:srgbClr val="BFD3C8"/>
                 </a:solidFill>
@@ -4324,34 +4415,30 @@
                 <a:ea typeface="IBM Plex Sans" pitchFamily="34" charset="-122"/>
                 <a:cs typeface="IBM Plex Sans" pitchFamily="34" charset="-120"/>
               </a:rPr>
-              <a:t>test scenarios detected and labelled correctly: AI agent, guided AI, script, human (logic test)</a:t>
-            </a:r>
-            <a:endParaRPr lang="en-US" sz="1155" dirty="0"/>
-          </a:p>
-        </p:txBody>
-      </p:sp>
-      <p:sp>
-        <p:nvSpPr>
-          <p:cNvPr id="7" name="Shape 5"/>
-          <p:cNvSpPr/>
-          <p:nvPr/>
-        </p:nvSpPr>
-        <p:spPr>
-          <a:xfrm>
-            <a:off x="4388892" y="2222450"/>
-            <a:ext cx="3414167" cy="1561654"/>
-          </a:xfrm>
-          <a:prstGeom prst="roundRect">
-            <a:avLst>
-              <a:gd name="adj" fmla="val 6303"/>
-            </a:avLst>
-          </a:prstGeom>
-          <a:solidFill>
-            <a:srgbClr val="18221E"/>
-          </a:solidFill>
-          <a:ln w="6350">
+              <a:t>The intruder took 1 file: a fake credentials file (.env).</a:t>
+            </a:r>
+            <a:endParaRPr lang="en-US" sz="1300" dirty="0"/>
+          </a:p>
+        </p:txBody>
+      </p:sp>
+      <p:sp>
+        <p:nvSpPr>
+          <p:cNvPr id="9" name="Shape 6"/>
+          <p:cNvSpPr/>
+          <p:nvPr/>
+        </p:nvSpPr>
+        <p:spPr>
+          <a:xfrm>
+            <a:off x="6153150" y="2355602"/>
+            <a:ext cx="0" cy="578445"/>
+          </a:xfrm>
+          <a:prstGeom prst="line">
+            <a:avLst/>
+          </a:prstGeom>
+          <a:noFill/>
+          <a:ln w="25400">
             <a:solidFill>
-              <a:srgbClr val="2C3D36"/>
+              <a:srgbClr val="7BE0A0"/>
             </a:solidFill>
             <a:prstDash val="solid"/>
           </a:ln>
@@ -4359,35 +4446,35 @@
       </p:sp>
       <p:sp>
         <p:nvSpPr>
-          <p:cNvPr id="8" name="Text 6"/>
-          <p:cNvSpPr/>
-          <p:nvPr/>
-        </p:nvSpPr>
-        <p:spPr>
-          <a:xfrm>
-            <a:off x="4569867" y="2403425"/>
-            <a:ext cx="3143783" cy="657423"/>
-          </a:xfrm>
-          <a:prstGeom prst="rect">
-            <a:avLst/>
-          </a:prstGeom>
-          <a:noFill/>
-          <a:ln/>
-        </p:spPr>
-        <p:txBody>
-          <a:bodyPr wrap="square" lIns="0" tIns="0" rIns="0" bIns="0" rtlCol="0" anchor="t">
-            <a:normAutofit/>
-          </a:bodyPr>
-          <a:lstStyle/>
-          <a:p>
-            <a:pPr algn="l" indent="0" marL="0">
-              <a:lnSpc>
-                <a:spcPts val="5024"/>
-              </a:lnSpc>
-              <a:buNone/>
-            </a:pPr>
-            <a:r>
-              <a:rPr lang="en-US" sz="3589" b="1" dirty="0">
+          <p:cNvPr id="10" name="Text 7"/>
+          <p:cNvSpPr/>
+          <p:nvPr/>
+        </p:nvSpPr>
+        <p:spPr>
+          <a:xfrm>
+            <a:off x="6318250" y="2381002"/>
+            <a:ext cx="5212779" cy="304800"/>
+          </a:xfrm>
+          <a:prstGeom prst="rect">
+            <a:avLst/>
+          </a:prstGeom>
+          <a:noFill/>
+          <a:ln/>
+        </p:spPr>
+        <p:txBody>
+          <a:bodyPr wrap="square" lIns="0" tIns="0" rIns="0" bIns="0" rtlCol="0" anchor="t">
+            <a:normAutofit/>
+          </a:bodyPr>
+          <a:lstStyle/>
+          <a:p>
+            <a:pPr algn="l" indent="0" marL="0">
+              <a:lnSpc>
+                <a:spcPts val="2200"/>
+              </a:lnSpc>
+              <a:buNone/>
+            </a:pPr>
+            <a:r>
+              <a:rPr lang="en-US" sz="2000" b="1" dirty="0">
                 <a:solidFill>
                   <a:srgbClr val="7BE0A0"/>
                 </a:solidFill>
@@ -4395,43 +4482,43 @@
                 <a:ea typeface="Space Grotesk" pitchFamily="34" charset="-122"/>
                 <a:cs typeface="Space Grotesk" pitchFamily="34" charset="-120"/>
               </a:rPr>
-              <a:t>7 / 10</a:t>
-            </a:r>
-            <a:endParaRPr lang="en-US" sz="3589" dirty="0"/>
-          </a:p>
-        </p:txBody>
-      </p:sp>
-      <p:sp>
-        <p:nvSpPr>
-          <p:cNvPr id="9" name="Text 7"/>
-          <p:cNvSpPr/>
-          <p:nvPr/>
-        </p:nvSpPr>
-        <p:spPr>
-          <a:xfrm>
-            <a:off x="4569867" y="3111649"/>
-            <a:ext cx="3143783" cy="516880"/>
-          </a:xfrm>
-          <a:prstGeom prst="rect">
-            <a:avLst/>
-          </a:prstGeom>
-          <a:noFill/>
-          <a:ln/>
-        </p:spPr>
-        <p:txBody>
-          <a:bodyPr wrap="square" lIns="0" tIns="0" rIns="0" bIns="0" rtlCol="0" anchor="t">
-            <a:normAutofit/>
-          </a:bodyPr>
-          <a:lstStyle/>
-          <a:p>
-            <a:pPr algn="l" indent="0" marL="0">
-              <a:lnSpc>
-                <a:spcPts val="1936"/>
-              </a:lnSpc>
-              <a:buNone/>
-            </a:pPr>
-            <a:r>
-              <a:rPr lang="en-US" sz="1383" dirty="0">
+              <a:t>2.7 ms</a:t>
+            </a:r>
+            <a:endParaRPr lang="en-US" sz="2000" dirty="0"/>
+          </a:p>
+        </p:txBody>
+      </p:sp>
+      <p:sp>
+        <p:nvSpPr>
+          <p:cNvPr id="11" name="Text 8"/>
+          <p:cNvSpPr/>
+          <p:nvPr/>
+        </p:nvSpPr>
+        <p:spPr>
+          <a:xfrm>
+            <a:off x="6318250" y="2685802"/>
+            <a:ext cx="5212779" cy="248245"/>
+          </a:xfrm>
+          <a:prstGeom prst="rect">
+            <a:avLst/>
+          </a:prstGeom>
+          <a:noFill/>
+          <a:ln/>
+        </p:spPr>
+        <p:txBody>
+          <a:bodyPr wrap="square" lIns="0" tIns="0" rIns="0" bIns="0" rtlCol="0" anchor="t">
+            <a:normAutofit/>
+          </a:bodyPr>
+          <a:lstStyle/>
+          <a:p>
+            <a:pPr algn="l" indent="0" marL="0">
+              <a:lnSpc>
+                <a:spcPts val="1755"/>
+              </a:lnSpc>
+              <a:buNone/>
+            </a:pPr>
+            <a:r>
+              <a:rPr lang="en-US" sz="1300" dirty="0">
                 <a:solidFill>
                   <a:srgbClr val="BFD3C8"/>
                 </a:solidFill>
@@ -4439,34 +4526,30 @@
                 <a:ea typeface="IBM Plex Sans" pitchFamily="34" charset="-122"/>
                 <a:cs typeface="IBM Plex Sans" pitchFamily="34" charset="-120"/>
               </a:rPr>
-              <a:t>live AI runs that confessed their mission (qwen3.5:35b, local)</a:t>
-            </a:r>
-            <a:endParaRPr lang="en-US" sz="1383" dirty="0"/>
-          </a:p>
-        </p:txBody>
-      </p:sp>
-      <p:sp>
-        <p:nvSpPr>
-          <p:cNvPr id="10" name="Shape 8"/>
-          <p:cNvSpPr/>
-          <p:nvPr/>
-        </p:nvSpPr>
-        <p:spPr>
-          <a:xfrm>
-            <a:off x="7961809" y="2222450"/>
-            <a:ext cx="3414216" cy="1561654"/>
-          </a:xfrm>
-          <a:prstGeom prst="roundRect">
-            <a:avLst>
-              <a:gd name="adj" fmla="val 6303"/>
-            </a:avLst>
-          </a:prstGeom>
-          <a:solidFill>
-            <a:srgbClr val="18221E"/>
-          </a:solidFill>
-          <a:ln w="6350">
+              <a:t>3 protected files swapped for fakes, timed by the guard in this run.</a:t>
+            </a:r>
+            <a:endParaRPr lang="en-US" sz="1300" dirty="0"/>
+          </a:p>
+        </p:txBody>
+      </p:sp>
+      <p:sp>
+        <p:nvSpPr>
+          <p:cNvPr id="12" name="Shape 9"/>
+          <p:cNvSpPr/>
+          <p:nvPr/>
+        </p:nvSpPr>
+        <p:spPr>
+          <a:xfrm>
+            <a:off x="6153150" y="3099147"/>
+            <a:ext cx="0" cy="801291"/>
+          </a:xfrm>
+          <a:prstGeom prst="line">
+            <a:avLst/>
+          </a:prstGeom>
+          <a:noFill/>
+          <a:ln w="25400">
             <a:solidFill>
-              <a:srgbClr val="2C3D36"/>
+              <a:srgbClr val="7BE0A0"/>
             </a:solidFill>
             <a:prstDash val="solid"/>
           </a:ln>
@@ -4474,35 +4557,35 @@
       </p:sp>
       <p:sp>
         <p:nvSpPr>
-          <p:cNvPr id="11" name="Text 9"/>
-          <p:cNvSpPr/>
-          <p:nvPr/>
-        </p:nvSpPr>
-        <p:spPr>
-          <a:xfrm>
-            <a:off x="8142784" y="2403425"/>
-            <a:ext cx="3143834" cy="657423"/>
-          </a:xfrm>
-          <a:prstGeom prst="rect">
-            <a:avLst/>
-          </a:prstGeom>
-          <a:noFill/>
-          <a:ln/>
-        </p:spPr>
-        <p:txBody>
-          <a:bodyPr wrap="square" lIns="0" tIns="0" rIns="0" bIns="0" rtlCol="0" anchor="t">
-            <a:normAutofit/>
-          </a:bodyPr>
-          <a:lstStyle/>
-          <a:p>
-            <a:pPr algn="l" indent="0" marL="0">
-              <a:lnSpc>
-                <a:spcPts val="5024"/>
-              </a:lnSpc>
-              <a:buNone/>
-            </a:pPr>
-            <a:r>
-              <a:rPr lang="en-US" sz="3589" b="1" dirty="0">
+          <p:cNvPr id="13" name="Text 10"/>
+          <p:cNvSpPr/>
+          <p:nvPr/>
+        </p:nvSpPr>
+        <p:spPr>
+          <a:xfrm>
+            <a:off x="6318250" y="3124547"/>
+            <a:ext cx="5212779" cy="304800"/>
+          </a:xfrm>
+          <a:prstGeom prst="rect">
+            <a:avLst/>
+          </a:prstGeom>
+          <a:noFill/>
+          <a:ln/>
+        </p:spPr>
+        <p:txBody>
+          <a:bodyPr wrap="square" lIns="0" tIns="0" rIns="0" bIns="0" rtlCol="0" anchor="t">
+            <a:normAutofit/>
+          </a:bodyPr>
+          <a:lstStyle/>
+          <a:p>
+            <a:pPr algn="l" indent="0" marL="0">
+              <a:lnSpc>
+                <a:spcPts val="2200"/>
+              </a:lnSpc>
+              <a:buNone/>
+            </a:pPr>
+            <a:r>
+              <a:rPr lang="en-US" sz="2000" b="1" dirty="0">
                 <a:solidFill>
                   <a:srgbClr val="7BE0A0"/>
                 </a:solidFill>
@@ -4510,43 +4593,43 @@
                 <a:ea typeface="Space Grotesk" pitchFamily="34" charset="-122"/>
                 <a:cs typeface="Space Grotesk" pitchFamily="34" charset="-120"/>
               </a:rPr>
-              <a:t>2 / 10</a:t>
-            </a:r>
-            <a:endParaRPr lang="en-US" sz="3589" dirty="0"/>
-          </a:p>
-        </p:txBody>
-      </p:sp>
-      <p:sp>
-        <p:nvSpPr>
-          <p:cNvPr id="12" name="Text 10"/>
-          <p:cNvSpPr/>
-          <p:nvPr/>
-        </p:nvSpPr>
-        <p:spPr>
-          <a:xfrm>
-            <a:off x="8142784" y="3111649"/>
-            <a:ext cx="3143834" cy="516880"/>
-          </a:xfrm>
-          <a:prstGeom prst="rect">
-            <a:avLst/>
-          </a:prstGeom>
-          <a:noFill/>
-          <a:ln/>
-        </p:spPr>
-        <p:txBody>
-          <a:bodyPr wrap="square" lIns="0" tIns="0" rIns="0" bIns="0" rtlCol="0" anchor="t">
-            <a:normAutofit/>
-          </a:bodyPr>
-          <a:lstStyle/>
-          <a:p>
-            <a:pPr algn="l" indent="0" marL="0">
-              <a:lnSpc>
-                <a:spcPts val="1936"/>
-              </a:lnSpc>
-              <a:buNone/>
-            </a:pPr>
-            <a:r>
-              <a:rPr lang="en-US" sz="1383" dirty="0">
+              <a:t>1 contradicted</a:t>
+            </a:r>
+            <a:endParaRPr lang="en-US" sz="2000" dirty="0"/>
+          </a:p>
+        </p:txBody>
+      </p:sp>
+      <p:sp>
+        <p:nvSpPr>
+          <p:cNvPr id="14" name="Text 11"/>
+          <p:cNvSpPr/>
+          <p:nvPr/>
+        </p:nvSpPr>
+        <p:spPr>
+          <a:xfrm>
+            <a:off x="6318250" y="3429347"/>
+            <a:ext cx="5212779" cy="471091"/>
+          </a:xfrm>
+          <a:prstGeom prst="rect">
+            <a:avLst/>
+          </a:prstGeom>
+          <a:noFill/>
+          <a:ln/>
+        </p:spPr>
+        <p:txBody>
+          <a:bodyPr wrap="square" lIns="0" tIns="0" rIns="0" bIns="0" rtlCol="0" anchor="t">
+            <a:normAutofit/>
+          </a:bodyPr>
+          <a:lstStyle/>
+          <a:p>
+            <a:pPr algn="l" indent="0" marL="0">
+              <a:lnSpc>
+                <a:spcPts val="1755"/>
+              </a:lnSpc>
+              <a:buNone/>
+            </a:pPr>
+            <a:r>
+              <a:rPr lang="en-US" sz="1300" dirty="0">
                 <a:solidFill>
                   <a:srgbClr val="BFD3C8"/>
                 </a:solidFill>
@@ -4554,34 +4637,30 @@
                 <a:ea typeface="IBM Plex Sans" pitchFamily="34" charset="-122"/>
                 <a:cs typeface="IBM Plex Sans" pitchFamily="34" charset="-120"/>
               </a:rPr>
-              <a:t>for the smaller model (qwen2.5:7b): careful models resist</a:t>
-            </a:r>
-            <a:endParaRPr lang="en-US" sz="1383" dirty="0"/>
-          </a:p>
-        </p:txBody>
-      </p:sp>
-      <p:sp>
-        <p:nvSpPr>
-          <p:cNvPr id="13" name="Shape 11"/>
-          <p:cNvSpPr/>
-          <p:nvPr/>
-        </p:nvSpPr>
-        <p:spPr>
-          <a:xfrm>
-            <a:off x="815975" y="3942854"/>
-            <a:ext cx="3414167" cy="1561654"/>
-          </a:xfrm>
-          <a:prstGeom prst="roundRect">
-            <a:avLst>
-              <a:gd name="adj" fmla="val 6303"/>
-            </a:avLst>
-          </a:prstGeom>
-          <a:solidFill>
-            <a:srgbClr val="18221E"/>
-          </a:solidFill>
-          <a:ln w="6350">
+              <a:t>4 claims checked against the logs. “Authorized”: contradicted, no pentest registered.</a:t>
+            </a:r>
+            <a:endParaRPr lang="en-US" sz="1300" dirty="0"/>
+          </a:p>
+        </p:txBody>
+      </p:sp>
+      <p:sp>
+        <p:nvSpPr>
+          <p:cNvPr id="15" name="Shape 12"/>
+          <p:cNvSpPr/>
+          <p:nvPr/>
+        </p:nvSpPr>
+        <p:spPr>
+          <a:xfrm>
+            <a:off x="6153150" y="4065538"/>
+            <a:ext cx="0" cy="801291"/>
+          </a:xfrm>
+          <a:prstGeom prst="line">
+            <a:avLst/>
+          </a:prstGeom>
+          <a:noFill/>
+          <a:ln w="25400">
             <a:solidFill>
-              <a:srgbClr val="2C3D36"/>
+              <a:srgbClr val="7BE0A0"/>
             </a:solidFill>
             <a:prstDash val="solid"/>
           </a:ln>
@@ -4589,35 +4668,35 @@
       </p:sp>
       <p:sp>
         <p:nvSpPr>
-          <p:cNvPr id="14" name="Text 12"/>
-          <p:cNvSpPr/>
-          <p:nvPr/>
-        </p:nvSpPr>
-        <p:spPr>
-          <a:xfrm>
-            <a:off x="996950" y="4123829"/>
-            <a:ext cx="3143783" cy="543967"/>
-          </a:xfrm>
-          <a:prstGeom prst="rect">
-            <a:avLst/>
-          </a:prstGeom>
-          <a:noFill/>
-          <a:ln/>
-        </p:spPr>
-        <p:txBody>
-          <a:bodyPr wrap="square" lIns="0" tIns="0" rIns="0" bIns="0" rtlCol="0" anchor="t">
-            <a:normAutofit/>
-          </a:bodyPr>
-          <a:lstStyle/>
-          <a:p>
-            <a:pPr algn="l" indent="0" marL="0">
-              <a:lnSpc>
-                <a:spcPts val="4111"/>
-              </a:lnSpc>
-              <a:buNone/>
-            </a:pPr>
-            <a:r>
-              <a:rPr lang="en-US" sz="2936" b="1" dirty="0">
+          <p:cNvPr id="16" name="Text 13"/>
+          <p:cNvSpPr/>
+          <p:nvPr/>
+        </p:nvSpPr>
+        <p:spPr>
+          <a:xfrm>
+            <a:off x="6318250" y="4090938"/>
+            <a:ext cx="5212779" cy="304800"/>
+          </a:xfrm>
+          <a:prstGeom prst="rect">
+            <a:avLst/>
+          </a:prstGeom>
+          <a:noFill/>
+          <a:ln/>
+        </p:spPr>
+        <p:txBody>
+          <a:bodyPr wrap="square" lIns="0" tIns="0" rIns="0" bIns="0" rtlCol="0" anchor="t">
+            <a:normAutofit/>
+          </a:bodyPr>
+          <a:lstStyle/>
+          <a:p>
+            <a:pPr algn="l" indent="0" marL="0">
+              <a:lnSpc>
+                <a:spcPts val="2200"/>
+              </a:lnSpc>
+              <a:buNone/>
+            </a:pPr>
+            <a:r>
+              <a:rPr lang="en-US" sz="2000" b="1" dirty="0">
                 <a:solidFill>
                   <a:srgbClr val="7BE0A0"/>
                 </a:solidFill>
@@ -4625,43 +4704,43 @@
                 <a:ea typeface="Space Grotesk" pitchFamily="34" charset="-122"/>
                 <a:cs typeface="Space Grotesk" pitchFamily="34" charset="-120"/>
               </a:rPr>
-              <a:t>Live</a:t>
-            </a:r>
-            <a:endParaRPr lang="en-US" sz="2936" dirty="0"/>
-          </a:p>
-        </p:txBody>
-      </p:sp>
-      <p:sp>
-        <p:nvSpPr>
-          <p:cNvPr id="15" name="Text 13"/>
-          <p:cNvSpPr/>
-          <p:nvPr/>
-        </p:nvSpPr>
-        <p:spPr>
-          <a:xfrm>
-            <a:off x="996950" y="4718596"/>
-            <a:ext cx="3143783" cy="630337"/>
-          </a:xfrm>
-          <a:prstGeom prst="rect">
-            <a:avLst/>
-          </a:prstGeom>
-          <a:noFill/>
-          <a:ln/>
-        </p:spPr>
-        <p:txBody>
-          <a:bodyPr wrap="square" lIns="0" tIns="0" rIns="0" bIns="0" rtlCol="0" anchor="t">
-            <a:normAutofit/>
-          </a:bodyPr>
-          <a:lstStyle/>
-          <a:p>
-            <a:pPr algn="l" indent="0" marL="0">
-              <a:lnSpc>
-                <a:spcPts val="1586"/>
-              </a:lnSpc>
-              <a:buNone/>
-            </a:pPr>
-            <a:r>
-              <a:rPr lang="en-US" sz="1133" dirty="0">
+              <a:t>Not sent</a:t>
+            </a:r>
+            <a:endParaRPr lang="en-US" sz="2000" dirty="0"/>
+          </a:p>
+        </p:txBody>
+      </p:sp>
+      <p:sp>
+        <p:nvSpPr>
+          <p:cNvPr id="17" name="Text 14"/>
+          <p:cNvSpPr/>
+          <p:nvPr/>
+        </p:nvSpPr>
+        <p:spPr>
+          <a:xfrm>
+            <a:off x="6318250" y="4395738"/>
+            <a:ext cx="5212779" cy="471091"/>
+          </a:xfrm>
+          <a:prstGeom prst="rect">
+            <a:avLst/>
+          </a:prstGeom>
+          <a:noFill/>
+          <a:ln/>
+        </p:spPr>
+        <p:txBody>
+          <a:bodyPr wrap="square" lIns="0" tIns="0" rIns="0" bIns="0" rtlCol="0" anchor="t">
+            <a:normAutofit/>
+          </a:bodyPr>
+          <a:lstStyle/>
+          <a:p>
+            <a:pPr algn="l" indent="0" marL="0">
+              <a:lnSpc>
+                <a:spcPts val="1755"/>
+              </a:lnSpc>
+              <a:buNone/>
+            </a:pPr>
+            <a:r>
+              <a:rPr lang="en-US" sz="1300" dirty="0">
                 <a:solidFill>
                   <a:srgbClr val="BFD3C8"/>
                 </a:solidFill>
@@ -4669,34 +4748,30 @@
                 <a:ea typeface="IBM Plex Sans" pitchFamily="34" charset="-122"/>
                 <a:cs typeface="IBM Plex Sans" pitchFamily="34" charset="-120"/>
               </a:rPr>
-              <a:t>swap time read from the guard on the incident card, in the demo you just saw (target: under 1 s)</a:t>
-            </a:r>
-            <a:endParaRPr lang="en-US" sz="1133" dirty="0"/>
-          </a:p>
-        </p:txBody>
-      </p:sp>
-      <p:sp>
-        <p:nvSpPr>
-          <p:cNvPr id="16" name="Shape 14"/>
-          <p:cNvSpPr/>
-          <p:nvPr/>
-        </p:nvSpPr>
-        <p:spPr>
-          <a:xfrm>
-            <a:off x="4388892" y="3942854"/>
-            <a:ext cx="3414167" cy="1561654"/>
-          </a:xfrm>
-          <a:prstGeom prst="roundRect">
-            <a:avLst>
-              <a:gd name="adj" fmla="val 6303"/>
-            </a:avLst>
-          </a:prstGeom>
-          <a:solidFill>
-            <a:srgbClr val="18221E"/>
-          </a:solidFill>
-          <a:ln w="6350">
+              <a:t>AI drafts of the summary and NIS2 early warning wait for the analyst’s approval.</a:t>
+            </a:r>
+            <a:endParaRPr lang="en-US" sz="1300" dirty="0"/>
+          </a:p>
+        </p:txBody>
+      </p:sp>
+      <p:sp>
+        <p:nvSpPr>
+          <p:cNvPr id="18" name="Shape 15"/>
+          <p:cNvSpPr/>
+          <p:nvPr/>
+        </p:nvSpPr>
+        <p:spPr>
+          <a:xfrm>
+            <a:off x="6153150" y="5031929"/>
+            <a:ext cx="0" cy="578445"/>
+          </a:xfrm>
+          <a:prstGeom prst="line">
+            <a:avLst/>
+          </a:prstGeom>
+          <a:noFill/>
+          <a:ln w="25400">
             <a:solidFill>
-              <a:srgbClr val="2C3D36"/>
+              <a:srgbClr val="7BE0A0"/>
             </a:solidFill>
             <a:prstDash val="solid"/>
           </a:ln>
@@ -4704,35 +4779,35 @@
       </p:sp>
       <p:sp>
         <p:nvSpPr>
-          <p:cNvPr id="17" name="Text 15"/>
-          <p:cNvSpPr/>
-          <p:nvPr/>
-        </p:nvSpPr>
-        <p:spPr>
-          <a:xfrm>
-            <a:off x="4569867" y="4123829"/>
-            <a:ext cx="3143783" cy="657423"/>
-          </a:xfrm>
-          <a:prstGeom prst="rect">
-            <a:avLst/>
-          </a:prstGeom>
-          <a:noFill/>
-          <a:ln/>
-        </p:spPr>
-        <p:txBody>
-          <a:bodyPr wrap="square" lIns="0" tIns="0" rIns="0" bIns="0" rtlCol="0" anchor="t">
-            <a:normAutofit/>
-          </a:bodyPr>
-          <a:lstStyle/>
-          <a:p>
-            <a:pPr algn="l" indent="0" marL="0">
-              <a:lnSpc>
-                <a:spcPts val="5024"/>
-              </a:lnSpc>
-              <a:buNone/>
-            </a:pPr>
-            <a:r>
-              <a:rPr lang="en-US" sz="3589" b="1" dirty="0">
+          <p:cNvPr id="19" name="Text 16"/>
+          <p:cNvSpPr/>
+          <p:nvPr/>
+        </p:nvSpPr>
+        <p:spPr>
+          <a:xfrm>
+            <a:off x="6318250" y="5057329"/>
+            <a:ext cx="5212779" cy="304800"/>
+          </a:xfrm>
+          <a:prstGeom prst="rect">
+            <a:avLst/>
+          </a:prstGeom>
+          <a:noFill/>
+          <a:ln/>
+        </p:spPr>
+        <p:txBody>
+          <a:bodyPr wrap="square" lIns="0" tIns="0" rIns="0" bIns="0" rtlCol="0" anchor="t">
+            <a:normAutofit/>
+          </a:bodyPr>
+          <a:lstStyle/>
+          <a:p>
+            <a:pPr algn="l" indent="0" marL="0">
+              <a:lnSpc>
+                <a:spcPts val="2200"/>
+              </a:lnSpc>
+              <a:buNone/>
+            </a:pPr>
+            <a:r>
+              <a:rPr lang="en-US" sz="2000" b="1" dirty="0">
                 <a:solidFill>
                   <a:srgbClr val="7BE0A0"/>
                 </a:solidFill>
@@ -4740,43 +4815,43 @@
                 <a:ea typeface="Space Grotesk" pitchFamily="34" charset="-122"/>
                 <a:cs typeface="Space Grotesk" pitchFamily="34" charset="-120"/>
               </a:rPr>
-              <a:t>3 tags</a:t>
-            </a:r>
-            <a:endParaRPr lang="en-US" sz="3589" dirty="0"/>
-          </a:p>
-        </p:txBody>
-      </p:sp>
-      <p:sp>
-        <p:nvSpPr>
-          <p:cNvPr id="18" name="Text 16"/>
-          <p:cNvSpPr/>
-          <p:nvPr/>
-        </p:nvSpPr>
-        <p:spPr>
-          <a:xfrm>
-            <a:off x="4569867" y="4832052"/>
-            <a:ext cx="3143783" cy="516880"/>
-          </a:xfrm>
-          <a:prstGeom prst="rect">
-            <a:avLst/>
-          </a:prstGeom>
-          <a:noFill/>
-          <a:ln/>
-        </p:spPr>
-        <p:txBody>
-          <a:bodyPr wrap="square" lIns="0" tIns="0" rIns="0" bIns="0" rtlCol="0" anchor="t">
-            <a:normAutofit/>
-          </a:bodyPr>
-          <a:lstStyle/>
-          <a:p>
-            <a:pPr algn="l" indent="0" marL="0">
-              <a:lnSpc>
-                <a:spcPts val="1936"/>
-              </a:lnSpc>
-              <a:buNone/>
-            </a:pPr>
-            <a:r>
-              <a:rPr lang="en-US" sz="1383" dirty="0">
+              <a:t>12 events, 1 card</a:t>
+            </a:r>
+            <a:endParaRPr lang="en-US" sz="2000" dirty="0"/>
+          </a:p>
+        </p:txBody>
+      </p:sp>
+      <p:sp>
+        <p:nvSpPr>
+          <p:cNvPr id="20" name="Text 17"/>
+          <p:cNvSpPr/>
+          <p:nvPr/>
+        </p:nvSpPr>
+        <p:spPr>
+          <a:xfrm>
+            <a:off x="6318250" y="5362129"/>
+            <a:ext cx="5212779" cy="248245"/>
+          </a:xfrm>
+          <a:prstGeom prst="rect">
+            <a:avLst/>
+          </a:prstGeom>
+          <a:noFill/>
+          <a:ln/>
+        </p:spPr>
+        <p:txBody>
+          <a:bodyPr wrap="square" lIns="0" tIns="0" rIns="0" bIns="0" rtlCol="0" anchor="t">
+            <a:normAutofit/>
+          </a:bodyPr>
+          <a:lstStyle/>
+          <a:p>
+            <a:pPr algn="l" indent="0" marL="0">
+              <a:lnSpc>
+                <a:spcPts val="1755"/>
+              </a:lnSpc>
+              <a:buNone/>
+            </a:pPr>
+            <a:r>
+              <a:rPr lang="en-US" sz="1300" dirty="0">
                 <a:solidFill>
                   <a:srgbClr val="BFD3C8"/>
                 </a:solidFill>
@@ -4784,212 +4859,53 @@
                 <a:ea typeface="IBM Plex Sans" pitchFamily="34" charset="-122"/>
                 <a:cs typeface="IBM Plex Sans" pitchFamily="34" charset="-120"/>
               </a:rPr>
-              <a:t>every claim checked against the logs: confirmed, unverified, contradicted</a:t>
-            </a:r>
-            <a:endParaRPr lang="en-US" sz="1383" dirty="0"/>
-          </a:p>
-        </p:txBody>
-      </p:sp>
-      <p:sp>
-        <p:nvSpPr>
-          <p:cNvPr id="19" name="Shape 17"/>
-          <p:cNvSpPr/>
-          <p:nvPr/>
-        </p:nvSpPr>
-        <p:spPr>
-          <a:xfrm>
-            <a:off x="7961809" y="3942854"/>
-            <a:ext cx="3414216" cy="1561654"/>
-          </a:xfrm>
-          <a:prstGeom prst="roundRect">
-            <a:avLst>
-              <a:gd name="adj" fmla="val 6303"/>
-            </a:avLst>
-          </a:prstGeom>
-          <a:solidFill>
-            <a:srgbClr val="18221E"/>
-          </a:solidFill>
-          <a:ln w="6350">
-            <a:solidFill>
-              <a:srgbClr val="2C3D36"/>
-            </a:solidFill>
-            <a:prstDash val="solid"/>
-          </a:ln>
-        </p:spPr>
-      </p:sp>
-      <p:sp>
-        <p:nvSpPr>
-          <p:cNvPr id="20" name="Text 18"/>
-          <p:cNvSpPr/>
-          <p:nvPr/>
-        </p:nvSpPr>
-        <p:spPr>
-          <a:xfrm>
-            <a:off x="8142784" y="4123829"/>
-            <a:ext cx="3143834" cy="657423"/>
-          </a:xfrm>
-          <a:prstGeom prst="rect">
-            <a:avLst/>
-          </a:prstGeom>
-          <a:noFill/>
-          <a:ln/>
-        </p:spPr>
-        <p:txBody>
-          <a:bodyPr wrap="square" lIns="0" tIns="0" rIns="0" bIns="0" rtlCol="0" anchor="t">
-            <a:normAutofit/>
-          </a:bodyPr>
-          <a:lstStyle/>
-          <a:p>
-            <a:pPr algn="l" indent="0" marL="0">
-              <a:lnSpc>
-                <a:spcPts val="5024"/>
-              </a:lnSpc>
-              <a:buNone/>
-            </a:pPr>
-            <a:r>
-              <a:rPr lang="en-US" sz="3589" b="1" dirty="0">
-                <a:solidFill>
-                  <a:srgbClr val="7BE0A0"/>
-                </a:solidFill>
-                <a:latin typeface="Space Grotesk" pitchFamily="34" charset="0"/>
-                <a:ea typeface="Space Grotesk" pitchFamily="34" charset="-122"/>
-                <a:cs typeface="Space Grotesk" pitchFamily="34" charset="-120"/>
-              </a:rPr>
-              <a:t>Next</a:t>
-            </a:r>
-            <a:endParaRPr lang="en-US" sz="3589" dirty="0"/>
-          </a:p>
-        </p:txBody>
-      </p:sp>
-      <p:sp>
-        <p:nvSpPr>
-          <p:cNvPr id="21" name="Text 19"/>
-          <p:cNvSpPr/>
-          <p:nvPr/>
-        </p:nvSpPr>
-        <p:spPr>
-          <a:xfrm>
-            <a:off x="8142784" y="4832052"/>
-            <a:ext cx="3143834" cy="516880"/>
-          </a:xfrm>
-          <a:prstGeom prst="rect">
-            <a:avLst/>
-          </a:prstGeom>
-          <a:noFill/>
-          <a:ln/>
-        </p:spPr>
-        <p:txBody>
-          <a:bodyPr wrap="square" lIns="0" tIns="0" rIns="0" bIns="0" rtlCol="0" anchor="t">
-            <a:normAutofit/>
-          </a:bodyPr>
-          <a:lstStyle/>
-          <a:p>
-            <a:pPr algn="l" indent="0" marL="0">
-              <a:lnSpc>
-                <a:spcPts val="1936"/>
-              </a:lnSpc>
-              <a:buNone/>
-            </a:pPr>
-            <a:r>
-              <a:rPr lang="en-US" sz="1383" dirty="0">
-                <a:solidFill>
-                  <a:srgbClr val="BFD3C8"/>
-                </a:solidFill>
-                <a:latin typeface="IBM Plex Sans" pitchFamily="34" charset="0"/>
-                <a:ea typeface="IBM Plex Sans" pitchFamily="34" charset="-122"/>
-                <a:cs typeface="IBM Plex Sans" pitchFamily="34" charset="-120"/>
-              </a:rPr>
-              <a:t>detection and false-alarm rates at scale, measured during pilots</a:t>
-            </a:r>
-            <a:endParaRPr lang="en-US" sz="1383" dirty="0"/>
-          </a:p>
-        </p:txBody>
-      </p:sp>
-      <p:sp>
-        <p:nvSpPr>
-          <p:cNvPr id="22" name="Text 20"/>
-          <p:cNvSpPr/>
-          <p:nvPr/>
-        </p:nvSpPr>
-        <p:spPr>
-          <a:xfrm>
-            <a:off x="812800" y="5685482"/>
-            <a:ext cx="10883392" cy="181918"/>
-          </a:xfrm>
-          <a:prstGeom prst="rect">
-            <a:avLst/>
-          </a:prstGeom>
-          <a:noFill/>
-          <a:ln/>
-        </p:spPr>
-        <p:txBody>
-          <a:bodyPr wrap="square" lIns="0" tIns="0" rIns="0" bIns="0" rtlCol="0" anchor="t">
-            <a:normAutofit/>
-          </a:bodyPr>
-          <a:lstStyle/>
-          <a:p>
-            <a:pPr algn="l" indent="0" marL="0">
-              <a:lnSpc>
-                <a:spcPts val="1274"/>
-              </a:lnSpc>
-              <a:buNone/>
-            </a:pPr>
-            <a:r>
-              <a:rPr lang="en-US" sz="980" dirty="0">
-                <a:solidFill>
-                  <a:srgbClr val="7BE0A0"/>
+              <a:t>The full timeline, tagged with ATT&amp;CK, sits under the card.</a:t>
+            </a:r>
+            <a:endParaRPr lang="en-US" sz="1300" dirty="0"/>
+          </a:p>
+        </p:txBody>
+      </p:sp>
+      <p:sp>
+        <p:nvSpPr>
+          <p:cNvPr id="21" name="Text 18"/>
+          <p:cNvSpPr/>
+          <p:nvPr/>
+        </p:nvSpPr>
+        <p:spPr>
+          <a:xfrm>
+            <a:off x="812800" y="6256040"/>
+            <a:ext cx="10883392" cy="220960"/>
+          </a:xfrm>
+          <a:prstGeom prst="rect">
+            <a:avLst/>
+          </a:prstGeom>
+          <a:noFill/>
+          <a:ln/>
+        </p:spPr>
+        <p:txBody>
+          <a:bodyPr wrap="square" lIns="0" tIns="0" rIns="0" bIns="0" rtlCol="0" anchor="t">
+            <a:normAutofit/>
+          </a:bodyPr>
+          <a:lstStyle/>
+          <a:p>
+            <a:pPr algn="l" indent="0" marL="0">
+              <a:lnSpc>
+                <a:spcPts val="1540"/>
+              </a:lnSpc>
+              <a:buNone/>
+            </a:pPr>
+            <a:r>
+              <a:rPr lang="en-US" sz="1100" dirty="0">
+                <a:solidFill>
+                  <a:srgbClr val="9DB3A8"/>
                 </a:solidFill>
                 <a:latin typeface="JetBrains Mono" pitchFamily="49" charset="0"/>
                 <a:ea typeface="JetBrains Mono" pitchFamily="49" charset="-122"/>
                 <a:cs typeface="JetBrains Mono" pitchFamily="49" charset="-120"/>
               </a:rPr>
-              <a:t>ATT&amp;CK T1059 · T1083 · T1005 · T1552.001 · T1078 · ATLAS AML.T0051 · OWASP ASI01, used defensively</a:t>
-            </a:r>
-            <a:endParaRPr lang="en-US" sz="980" dirty="0"/>
-          </a:p>
-        </p:txBody>
-      </p:sp>
-      <p:sp>
-        <p:nvSpPr>
-          <p:cNvPr id="23" name="Text 21"/>
-          <p:cNvSpPr/>
-          <p:nvPr/>
-        </p:nvSpPr>
-        <p:spPr>
-          <a:xfrm>
-            <a:off x="812800" y="6238280"/>
-            <a:ext cx="10883392" cy="238720"/>
-          </a:xfrm>
-          <a:prstGeom prst="rect">
-            <a:avLst/>
-          </a:prstGeom>
-          <a:noFill/>
-          <a:ln/>
-        </p:spPr>
-        <p:txBody>
-          <a:bodyPr wrap="square" lIns="0" tIns="0" rIns="0" bIns="0" rtlCol="0" anchor="t">
-            <a:normAutofit/>
-          </a:bodyPr>
-          <a:lstStyle/>
-          <a:p>
-            <a:pPr algn="l" indent="0" marL="0">
-              <a:lnSpc>
-                <a:spcPts val="1680"/>
-              </a:lnSpc>
-              <a:buNone/>
-            </a:pPr>
-            <a:r>
-              <a:rPr lang="en-US" sz="1200" dirty="0">
-                <a:solidFill>
-                  <a:srgbClr val="9DB3A8"/>
-                </a:solidFill>
-                <a:latin typeface="IBM Plex Sans" pitchFamily="34" charset="0"/>
-                <a:ea typeface="IBM Plex Sans" pitchFamily="34" charset="-122"/>
-                <a:cs typeface="IBM Plex Sans" pitchFamily="34" charset="-120"/>
-              </a:rPr>
-              <a:t>Test scenarios: hand-written event sequences (mirage/fakes.py) · Confessions: live runs on local Ollama models · Synthetic data only</a:t>
-            </a:r>
-            <a:endParaRPr lang="en-US" sz="1200" dirty="0"/>
+              <a:t>Screenshot from one live run · Lumen Health is fictional, all data synthetic</a:t>
+            </a:r>
+            <a:endParaRPr lang="en-US" sz="1100" dirty="0"/>
           </a:p>
         </p:txBody>
       </p:sp>
@@ -5004,6 +4920,906 @@
 <file path=ppt/slides/slide6.xml><?xml version="1.0" encoding="utf-8"?>
 <p:sld xmlns:a="http://schemas.openxmlformats.org/drawingml/2006/main" xmlns:r="http://schemas.openxmlformats.org/officeDocument/2006/relationships" xmlns:p="http://schemas.openxmlformats.org/presentationml/2006/main">
   <p:cSld name="Slide 6">
+    <p:bg>
+      <p:bgPr>
+        <a:solidFill>
+          <a:srgbClr val="0E1512"/>
+        </a:solidFill>
+      </p:bgPr>
+    </p:bg>
+    <p:spTree>
+      <p:nvGrpSpPr>
+        <p:cNvPr id="1" name=""/>
+        <p:cNvGrpSpPr/>
+        <p:nvPr/>
+      </p:nvGrpSpPr>
+      <p:grpSpPr>
+        <a:xfrm>
+          <a:off x="0" y="0"/>
+          <a:ext cx="0" cy="0"/>
+          <a:chOff x="0" y="0"/>
+          <a:chExt cx="0" cy="0"/>
+        </a:xfrm>
+      </p:grpSpPr>
+      <p:sp>
+        <p:nvSpPr>
+          <p:cNvPr id="2" name="Text 0"/>
+          <p:cNvSpPr/>
+          <p:nvPr/>
+        </p:nvSpPr>
+        <p:spPr>
+          <a:xfrm>
+            <a:off x="812800" y="812800"/>
+            <a:ext cx="10883392" cy="209302"/>
+          </a:xfrm>
+          <a:prstGeom prst="rect">
+            <a:avLst/>
+          </a:prstGeom>
+          <a:noFill/>
+          <a:ln/>
+        </p:spPr>
+        <p:txBody>
+          <a:bodyPr wrap="square" lIns="0" tIns="0" rIns="0" bIns="0" rtlCol="0" anchor="t">
+            <a:normAutofit/>
+          </a:bodyPr>
+          <a:lstStyle/>
+          <a:p>
+            <a:pPr algn="l" indent="0" marL="0">
+              <a:lnSpc>
+                <a:spcPts val="1470"/>
+              </a:lnSpc>
+              <a:buNone/>
+            </a:pPr>
+            <a:r>
+              <a:rPr lang="en-US" sz="1050" spc="200" kern="0" dirty="0">
+                <a:solidFill>
+                  <a:srgbClr val="7BE0A0"/>
+                </a:solidFill>
+                <a:latin typeface="JetBrains Mono" pitchFamily="49" charset="0"/>
+                <a:ea typeface="JetBrains Mono" pitchFamily="49" charset="-122"/>
+                <a:cs typeface="JetBrains Mono" pitchFamily="49" charset="-120"/>
+              </a:rPr>
+              <a:t>WHAT WE TESTED, AND HOW</a:t>
+            </a:r>
+            <a:endParaRPr lang="en-US" sz="1050" dirty="0"/>
+          </a:p>
+        </p:txBody>
+      </p:sp>
+      <p:sp>
+        <p:nvSpPr>
+          <p:cNvPr id="3" name="Text 1"/>
+          <p:cNvSpPr/>
+          <p:nvPr>
+            <p:ph type="title"/>
+          </p:nvPr>
+        </p:nvSpPr>
+        <p:spPr>
+          <a:xfrm>
+            <a:off x="812800" y="1174502"/>
+            <a:ext cx="10883392" cy="892373"/>
+          </a:xfrm>
+          <a:prstGeom prst="rect">
+            <a:avLst/>
+          </a:prstGeom>
+          <a:noFill/>
+          <a:ln/>
+        </p:spPr>
+        <p:txBody>
+          <a:bodyPr wrap="square" lIns="0" tIns="0" rIns="0" bIns="0" rtlCol="0" anchor="t">
+            <a:normAutofit/>
+          </a:bodyPr>
+          <a:lstStyle/>
+          <a:p>
+            <a:pPr algn="l" indent="0" marL="0">
+              <a:lnSpc>
+                <a:spcPts val="3428"/>
+              </a:lnSpc>
+              <a:buNone/>
+            </a:pPr>
+            <a:r>
+              <a:rPr lang="en-US" sz="3116" b="1" i="0" dirty="0">
+                <a:solidFill>
+                  <a:srgbClr val="F2F5F0"/>
+                </a:solidFill>
+                <a:latin typeface="Space Grotesk" pitchFamily="34" charset="0"/>
+                <a:ea typeface="Space Grotesk" pitchFamily="34" charset="-122"/>
+                <a:cs typeface="Space Grotesk" pitchFamily="34" charset="-120"/>
+              </a:rPr>
+              <a:t>Logic validated on test scenarios. Confessions measured live.</a:t>
+            </a:r>
+            <a:endParaRPr lang="en-US" sz="3116" dirty="0"/>
+          </a:p>
+        </p:txBody>
+      </p:sp>
+      <p:sp>
+        <p:nvSpPr>
+          <p:cNvPr id="4" name="Shape 2"/>
+          <p:cNvSpPr/>
+          <p:nvPr/>
+        </p:nvSpPr>
+        <p:spPr>
+          <a:xfrm>
+            <a:off x="815975" y="2222450"/>
+            <a:ext cx="3414167" cy="1561654"/>
+          </a:xfrm>
+          <a:prstGeom prst="roundRect">
+            <a:avLst>
+              <a:gd name="adj" fmla="val 6303"/>
+            </a:avLst>
+          </a:prstGeom>
+          <a:solidFill>
+            <a:srgbClr val="18221E"/>
+          </a:solidFill>
+          <a:ln w="6350">
+            <a:solidFill>
+              <a:srgbClr val="2C3D36"/>
+            </a:solidFill>
+            <a:prstDash val="solid"/>
+          </a:ln>
+        </p:spPr>
+      </p:sp>
+      <p:sp>
+        <p:nvSpPr>
+          <p:cNvPr id="5" name="Text 3"/>
+          <p:cNvSpPr/>
+          <p:nvPr/>
+        </p:nvSpPr>
+        <p:spPr>
+          <a:xfrm>
+            <a:off x="996950" y="2403425"/>
+            <a:ext cx="3143783" cy="543967"/>
+          </a:xfrm>
+          <a:prstGeom prst="rect">
+            <a:avLst/>
+          </a:prstGeom>
+          <a:noFill/>
+          <a:ln/>
+        </p:spPr>
+        <p:txBody>
+          <a:bodyPr wrap="square" lIns="0" tIns="0" rIns="0" bIns="0" rtlCol="0" anchor="t">
+            <a:normAutofit/>
+          </a:bodyPr>
+          <a:lstStyle/>
+          <a:p>
+            <a:pPr algn="l" indent="0" marL="0">
+              <a:lnSpc>
+                <a:spcPts val="4111"/>
+              </a:lnSpc>
+              <a:buNone/>
+            </a:pPr>
+            <a:r>
+              <a:rPr lang="en-US" sz="2936" b="1" dirty="0">
+                <a:solidFill>
+                  <a:srgbClr val="7BE0A0"/>
+                </a:solidFill>
+                <a:latin typeface="Space Grotesk" pitchFamily="34" charset="0"/>
+                <a:ea typeface="Space Grotesk" pitchFamily="34" charset="-122"/>
+                <a:cs typeface="Space Grotesk" pitchFamily="34" charset="-120"/>
+              </a:rPr>
+              <a:t>4 / 4</a:t>
+            </a:r>
+            <a:endParaRPr lang="en-US" sz="2936" dirty="0"/>
+          </a:p>
+        </p:txBody>
+      </p:sp>
+      <p:sp>
+        <p:nvSpPr>
+          <p:cNvPr id="6" name="Text 4"/>
+          <p:cNvSpPr/>
+          <p:nvPr/>
+        </p:nvSpPr>
+        <p:spPr>
+          <a:xfrm>
+            <a:off x="996950" y="2998192"/>
+            <a:ext cx="3143783" cy="630337"/>
+          </a:xfrm>
+          <a:prstGeom prst="rect">
+            <a:avLst/>
+          </a:prstGeom>
+          <a:noFill/>
+          <a:ln/>
+        </p:spPr>
+        <p:txBody>
+          <a:bodyPr wrap="square" lIns="0" tIns="0" rIns="0" bIns="0" rtlCol="0" anchor="t">
+            <a:normAutofit/>
+          </a:bodyPr>
+          <a:lstStyle/>
+          <a:p>
+            <a:pPr algn="l" indent="0" marL="0">
+              <a:lnSpc>
+                <a:spcPts val="1617"/>
+              </a:lnSpc>
+              <a:buNone/>
+            </a:pPr>
+            <a:r>
+              <a:rPr lang="en-US" sz="1155" dirty="0">
+                <a:solidFill>
+                  <a:srgbClr val="BFD3C8"/>
+                </a:solidFill>
+                <a:latin typeface="IBM Plex Sans" pitchFamily="34" charset="0"/>
+                <a:ea typeface="IBM Plex Sans" pitchFamily="34" charset="-122"/>
+                <a:cs typeface="IBM Plex Sans" pitchFamily="34" charset="-120"/>
+              </a:rPr>
+              <a:t>test scenarios detected and labelled correctly: AI agent, guided AI, script, human (logic test)</a:t>
+            </a:r>
+            <a:endParaRPr lang="en-US" sz="1155" dirty="0"/>
+          </a:p>
+        </p:txBody>
+      </p:sp>
+      <p:sp>
+        <p:nvSpPr>
+          <p:cNvPr id="7" name="Shape 5"/>
+          <p:cNvSpPr/>
+          <p:nvPr/>
+        </p:nvSpPr>
+        <p:spPr>
+          <a:xfrm>
+            <a:off x="4388892" y="2222450"/>
+            <a:ext cx="3414167" cy="1561654"/>
+          </a:xfrm>
+          <a:prstGeom prst="roundRect">
+            <a:avLst>
+              <a:gd name="adj" fmla="val 6303"/>
+            </a:avLst>
+          </a:prstGeom>
+          <a:solidFill>
+            <a:srgbClr val="18221E"/>
+          </a:solidFill>
+          <a:ln w="6350">
+            <a:solidFill>
+              <a:srgbClr val="2C3D36"/>
+            </a:solidFill>
+            <a:prstDash val="solid"/>
+          </a:ln>
+        </p:spPr>
+      </p:sp>
+      <p:sp>
+        <p:nvSpPr>
+          <p:cNvPr id="8" name="Text 6"/>
+          <p:cNvSpPr/>
+          <p:nvPr/>
+        </p:nvSpPr>
+        <p:spPr>
+          <a:xfrm>
+            <a:off x="4569867" y="2403425"/>
+            <a:ext cx="3143783" cy="657423"/>
+          </a:xfrm>
+          <a:prstGeom prst="rect">
+            <a:avLst/>
+          </a:prstGeom>
+          <a:noFill/>
+          <a:ln/>
+        </p:spPr>
+        <p:txBody>
+          <a:bodyPr wrap="square" lIns="0" tIns="0" rIns="0" bIns="0" rtlCol="0" anchor="t">
+            <a:normAutofit/>
+          </a:bodyPr>
+          <a:lstStyle/>
+          <a:p>
+            <a:pPr algn="l" indent="0" marL="0">
+              <a:lnSpc>
+                <a:spcPts val="5024"/>
+              </a:lnSpc>
+              <a:buNone/>
+            </a:pPr>
+            <a:r>
+              <a:rPr lang="en-US" sz="3589" b="1" dirty="0">
+                <a:solidFill>
+                  <a:srgbClr val="7BE0A0"/>
+                </a:solidFill>
+                <a:latin typeface="Space Grotesk" pitchFamily="34" charset="0"/>
+                <a:ea typeface="Space Grotesk" pitchFamily="34" charset="-122"/>
+                <a:cs typeface="Space Grotesk" pitchFamily="34" charset="-120"/>
+              </a:rPr>
+              <a:t>7 / 10</a:t>
+            </a:r>
+            <a:endParaRPr lang="en-US" sz="3589" dirty="0"/>
+          </a:p>
+        </p:txBody>
+      </p:sp>
+      <p:sp>
+        <p:nvSpPr>
+          <p:cNvPr id="9" name="Text 7"/>
+          <p:cNvSpPr/>
+          <p:nvPr/>
+        </p:nvSpPr>
+        <p:spPr>
+          <a:xfrm>
+            <a:off x="4569867" y="3111649"/>
+            <a:ext cx="3143783" cy="516880"/>
+          </a:xfrm>
+          <a:prstGeom prst="rect">
+            <a:avLst/>
+          </a:prstGeom>
+          <a:noFill/>
+          <a:ln/>
+        </p:spPr>
+        <p:txBody>
+          <a:bodyPr wrap="square" lIns="0" tIns="0" rIns="0" bIns="0" rtlCol="0" anchor="t">
+            <a:normAutofit/>
+          </a:bodyPr>
+          <a:lstStyle/>
+          <a:p>
+            <a:pPr algn="l" indent="0" marL="0">
+              <a:lnSpc>
+                <a:spcPts val="1936"/>
+              </a:lnSpc>
+              <a:buNone/>
+            </a:pPr>
+            <a:r>
+              <a:rPr lang="en-US" sz="1383" dirty="0">
+                <a:solidFill>
+                  <a:srgbClr val="BFD3C8"/>
+                </a:solidFill>
+                <a:latin typeface="IBM Plex Sans" pitchFamily="34" charset="0"/>
+                <a:ea typeface="IBM Plex Sans" pitchFamily="34" charset="-122"/>
+                <a:cs typeface="IBM Plex Sans" pitchFamily="34" charset="-120"/>
+              </a:rPr>
+              <a:t>live AI runs that confessed their mission (qwen3.5:35b, local)</a:t>
+            </a:r>
+            <a:endParaRPr lang="en-US" sz="1383" dirty="0"/>
+          </a:p>
+        </p:txBody>
+      </p:sp>
+      <p:sp>
+        <p:nvSpPr>
+          <p:cNvPr id="10" name="Shape 8"/>
+          <p:cNvSpPr/>
+          <p:nvPr/>
+        </p:nvSpPr>
+        <p:spPr>
+          <a:xfrm>
+            <a:off x="7961809" y="2222450"/>
+            <a:ext cx="3414216" cy="1561654"/>
+          </a:xfrm>
+          <a:prstGeom prst="roundRect">
+            <a:avLst>
+              <a:gd name="adj" fmla="val 6303"/>
+            </a:avLst>
+          </a:prstGeom>
+          <a:solidFill>
+            <a:srgbClr val="18221E"/>
+          </a:solidFill>
+          <a:ln w="6350">
+            <a:solidFill>
+              <a:srgbClr val="2C3D36"/>
+            </a:solidFill>
+            <a:prstDash val="solid"/>
+          </a:ln>
+        </p:spPr>
+      </p:sp>
+      <p:sp>
+        <p:nvSpPr>
+          <p:cNvPr id="11" name="Text 9"/>
+          <p:cNvSpPr/>
+          <p:nvPr/>
+        </p:nvSpPr>
+        <p:spPr>
+          <a:xfrm>
+            <a:off x="8142784" y="2403425"/>
+            <a:ext cx="3143834" cy="657423"/>
+          </a:xfrm>
+          <a:prstGeom prst="rect">
+            <a:avLst/>
+          </a:prstGeom>
+          <a:noFill/>
+          <a:ln/>
+        </p:spPr>
+        <p:txBody>
+          <a:bodyPr wrap="square" lIns="0" tIns="0" rIns="0" bIns="0" rtlCol="0" anchor="t">
+            <a:normAutofit/>
+          </a:bodyPr>
+          <a:lstStyle/>
+          <a:p>
+            <a:pPr algn="l" indent="0" marL="0">
+              <a:lnSpc>
+                <a:spcPts val="5024"/>
+              </a:lnSpc>
+              <a:buNone/>
+            </a:pPr>
+            <a:r>
+              <a:rPr lang="en-US" sz="3589" b="1" dirty="0">
+                <a:solidFill>
+                  <a:srgbClr val="7BE0A0"/>
+                </a:solidFill>
+                <a:latin typeface="Space Grotesk" pitchFamily="34" charset="0"/>
+                <a:ea typeface="Space Grotesk" pitchFamily="34" charset="-122"/>
+                <a:cs typeface="Space Grotesk" pitchFamily="34" charset="-120"/>
+              </a:rPr>
+              <a:t>2 / 10</a:t>
+            </a:r>
+            <a:endParaRPr lang="en-US" sz="3589" dirty="0"/>
+          </a:p>
+        </p:txBody>
+      </p:sp>
+      <p:sp>
+        <p:nvSpPr>
+          <p:cNvPr id="12" name="Text 10"/>
+          <p:cNvSpPr/>
+          <p:nvPr/>
+        </p:nvSpPr>
+        <p:spPr>
+          <a:xfrm>
+            <a:off x="8142784" y="3111649"/>
+            <a:ext cx="3143834" cy="516880"/>
+          </a:xfrm>
+          <a:prstGeom prst="rect">
+            <a:avLst/>
+          </a:prstGeom>
+          <a:noFill/>
+          <a:ln/>
+        </p:spPr>
+        <p:txBody>
+          <a:bodyPr wrap="square" lIns="0" tIns="0" rIns="0" bIns="0" rtlCol="0" anchor="t">
+            <a:normAutofit/>
+          </a:bodyPr>
+          <a:lstStyle/>
+          <a:p>
+            <a:pPr algn="l" indent="0" marL="0">
+              <a:lnSpc>
+                <a:spcPts val="1936"/>
+              </a:lnSpc>
+              <a:buNone/>
+            </a:pPr>
+            <a:r>
+              <a:rPr lang="en-US" sz="1383" dirty="0">
+                <a:solidFill>
+                  <a:srgbClr val="BFD3C8"/>
+                </a:solidFill>
+                <a:latin typeface="IBM Plex Sans" pitchFamily="34" charset="0"/>
+                <a:ea typeface="IBM Plex Sans" pitchFamily="34" charset="-122"/>
+                <a:cs typeface="IBM Plex Sans" pitchFamily="34" charset="-120"/>
+              </a:rPr>
+              <a:t>for the smaller model (qwen2.5:7b): careful models resist</a:t>
+            </a:r>
+            <a:endParaRPr lang="en-US" sz="1383" dirty="0"/>
+          </a:p>
+        </p:txBody>
+      </p:sp>
+      <p:sp>
+        <p:nvSpPr>
+          <p:cNvPr id="13" name="Shape 11"/>
+          <p:cNvSpPr/>
+          <p:nvPr/>
+        </p:nvSpPr>
+        <p:spPr>
+          <a:xfrm>
+            <a:off x="815975" y="3942854"/>
+            <a:ext cx="3414167" cy="1561654"/>
+          </a:xfrm>
+          <a:prstGeom prst="roundRect">
+            <a:avLst>
+              <a:gd name="adj" fmla="val 6303"/>
+            </a:avLst>
+          </a:prstGeom>
+          <a:solidFill>
+            <a:srgbClr val="18221E"/>
+          </a:solidFill>
+          <a:ln w="6350">
+            <a:solidFill>
+              <a:srgbClr val="2C3D36"/>
+            </a:solidFill>
+            <a:prstDash val="solid"/>
+          </a:ln>
+        </p:spPr>
+      </p:sp>
+      <p:sp>
+        <p:nvSpPr>
+          <p:cNvPr id="14" name="Text 12"/>
+          <p:cNvSpPr/>
+          <p:nvPr/>
+        </p:nvSpPr>
+        <p:spPr>
+          <a:xfrm>
+            <a:off x="996950" y="4123829"/>
+            <a:ext cx="3143783" cy="543967"/>
+          </a:xfrm>
+          <a:prstGeom prst="rect">
+            <a:avLst/>
+          </a:prstGeom>
+          <a:noFill/>
+          <a:ln/>
+        </p:spPr>
+        <p:txBody>
+          <a:bodyPr wrap="square" lIns="0" tIns="0" rIns="0" bIns="0" rtlCol="0" anchor="t">
+            <a:normAutofit/>
+          </a:bodyPr>
+          <a:lstStyle/>
+          <a:p>
+            <a:pPr algn="l" indent="0" marL="0">
+              <a:lnSpc>
+                <a:spcPts val="4111"/>
+              </a:lnSpc>
+              <a:buNone/>
+            </a:pPr>
+            <a:r>
+              <a:rPr lang="en-US" sz="2936" b="1" dirty="0">
+                <a:solidFill>
+                  <a:srgbClr val="7BE0A0"/>
+                </a:solidFill>
+                <a:latin typeface="Space Grotesk" pitchFamily="34" charset="0"/>
+                <a:ea typeface="Space Grotesk" pitchFamily="34" charset="-122"/>
+                <a:cs typeface="Space Grotesk" pitchFamily="34" charset="-120"/>
+              </a:rPr>
+              <a:t>Live</a:t>
+            </a:r>
+            <a:endParaRPr lang="en-US" sz="2936" dirty="0"/>
+          </a:p>
+        </p:txBody>
+      </p:sp>
+      <p:sp>
+        <p:nvSpPr>
+          <p:cNvPr id="15" name="Text 13"/>
+          <p:cNvSpPr/>
+          <p:nvPr/>
+        </p:nvSpPr>
+        <p:spPr>
+          <a:xfrm>
+            <a:off x="996950" y="4718596"/>
+            <a:ext cx="3143783" cy="630337"/>
+          </a:xfrm>
+          <a:prstGeom prst="rect">
+            <a:avLst/>
+          </a:prstGeom>
+          <a:noFill/>
+          <a:ln/>
+        </p:spPr>
+        <p:txBody>
+          <a:bodyPr wrap="square" lIns="0" tIns="0" rIns="0" bIns="0" rtlCol="0" anchor="t">
+            <a:normAutofit/>
+          </a:bodyPr>
+          <a:lstStyle/>
+          <a:p>
+            <a:pPr algn="l" indent="0" marL="0">
+              <a:lnSpc>
+                <a:spcPts val="1586"/>
+              </a:lnSpc>
+              <a:buNone/>
+            </a:pPr>
+            <a:r>
+              <a:rPr lang="en-US" sz="1133" dirty="0">
+                <a:solidFill>
+                  <a:srgbClr val="BFD3C8"/>
+                </a:solidFill>
+                <a:latin typeface="IBM Plex Sans" pitchFamily="34" charset="0"/>
+                <a:ea typeface="IBM Plex Sans" pitchFamily="34" charset="-122"/>
+                <a:cs typeface="IBM Plex Sans" pitchFamily="34" charset="-120"/>
+              </a:rPr>
+              <a:t>swap time read from the guard on the incident card, in the demo you just saw (target: under 1 s)</a:t>
+            </a:r>
+            <a:endParaRPr lang="en-US" sz="1133" dirty="0"/>
+          </a:p>
+        </p:txBody>
+      </p:sp>
+      <p:sp>
+        <p:nvSpPr>
+          <p:cNvPr id="16" name="Shape 14"/>
+          <p:cNvSpPr/>
+          <p:nvPr/>
+        </p:nvSpPr>
+        <p:spPr>
+          <a:xfrm>
+            <a:off x="4388892" y="3942854"/>
+            <a:ext cx="3414167" cy="1561654"/>
+          </a:xfrm>
+          <a:prstGeom prst="roundRect">
+            <a:avLst>
+              <a:gd name="adj" fmla="val 6303"/>
+            </a:avLst>
+          </a:prstGeom>
+          <a:solidFill>
+            <a:srgbClr val="18221E"/>
+          </a:solidFill>
+          <a:ln w="6350">
+            <a:solidFill>
+              <a:srgbClr val="2C3D36"/>
+            </a:solidFill>
+            <a:prstDash val="solid"/>
+          </a:ln>
+        </p:spPr>
+      </p:sp>
+      <p:sp>
+        <p:nvSpPr>
+          <p:cNvPr id="17" name="Text 15"/>
+          <p:cNvSpPr/>
+          <p:nvPr/>
+        </p:nvSpPr>
+        <p:spPr>
+          <a:xfrm>
+            <a:off x="4569867" y="4123829"/>
+            <a:ext cx="3143783" cy="657423"/>
+          </a:xfrm>
+          <a:prstGeom prst="rect">
+            <a:avLst/>
+          </a:prstGeom>
+          <a:noFill/>
+          <a:ln/>
+        </p:spPr>
+        <p:txBody>
+          <a:bodyPr wrap="square" lIns="0" tIns="0" rIns="0" bIns="0" rtlCol="0" anchor="t">
+            <a:normAutofit/>
+          </a:bodyPr>
+          <a:lstStyle/>
+          <a:p>
+            <a:pPr algn="l" indent="0" marL="0">
+              <a:lnSpc>
+                <a:spcPts val="5024"/>
+              </a:lnSpc>
+              <a:buNone/>
+            </a:pPr>
+            <a:r>
+              <a:rPr lang="en-US" sz="3589" b="1" dirty="0">
+                <a:solidFill>
+                  <a:srgbClr val="7BE0A0"/>
+                </a:solidFill>
+                <a:latin typeface="Space Grotesk" pitchFamily="34" charset="0"/>
+                <a:ea typeface="Space Grotesk" pitchFamily="34" charset="-122"/>
+                <a:cs typeface="Space Grotesk" pitchFamily="34" charset="-120"/>
+              </a:rPr>
+              <a:t>3 tags</a:t>
+            </a:r>
+            <a:endParaRPr lang="en-US" sz="3589" dirty="0"/>
+          </a:p>
+        </p:txBody>
+      </p:sp>
+      <p:sp>
+        <p:nvSpPr>
+          <p:cNvPr id="18" name="Text 16"/>
+          <p:cNvSpPr/>
+          <p:nvPr/>
+        </p:nvSpPr>
+        <p:spPr>
+          <a:xfrm>
+            <a:off x="4569867" y="4832052"/>
+            <a:ext cx="3143783" cy="516880"/>
+          </a:xfrm>
+          <a:prstGeom prst="rect">
+            <a:avLst/>
+          </a:prstGeom>
+          <a:noFill/>
+          <a:ln/>
+        </p:spPr>
+        <p:txBody>
+          <a:bodyPr wrap="square" lIns="0" tIns="0" rIns="0" bIns="0" rtlCol="0" anchor="t">
+            <a:normAutofit/>
+          </a:bodyPr>
+          <a:lstStyle/>
+          <a:p>
+            <a:pPr algn="l" indent="0" marL="0">
+              <a:lnSpc>
+                <a:spcPts val="1936"/>
+              </a:lnSpc>
+              <a:buNone/>
+            </a:pPr>
+            <a:r>
+              <a:rPr lang="en-US" sz="1383" dirty="0">
+                <a:solidFill>
+                  <a:srgbClr val="BFD3C8"/>
+                </a:solidFill>
+                <a:latin typeface="IBM Plex Sans" pitchFamily="34" charset="0"/>
+                <a:ea typeface="IBM Plex Sans" pitchFamily="34" charset="-122"/>
+                <a:cs typeface="IBM Plex Sans" pitchFamily="34" charset="-120"/>
+              </a:rPr>
+              <a:t>every claim checked against the logs: confirmed, unverified, contradicted</a:t>
+            </a:r>
+            <a:endParaRPr lang="en-US" sz="1383" dirty="0"/>
+          </a:p>
+        </p:txBody>
+      </p:sp>
+      <p:sp>
+        <p:nvSpPr>
+          <p:cNvPr id="19" name="Shape 17"/>
+          <p:cNvSpPr/>
+          <p:nvPr/>
+        </p:nvSpPr>
+        <p:spPr>
+          <a:xfrm>
+            <a:off x="7961809" y="3942854"/>
+            <a:ext cx="3414216" cy="1561654"/>
+          </a:xfrm>
+          <a:prstGeom prst="roundRect">
+            <a:avLst>
+              <a:gd name="adj" fmla="val 6303"/>
+            </a:avLst>
+          </a:prstGeom>
+          <a:solidFill>
+            <a:srgbClr val="18221E"/>
+          </a:solidFill>
+          <a:ln w="6350">
+            <a:solidFill>
+              <a:srgbClr val="2C3D36"/>
+            </a:solidFill>
+            <a:prstDash val="solid"/>
+          </a:ln>
+        </p:spPr>
+      </p:sp>
+      <p:sp>
+        <p:nvSpPr>
+          <p:cNvPr id="20" name="Text 18"/>
+          <p:cNvSpPr/>
+          <p:nvPr/>
+        </p:nvSpPr>
+        <p:spPr>
+          <a:xfrm>
+            <a:off x="8142784" y="4123829"/>
+            <a:ext cx="3143834" cy="657423"/>
+          </a:xfrm>
+          <a:prstGeom prst="rect">
+            <a:avLst/>
+          </a:prstGeom>
+          <a:noFill/>
+          <a:ln/>
+        </p:spPr>
+        <p:txBody>
+          <a:bodyPr wrap="square" lIns="0" tIns="0" rIns="0" bIns="0" rtlCol="0" anchor="t">
+            <a:normAutofit/>
+          </a:bodyPr>
+          <a:lstStyle/>
+          <a:p>
+            <a:pPr algn="l" indent="0" marL="0">
+              <a:lnSpc>
+                <a:spcPts val="5024"/>
+              </a:lnSpc>
+              <a:buNone/>
+            </a:pPr>
+            <a:r>
+              <a:rPr lang="en-US" sz="3589" b="1" dirty="0">
+                <a:solidFill>
+                  <a:srgbClr val="7BE0A0"/>
+                </a:solidFill>
+                <a:latin typeface="Space Grotesk" pitchFamily="34" charset="0"/>
+                <a:ea typeface="Space Grotesk" pitchFamily="34" charset="-122"/>
+                <a:cs typeface="Space Grotesk" pitchFamily="34" charset="-120"/>
+              </a:rPr>
+              <a:t>Next</a:t>
+            </a:r>
+            <a:endParaRPr lang="en-US" sz="3589" dirty="0"/>
+          </a:p>
+        </p:txBody>
+      </p:sp>
+      <p:sp>
+        <p:nvSpPr>
+          <p:cNvPr id="21" name="Text 19"/>
+          <p:cNvSpPr/>
+          <p:nvPr/>
+        </p:nvSpPr>
+        <p:spPr>
+          <a:xfrm>
+            <a:off x="8142784" y="4832052"/>
+            <a:ext cx="3143834" cy="516880"/>
+          </a:xfrm>
+          <a:prstGeom prst="rect">
+            <a:avLst/>
+          </a:prstGeom>
+          <a:noFill/>
+          <a:ln/>
+        </p:spPr>
+        <p:txBody>
+          <a:bodyPr wrap="square" lIns="0" tIns="0" rIns="0" bIns="0" rtlCol="0" anchor="t">
+            <a:normAutofit/>
+          </a:bodyPr>
+          <a:lstStyle/>
+          <a:p>
+            <a:pPr algn="l" indent="0" marL="0">
+              <a:lnSpc>
+                <a:spcPts val="1936"/>
+              </a:lnSpc>
+              <a:buNone/>
+            </a:pPr>
+            <a:r>
+              <a:rPr lang="en-US" sz="1383" dirty="0">
+                <a:solidFill>
+                  <a:srgbClr val="BFD3C8"/>
+                </a:solidFill>
+                <a:latin typeface="IBM Plex Sans" pitchFamily="34" charset="0"/>
+                <a:ea typeface="IBM Plex Sans" pitchFamily="34" charset="-122"/>
+                <a:cs typeface="IBM Plex Sans" pitchFamily="34" charset="-120"/>
+              </a:rPr>
+              <a:t>detection and false-alarm rates at scale, measured during pilots</a:t>
+            </a:r>
+            <a:endParaRPr lang="en-US" sz="1383" dirty="0"/>
+          </a:p>
+        </p:txBody>
+      </p:sp>
+      <p:sp>
+        <p:nvSpPr>
+          <p:cNvPr id="22" name="Text 20"/>
+          <p:cNvSpPr/>
+          <p:nvPr/>
+        </p:nvSpPr>
+        <p:spPr>
+          <a:xfrm>
+            <a:off x="812800" y="5685482"/>
+            <a:ext cx="10883392" cy="181918"/>
+          </a:xfrm>
+          <a:prstGeom prst="rect">
+            <a:avLst/>
+          </a:prstGeom>
+          <a:noFill/>
+          <a:ln/>
+        </p:spPr>
+        <p:txBody>
+          <a:bodyPr wrap="square" lIns="0" tIns="0" rIns="0" bIns="0" rtlCol="0" anchor="t">
+            <a:normAutofit/>
+          </a:bodyPr>
+          <a:lstStyle/>
+          <a:p>
+            <a:pPr algn="l" indent="0" marL="0">
+              <a:lnSpc>
+                <a:spcPts val="1274"/>
+              </a:lnSpc>
+              <a:buNone/>
+            </a:pPr>
+            <a:r>
+              <a:rPr lang="en-US" sz="980" dirty="0">
+                <a:solidFill>
+                  <a:srgbClr val="7BE0A0"/>
+                </a:solidFill>
+                <a:latin typeface="JetBrains Mono" pitchFamily="49" charset="0"/>
+                <a:ea typeface="JetBrains Mono" pitchFamily="49" charset="-122"/>
+                <a:cs typeface="JetBrains Mono" pitchFamily="49" charset="-120"/>
+              </a:rPr>
+              <a:t>ATT&amp;CK T1059 · T1083 · T1005 · T1552.001 · T1078 · ATLAS AML.T0051 · OWASP ASI01, used defensively</a:t>
+            </a:r>
+            <a:endParaRPr lang="en-US" sz="980" dirty="0"/>
+          </a:p>
+        </p:txBody>
+      </p:sp>
+      <p:sp>
+        <p:nvSpPr>
+          <p:cNvPr id="23" name="Text 21"/>
+          <p:cNvSpPr/>
+          <p:nvPr/>
+        </p:nvSpPr>
+        <p:spPr>
+          <a:xfrm>
+            <a:off x="812800" y="6238280"/>
+            <a:ext cx="10883392" cy="238720"/>
+          </a:xfrm>
+          <a:prstGeom prst="rect">
+            <a:avLst/>
+          </a:prstGeom>
+          <a:noFill/>
+          <a:ln/>
+        </p:spPr>
+        <p:txBody>
+          <a:bodyPr wrap="square" lIns="0" tIns="0" rIns="0" bIns="0" rtlCol="0" anchor="t">
+            <a:normAutofit/>
+          </a:bodyPr>
+          <a:lstStyle/>
+          <a:p>
+            <a:pPr algn="l" indent="0" marL="0">
+              <a:lnSpc>
+                <a:spcPts val="1680"/>
+              </a:lnSpc>
+              <a:buNone/>
+            </a:pPr>
+            <a:r>
+              <a:rPr lang="en-US" sz="1200" dirty="0">
+                <a:solidFill>
+                  <a:srgbClr val="9DB3A8"/>
+                </a:solidFill>
+                <a:latin typeface="IBM Plex Sans" pitchFamily="34" charset="0"/>
+                <a:ea typeface="IBM Plex Sans" pitchFamily="34" charset="-122"/>
+                <a:cs typeface="IBM Plex Sans" pitchFamily="34" charset="-120"/>
+              </a:rPr>
+              <a:t>Test scenarios: hand-written event sequences (mirage/fakes.py) · Confessions: live runs on local Ollama models · Synthetic data only</a:t>
+            </a:r>
+            <a:endParaRPr lang="en-US" sz="1200" dirty="0"/>
+          </a:p>
+        </p:txBody>
+      </p:sp>
+    </p:spTree>
+  </p:cSld>
+  <p:clrMapOvr>
+    <a:masterClrMapping/>
+  </p:clrMapOvr>
+</p:sld>
+</file>
+
+<file path=ppt/slides/slide7.xml><?xml version="1.0" encoding="utf-8"?>
+<p:sld xmlns:a="http://schemas.openxmlformats.org/drawingml/2006/main" xmlns:r="http://schemas.openxmlformats.org/officeDocument/2006/relationships" xmlns:p="http://schemas.openxmlformats.org/presentationml/2006/main">
+  <p:cSld name="Slide 7">
     <p:bg>
       <p:bgPr>
         <a:solidFill>
@@ -5987,9 +6803,9 @@
 </p:sld>
 </file>
 
-<file path=ppt/slides/slide7.xml><?xml version="1.0" encoding="utf-8"?>
+<file path=ppt/slides/slide8.xml><?xml version="1.0" encoding="utf-8"?>
 <p:sld xmlns:a="http://schemas.openxmlformats.org/drawingml/2006/main" xmlns:r="http://schemas.openxmlformats.org/officeDocument/2006/relationships" xmlns:p="http://schemas.openxmlformats.org/presentationml/2006/main">
-  <p:cSld name="Slide 7">
+  <p:cSld name="Slide 8">
     <p:bg>
       <p:bgPr>
         <a:solidFill>
@@ -6692,10 +7508,10 @@
         <a:srgbClr val="BFD3C8"/>
       </a:accent4>
       <a:accent5>
-        <a:srgbClr val="5F6B65"/>
+        <a:srgbClr val="9DB3A8"/>
       </a:accent5>
       <a:accent6>
-        <a:srgbClr val="9DB3A8"/>
+        <a:srgbClr val="5F6B65"/>
       </a:accent6>
       <a:hlink>
         <a:srgbClr val="0563C1"/>

</xml_diff>

<commit_message>
Revert the service-account pre-emptive swap; live numbers in defense sheet, README, demo script, handoff and pitch slide 6
The rule swapped on the legitimate backup job (same svc_backup account): a false alarm, and the
backup copied the fakes. The 10 live runs never needed it (a mine caught the agent every time), so
their numbers stand. False-positive run after the revert: 8.3 min of normal activity (112 commands,
4 backup runs), 0 swaps, 0 incidents.

Co-Authored-By: Claude Opus 5.5 <noreply@anthropic.com>
</commit_message>
<xml_diff>
--- a/docs/pitch/MIRAGE_pitch_5min.pptx
+++ b/docs/pitch/MIRAGE_pitch_5min.pptx
@@ -5025,7 +5025,7 @@
                 <a:ea typeface="Space Grotesk" pitchFamily="34" charset="-122"/>
                 <a:cs typeface="Space Grotesk" pitchFamily="34" charset="-120"/>
               </a:rPr>
-              <a:t>Logic validated on test scenarios. Confessions measured live.</a:t>
+              <a:t>Measured live: a real AI agent attacked our test server 10 times.</a:t>
             </a:r>
             <a:endParaRPr lang="en-US" sz="3116" dirty="0"/>
           </a:p>
@@ -5096,7 +5096,7 @@
                 <a:ea typeface="Space Grotesk" pitchFamily="34" charset="-122"/>
                 <a:cs typeface="Space Grotesk" pitchFamily="34" charset="-120"/>
               </a:rPr>
-              <a:t>4 / 4</a:t>
+              <a:t>10 / 10</a:t>
             </a:r>
             <a:endParaRPr lang="en-US" sz="2936" dirty="0"/>
           </a:p>
@@ -5140,7 +5140,7 @@
                 <a:ea typeface="IBM Plex Sans" pitchFamily="34" charset="-122"/>
                 <a:cs typeface="IBM Plex Sans" pitchFamily="34" charset="-120"/>
               </a:rPr>
-              <a:t>test scenarios detected and labelled correctly: AI agent, guided AI, script, human (logic test)</a:t>
+              <a:t>live AI attacks caught by a trap, with 0 real files lost (qwen3.5:35b, local)</a:t>
             </a:r>
             <a:endParaRPr lang="en-US" sz="1155" dirty="0"/>
           </a:p>
@@ -5211,7 +5211,7 @@
                 <a:ea typeface="Space Grotesk" pitchFamily="34" charset="-122"/>
                 <a:cs typeface="Space Grotesk" pitchFamily="34" charset="-120"/>
               </a:rPr>
-              <a:t>7 / 10</a:t>
+              <a:t>2.2 ms</a:t>
             </a:r>
             <a:endParaRPr lang="en-US" sz="3589" dirty="0"/>
           </a:p>
@@ -5255,7 +5255,7 @@
                 <a:ea typeface="IBM Plex Sans" pitchFamily="34" charset="-122"/>
                 <a:cs typeface="IBM Plex Sans" pitchFamily="34" charset="-120"/>
               </a:rPr>
-              <a:t>live AI runs that confessed their mission (qwen3.5:35b, local)</a:t>
+              <a:t>median swap time read from the guard over the 10 runs (0.4–12 ms)</a:t>
             </a:r>
             <a:endParaRPr lang="en-US" sz="1383" dirty="0"/>
           </a:p>
@@ -5326,7 +5326,7 @@
                 <a:ea typeface="Space Grotesk" pitchFamily="34" charset="-122"/>
                 <a:cs typeface="Space Grotesk" pitchFamily="34" charset="-120"/>
               </a:rPr>
-              <a:t>2 / 10</a:t>
+              <a:t>10 / 10</a:t>
             </a:r>
             <a:endParaRPr lang="en-US" sz="3589" dirty="0"/>
           </a:p>
@@ -5370,7 +5370,7 @@
                 <a:ea typeface="IBM Plex Sans" pitchFamily="34" charset="-122"/>
                 <a:cs typeface="IBM Plex Sans" pitchFamily="34" charset="-120"/>
               </a:rPr>
-              <a:t>for the smaller model (qwen2.5:7b): careful models resist</a:t>
+              <a:t>live runs where the AI confessed its mission (smaller qwen2.5:7b: 2/10 earlier)</a:t>
             </a:r>
             <a:endParaRPr lang="en-US" sz="1383" dirty="0"/>
           </a:p>
@@ -5441,7 +5441,7 @@
                 <a:ea typeface="Space Grotesk" pitchFamily="34" charset="-122"/>
                 <a:cs typeface="Space Grotesk" pitchFamily="34" charset="-120"/>
               </a:rPr>
-              <a:t>Live</a:t>
+              <a:t>0</a:t>
             </a:r>
             <a:endParaRPr lang="en-US" sz="2936" dirty="0"/>
           </a:p>
@@ -5485,7 +5485,7 @@
                 <a:ea typeface="IBM Plex Sans" pitchFamily="34" charset="-122"/>
                 <a:cs typeface="IBM Plex Sans" pitchFamily="34" charset="-120"/>
               </a:rPr>
-              <a:t>swap time read from the guard on the incident card, in the demo you just saw (target: under 1 s)</a:t>
+              <a:t>false alarms in 8 min of live normal work: staff + 4 backup runs touching the crown jewels</a:t>
             </a:r>
             <a:endParaRPr lang="en-US" sz="1133" dirty="0"/>
           </a:p>
@@ -5715,7 +5715,7 @@
                 <a:ea typeface="IBM Plex Sans" pitchFamily="34" charset="-122"/>
                 <a:cs typeface="IBM Plex Sans" pitchFamily="34" charset="-120"/>
               </a:rPr>
-              <a:t>detection and false-alarm rates at scale, measured during pilots</a:t>
+              <a:t>false-alarm rate at scale and more attacker models, measured during pilots</a:t>
             </a:r>
             <a:endParaRPr lang="en-US" sz="1383" dirty="0"/>
           </a:p>
@@ -5803,7 +5803,7 @@
                 <a:ea typeface="IBM Plex Sans" pitchFamily="34" charset="-122"/>
                 <a:cs typeface="IBM Plex Sans" pitchFamily="34" charset="-120"/>
               </a:rPr>
-              <a:t>Test scenarios: hand-written event sequences (mirage/fakes.py) · Confessions: live runs on local Ollama models · Synthetic data only</a:t>
+              <a:t>Live runs: local Ollama model, clean reset before each run (docs/live_bench_results.csv) · Synthetic data only</a:t>
             </a:r>
             <a:endParaRPr lang="en-US" sz="1200" dirty="0"/>
           </a:p>

</xml_diff>

<commit_message>
pitch: speaker notes in the 5-min deck = docs/pitch/pitch_script.md (updated script)
Co-Authored-By: Claude Opus 5.5 <noreply@anthropic.com>
</commit_message>
<xml_diff>
--- a/docs/pitch/MIRAGE_pitch_5min.pptx
+++ b/docs/pitch/MIRAGE_pitch_5min.pptx
@@ -509,9 +509,32 @@
           <a:p>
             <a:r>
               <a:rPr lang="en-US" dirty="0"/>
-              <a:t>ANA · [0:00–0:15] This AI hacker just stole 400 patient records. (pause) All of them are fake. And it told us who sent it. We're Team 7, and this is MIRAGE.</a:t>
-            </a:r>
-            <a:endParaRPr lang="en-US" dirty="0"/>
+              <a:t>ANA · [0:00–0:15]</a:t>
+            </a:r>
+          </a:p>
+          <a:p>
+            <a:r>
+              <a:rPr lang="en-US" dirty="0"/>
+              <a:t>This AI hacker just broke into a clinic and stole patient records and passwords.</a:t>
+            </a:r>
+          </a:p>
+          <a:p>
+            <a:r>
+              <a:rPr lang="en-US" dirty="0"/>
+              <a:t>[Pause two seconds.]</a:t>
+            </a:r>
+          </a:p>
+          <a:p>
+            <a:r>
+              <a:rPr lang="en-US" dirty="0"/>
+              <a:t>All of them were fake. And it told us what it was looking for.</a:t>
+            </a:r>
+          </a:p>
+          <a:p>
+            <a:r>
+              <a:rPr lang="en-US" dirty="0"/>
+              <a:t>We're Team 7, and this is MIRAGE.</a:t>
+            </a:r>
           </a:p>
         </p:txBody>
       </p:sp>
@@ -597,9 +620,44 @@
           <a:p>
             <a:r>
               <a:rPr lang="en-US" dirty="0"/>
-              <a:t>ANA · [0:15–0:50] Attackers no longer need to encrypt to get paid. In more than three out of four ransomware attacks, they steal data first, and no backup can bring it back. Healthcare is hit hardest: in 2023, the health sector reported 309 significant cyber incidents in the EU, more than any other critical sector. Clinics hold the data attackers want most. And attackers are becoming AI agents. In a 2025 campaign, an AI did 80 to 90% of the work, at several actions per second. By the time an analyst reads the first alert, the files are gone. So we asked: what if whatever they steal is worthless? Thomas.</a:t>
-            </a:r>
-            <a:endParaRPr lang="en-US" dirty="0"/>
+              <a:t>ANA · [0:15–0:50]</a:t>
+            </a:r>
+          </a:p>
+          <a:p>
+            <a:r>
+              <a:rPr lang="en-US" dirty="0"/>
+              <a:t>Hackers no longer need to encrypt your systems: they steal the data.</a:t>
+            </a:r>
+          </a:p>
+          <a:p>
+            <a:r>
+              <a:rPr lang="en-US" dirty="0"/>
+              <a:t>In more than three out of four ransomware attacks, data is stolen, and no backup can undo a leak.</a:t>
+            </a:r>
+          </a:p>
+          <a:p>
+            <a:r>
+              <a:rPr lang="en-US" dirty="0"/>
+              <a:t>Healthcare is hit hardest: in 2023, the EU health sector reported 309 significant cyber incidents, more than any other critical sector.</a:t>
+            </a:r>
+          </a:p>
+          <a:p>
+            <a:r>
+              <a:rPr lang="en-US" dirty="0"/>
+              <a:t>And attackers are becoming AI agents. In a 2025 campaign, AI ran 80 to 90% of the operations, at several actions per second.</a:t>
+            </a:r>
+          </a:p>
+          <a:p>
+            <a:r>
+              <a:rPr lang="en-US" dirty="0"/>
+              <a:t>By the time an analyst reacts, the files are gone.</a:t>
+            </a:r>
+          </a:p>
+          <a:p>
+            <a:r>
+              <a:rPr lang="en-US" dirty="0"/>
+              <a:t>So what if whatever they steal is worthless? Thomas.</a:t>
+            </a:r>
           </a:p>
         </p:txBody>
       </p:sp>
@@ -685,9 +743,38 @@
           <a:p>
             <a:r>
               <a:rPr lang="en-US" dirty="0"/>
-              <a:t>THOMAS · [0:50–1:25] Before any attack, our AI reads the clinic's file server and finds the crown jewels: patient records, contracts, API keys. For each one, it writes a fake twin: same name, same format, invented content. Then plain code checks every fake: if a single real value slipped in, the fake is rejected. Each fake carries a unique beacon, like an API key that exists nowhere else. And we hide a few traps: files no employee ever needs, like a passwords backup. Then MIRAGE waits. Leon.</a:t>
-            </a:r>
-            <a:endParaRPr lang="en-US" dirty="0"/>
+              <a:t>THOMAS · [0:50–1:25]</a:t>
+            </a:r>
+          </a:p>
+          <a:p>
+            <a:r>
+              <a:rPr lang="en-US" dirty="0"/>
+              <a:t>Before any attack, MIRAGE finds the clinic's most sensitive files: patient records, contracts, credentials.</a:t>
+            </a:r>
+          </a:p>
+          <a:p>
+            <a:r>
+              <a:rPr lang="en-US" dirty="0"/>
+              <a:t>For each one, it writes a realistic fake twin: same name, same format, invented content. A local AI can draft them, and code checks that no real value slips into a fake.</a:t>
+            </a:r>
+          </a:p>
+          <a:p>
+            <a:r>
+              <a:rPr lang="en-US" dirty="0"/>
+              <a:t>Then we hide traps, files no employee ever needs, like a passwords backup. We call them mines.</a:t>
+            </a:r>
+          </a:p>
+          <a:p>
+            <a:r>
+              <a:rPr lang="en-US" dirty="0"/>
+              <a:t>When an intruder opens one, the real files move to a locked vault and the fakes take their place.</a:t>
+            </a:r>
+          </a:p>
+          <a:p>
+            <a:r>
+              <a:rPr lang="en-US" dirty="0"/>
+              <a:t>And if the intruder is an AI, the mine makes it reveal its mission. Leon.</a:t>
+            </a:r>
           </a:p>
         </p:txBody>
       </p:sp>
@@ -773,9 +860,26 @@
           <a:p>
             <a:r>
               <a:rPr lang="en-US" dirty="0"/>
-              <a:t>LEON · [1:25–1:45] On the server, a small guard watches the traps. No AI inside: the critical second must be predictable. When a trap opens, it moves the real files into a locked vault and puts the fakes in their place. It logs every command, and if anyone kills it, the console raises an alarm. Gaia built the attacker. Let's watch it fail.</a:t>
-            </a:r>
-            <a:endParaRPr lang="en-US" dirty="0"/>
+              <a:t>LEON · [1:25–1:45]</a:t>
+            </a:r>
+          </a:p>
+          <a:p>
+            <a:r>
+              <a:rPr lang="en-US" dirty="0"/>
+              <a:t>Preparation happens in advance. Plain code acts in the critical second.</a:t>
+            </a:r>
+          </a:p>
+          <a:p>
+            <a:r>
+              <a:rPr lang="en-US" dirty="0"/>
+              <a:t>On the server, a small guard with no AI watches the mines. When one opens, it swaps the files and logs every command. If anyone kills the guard, the console raises an alarm.</a:t>
+            </a:r>
+          </a:p>
+          <a:p>
+            <a:r>
+              <a:rPr lang="en-US" dirty="0"/>
+              <a:t>Everything runs locally, with no external AI API. Gaia.</a:t>
+            </a:r>
           </a:p>
         </p:txBody>
       </p:sp>
@@ -861,9 +965,86 @@
           <a:p>
             <a:r>
               <a:rPr lang="en-US" dirty="0"/>
-              <a:t>GAIA · [1:45–1:55, before the live demo; use it instead of the demo if the live run fails] This is the analyst's console after a real run of our AI attacker. No real files lost: the agent took one file, and it was a fake. The guard swapped three files in 2.7 milliseconds. The agent followed our note and made four claims; we checked each against the logs, and its claim to be authorized is contradicted. The summary and the NIS2 warning are AI drafts, not sent until the analyst approves. Now let's watch it live.</a:t>
-            </a:r>
-            <a:endParaRPr lang="en-US" dirty="0"/>
+              <a:t>GAIA · [1:45–3:05]</a:t>
+            </a:r>
+          </a:p>
+          <a:p>
+            <a:r>
+              <a:rPr lang="en-US" dirty="0"/>
+              <a:t>[On the screenshot slide, about 10 seconds.]</a:t>
+            </a:r>
+          </a:p>
+          <a:p>
+            <a:r>
+              <a:rPr lang="en-US" dirty="0"/>
+              <a:t>This is the analyst's console after one of our live runs: no real files lost, the swap timed by the guard, every claim checked. Let's watch it live.</a:t>
+            </a:r>
+          </a:p>
+          <a:p>
+            <a:r>
+              <a:rPr lang="en-US" dirty="0"/>
+              <a:t>[Switch to the live demo.]</a:t>
+            </a:r>
+          </a:p>
+          <a:p>
+            <a:r>
+              <a:rPr lang="en-US" dirty="0"/>
+              <a:t>Welcome to Lumen Health, our fictional clinic group, synthetic data only.</a:t>
+            </a:r>
+          </a:p>
+          <a:p>
+            <a:r>
+              <a:rPr lang="en-US" dirty="0"/>
+              <a:t>On the left, an AI agent with a stolen password explores the file server. On the right, MIRAGE.</a:t>
+            </a:r>
+          </a:p>
+          <a:p>
+            <a:r>
+              <a:rPr lang="en-US" dirty="0"/>
+              <a:t>[The agent opens a mine.]</a:t>
+            </a:r>
+          </a:p>
+          <a:p>
+            <a:r>
+              <a:rPr lang="en-US" dirty="0"/>
+              <a:t>That's our trap. The guard swaps the files, and here's the time it measured. [Point to the swap time.]</a:t>
+            </a:r>
+          </a:p>
+          <a:p>
+            <a:r>
+              <a:rPr lang="en-US" dirty="0"/>
+              <a:t>The agent keeps going and grabs what it came for. Here's what it got… and here's the real file, safe in the vault.</a:t>
+            </a:r>
+          </a:p>
+          <a:p>
+            <a:r>
+              <a:rPr lang="en-US" dirty="0"/>
+              <a:t>[Show the claims panel.]</a:t>
+            </a:r>
+          </a:p>
+          <a:p>
+            <a:r>
+              <a:rPr lang="en-US" dirty="0"/>
+              <a:t>The mine also got the agent to reveal its mission, and MIRAGE checks each claim against the logs. [Read one tag aloud.]</a:t>
+            </a:r>
+          </a:p>
+          <a:p>
+            <a:r>
+              <a:rPr lang="en-US" dirty="0"/>
+              <a:t>The analyst sees all of this on one card, and decides: Contain, Keep watching, Dismiss or Restore.</a:t>
+            </a:r>
+          </a:p>
+          <a:p>
+            <a:r>
+              <a:rPr lang="en-US" dirty="0"/>
+              <a:t>If the agent ignores the note: "This one was careful. It still only got fakes."</a:t>
+            </a:r>
+          </a:p>
+          <a:p>
+            <a:r>
+              <a:rPr lang="en-US" dirty="0"/>
+              <a:t>If the live run fails: go back to the screenshot slide and walk through it.</a:t>
+            </a:r>
           </a:p>
         </p:txBody>
       </p:sp>
@@ -949,9 +1130,44 @@
           <a:p>
             <a:r>
               <a:rPr lang="en-US" dirty="0"/>
-              <a:t>GAIA · [3:05–3:30] We tested the logic on four scenarios: an AI agent, a guided AI, a script and a human. All four were detected and labelled correctly. Those are hand-written test sequences, not real attacks, and we say so. What we measured live: the larger local model confessed its mission 7 times out of 10, the smaller one 2 out of 10. Measuring detection and false alarms at scale is the first thing we'd do in a pilot. Thomas. — THOMAS · [3:30–3:50] A confession can lie, so each claim is checked against the logs: confirmed, unverified or contradicted. Claim an authorized pentest while using a stolen password, and the logs contradict it. Our trap note is prompt injection, ATLAS AML.T0051, turned against the attacker. And the AI-drafted NIS2 early warning stays a draft until a human approves it. Leon.</a:t>
-            </a:r>
-            <a:endParaRPr lang="en-US" dirty="0"/>
+              <a:t>GAIA · [3:05–3:30]</a:t>
+            </a:r>
+          </a:p>
+          <a:p>
+            <a:r>
+              <a:rPr lang="en-US" dirty="0"/>
+              <a:t>We ran it 10 times live: 0 real files lost in all 10, with a median swap of 2.2 milliseconds.</a:t>
+            </a:r>
+          </a:p>
+          <a:p>
+            <a:r>
+              <a:rPr lang="en-US" dirty="0"/>
+              <a:t>Then 8 minutes of normal work, staff plus the backup job copying the same sensitive files: zero false alarms.</a:t>
+            </a:r>
+          </a:p>
+          <a:p>
+            <a:r>
+              <a:rPr lang="en-US" dirty="0"/>
+              <a:t>The agent revealed its mission in all 10 runs. But a smaller model did it only twice out of ten in an earlier test, so protection never depends on the confession. Thomas.</a:t>
+            </a:r>
+          </a:p>
+          <a:p>
+            <a:r>
+              <a:rPr lang="en-US" dirty="0"/>
+              <a:t>THOMAS · [3:30–3:50]</a:t>
+            </a:r>
+          </a:p>
+          <a:p>
+            <a:r>
+              <a:rPr lang="en-US" dirty="0"/>
+              <a:t>A confession can lie, so we never trust it blindly. Each claim is checked against the logs: confirmed, unverified or contradicted.</a:t>
+            </a:r>
+          </a:p>
+          <a:p>
+            <a:r>
+              <a:rPr lang="en-US" dirty="0"/>
+              <a:t>Our AI drafts the incident summary and the NIS2 early warning, but they stay drafts. The decision always belongs to a human. Leon.</a:t>
+            </a:r>
           </a:p>
         </p:txBody>
       </p:sp>
@@ -1037,9 +1253,20 @@
           <a:p>
             <a:r>
               <a:rPr lang="en-US" dirty="0"/>
-              <a:t>LEON · [3:50–4:20] The swap is the only automatic action, and it deletes nothing. The intruder label triggers nothing, so a wrong label costs nothing. Everything else waits for the analyst: Contain the account, Keep watching the intruder in the decoys, Dismiss a false alarm, or Restore the real files in one click. Our honest limits: files read before a trap is touched are exposed, and we flag them as critical. A careful AI that never opens a trap is not caught by the swap. Ana.</a:t>
-            </a:r>
-            <a:endParaRPr lang="en-US" dirty="0"/>
+              <a:t>LEON · [3:50–4:20]</a:t>
+            </a:r>
+          </a:p>
+          <a:p>
+            <a:r>
+              <a:rPr lang="en-US" dirty="0"/>
+              <a:t>The swap is the only automatic action, and it deletes nothing. The intruder label triggers nothing, so a wrong label costs nothing. Everything else waits for the analyst.</a:t>
+            </a:r>
+          </a:p>
+          <a:p>
+            <a:r>
+              <a:rPr lang="en-US" dirty="0"/>
+              <a:t>And our honest limit: a file read before any mine is opened is exposed. If the intruder then hits a mine, the card flags that file as exposed. If it never touches a mine, the swap can't help. That happened in our very first live run, so we made the mines more tempting, and the next 10 runs all hit a mine first. Ana.</a:t>
+            </a:r>
           </a:p>
         </p:txBody>
       </p:sp>
@@ -1125,9 +1352,44 @@
           <a:p>
             <a:r>
               <a:rPr lang="en-US" dirty="0"/>
-              <a:t>ANA · [4:20–5:00] Deception is a 2.7 billion dollar market, and its pioneers were bought by SentinelOne, Proofpoint and Zscaler. They all detect intruders. None of those we reviewed protects the real files. Our customers are clinics and the medical sector: private clinics, medical labs and imaging centres. Their breaches are the most expensive of any sector, their patient data sits on shared drives, and NIS2 now covers them. We sell directly and through the providers that already run their SOC. Next: pilots with two or three clinics, and cloud storage like SharePoint and S3. We're Ana, Thomas, Leon and Gaia. Whoever breaks in steals only fakes. And if it's an AI, it tells us who sent it. Thank you.</a:t>
-            </a:r>
-            <a:endParaRPr lang="en-US" dirty="0"/>
+              <a:t>ANA · [4:20–5:00]</a:t>
+            </a:r>
+          </a:p>
+          <a:p>
+            <a:r>
+              <a:rPr lang="en-US" dirty="0"/>
+              <a:t>Deception is a 2.7-billion-dollar market, and its pioneers were bought by SentinelOne, Proofpoint and Zscaler.</a:t>
+            </a:r>
+          </a:p>
+          <a:p>
+            <a:r>
+              <a:rPr lang="en-US" dirty="0"/>
+              <a:t>They detect the intruder, but the real files stay exposed. MIRAGE takes them out of reach.</a:t>
+            </a:r>
+          </a:p>
+          <a:p>
+            <a:r>
+              <a:rPr lang="en-US" dirty="0"/>
+              <a:t>Our first customers: private clinics, medical labs and imaging centres, starting in France. Our working price is around 6,000 euros per clinic per year, sold directly and through their security providers.</a:t>
+            </a:r>
+          </a:p>
+          <a:p>
+            <a:r>
+              <a:rPr lang="en-US" dirty="0"/>
+              <a:t>Next: pilots with two or three clinics.</a:t>
+            </a:r>
+          </a:p>
+          <a:p>
+            <a:r>
+              <a:rPr lang="en-US" dirty="0"/>
+              <a:t>Cybersecurity shouldn't only tell you your data is being stolen. It should change what the attacker can steal.</a:t>
+            </a:r>
+          </a:p>
+          <a:p>
+            <a:r>
+              <a:rPr lang="en-US" dirty="0"/>
+              <a:t>MIRAGE: protect the real, show them the fake. Thank you.</a:t>
+            </a:r>
           </a:p>
         </p:txBody>
       </p:sp>

</xml_diff>